<commit_message>
Sjöskolan v41: figures, content fixes and Trefaslabbet (pre-review)
Co-Authored-By: Claude Opus 5.5 <noreply@anthropic.com>
Claude-Session: https://claude.ai/code/session_011V9KjBb53XrDm23Dw58SH3
</commit_message>
<xml_diff>
--- a/sjoskolan/vecka-41/aktuell/v41_01_Trefassystemets_grunder_elev.pptx
+++ b/sjoskolan/vecka-41/aktuell/v41_01_Trefassystemets_grunder_elev.pptx
@@ -6005,7 +6005,7 @@
         <p:spPr>
           <a:xfrm xmlns:a="http://schemas.openxmlformats.org/drawingml/2006/main">
             <a:off x="762000" y="2533650"/>
-            <a:ext cx="7620000" cy="2286000"/>
+            <a:ext cx="3886200" cy="2606040"/>
           </a:xfrm>
           <a:prstGeom xmlns:a="http://schemas.openxmlformats.org/drawingml/2006/main" prst="rect">
             <a:avLst/>
@@ -6162,6 +6162,30 @@
           </a:p>
         </p:txBody>
       </p:sp>
+      <p:pic xmlns:a="http://schemas.openxmlformats.org/drawingml/2006/main" xmlns:r="http://schemas.openxmlformats.org/officeDocument/2006/relationships">
+        <p:nvPicPr>
+          <p:cNvPr id="9" name="Figur: Tre fasvisare L1, L2 och L3 med okänd vi" descr="Tre fasvisare L1, L2 och L3 med okänd vinkel mellan L1 och L2"/>
+          <p:cNvPicPr>
+            <a:picLocks noChangeAspect="1"/>
+          </p:cNvPicPr>
+          <p:nvPr/>
+        </p:nvPicPr>
+        <p:blipFill>
+          <a:blip r:embed="rId3"/>
+          <a:stretch>
+            <a:fillRect/>
+          </a:stretch>
+        </p:blipFill>
+        <p:spPr>
+          <a:xfrm>
+            <a:off x="4846320" y="2331720"/>
+            <a:ext cx="3931920" cy="2740984"/>
+          </a:xfrm>
+          <a:prstGeom prst="rect">
+            <a:avLst/>
+          </a:prstGeom>
+        </p:spPr>
+      </p:pic>
     </p:spTree>
     <p:extLst>
       <p:ext uri="{BB962C8B-B14F-4D97-AF65-F5344CB8AC3E}">
@@ -6729,7 +6753,7 @@
         <p:spPr>
           <a:xfrm xmlns:a="http://schemas.openxmlformats.org/drawingml/2006/main">
             <a:off x="762000" y="2533650"/>
-            <a:ext cx="7620000" cy="2286000"/>
+            <a:ext cx="3886200" cy="2606040"/>
           </a:xfrm>
           <a:prstGeom xmlns:a="http://schemas.openxmlformats.org/drawingml/2006/main" prst="rect">
             <a:avLst/>
@@ -6765,7 +6789,7 @@
                 <a:ea typeface="Calibri"/>
                 <a:cs typeface="Calibri"/>
               </a:rPr>
-              <a:t>Ett symmetriskt trefassystem har f = 50 Hz. Hur många ms motsvarar 120°?</a:t>
+              <a:t>Ett symmetriskt trefassystem har f = 50 Hz. Hur många ms motsvarar 120°?</a:t>
             </a:r>
           </a:p>
         </p:txBody>
@@ -6886,6 +6910,30 @@
           </a:p>
         </p:txBody>
       </p:sp>
+      <p:pic xmlns:a="http://schemas.openxmlformats.org/drawingml/2006/main" xmlns:r="http://schemas.openxmlformats.org/officeDocument/2006/relationships">
+        <p:nvPicPr>
+          <p:cNvPr id="9" name="Figur: Tre sinusspänningar vid 50 Hz med okänd " descr="Tre sinusspänningar vid 50 Hz med okänd tidsförskjutning mellan L1 och L2"/>
+          <p:cNvPicPr>
+            <a:picLocks noChangeAspect="1"/>
+          </p:cNvPicPr>
+          <p:nvPr/>
+        </p:nvPicPr>
+        <p:blipFill>
+          <a:blip r:embed="rId3"/>
+          <a:stretch>
+            <a:fillRect/>
+          </a:stretch>
+        </p:blipFill>
+        <p:spPr>
+          <a:xfrm>
+            <a:off x="4846320" y="2331720"/>
+            <a:ext cx="3931920" cy="2740984"/>
+          </a:xfrm>
+          <a:prstGeom prst="rect">
+            <a:avLst/>
+          </a:prstGeom>
+        </p:spPr>
+      </p:pic>
     </p:spTree>
     <p:extLst>
       <p:ext uri="{BB962C8B-B14F-4D97-AF65-F5344CB8AC3E}">
@@ -6991,7 +7039,7 @@
       </p:sp>
       <p:sp>
         <p:nvSpPr>
-          <p:cNvPr id="10" name="Uꜰ = Uᴸ/√3">
+          <p:cNvPr id="10" name="UF = UL/√3">
             <a:extLst xmlns:a="http://schemas.openxmlformats.org/drawingml/2006/main">
               <a:ext uri="{FF2B5EF4-FFF2-40B4-BE49-F238E27FC236}">
                 <a16:creationId xmlns:a16="http://schemas.microsoft.com/office/drawing/2014/main" id="{54641C4D-4AE5-412D-9C65-60DA13A2CE4C}"/>
@@ -7041,14 +7089,58 @@
                 <a:ea typeface="Calibri"/>
                 <a:cs typeface="Calibri"/>
               </a:rPr>
-              <a:t>Uꜰ = Uᴸ/√3</a:t>
-            </a:r>
-          </a:p>
-        </p:txBody>
-      </p:sp>
-      <p:sp>
-        <p:nvSpPr>
-          <p:cNvPr id="11" name="Uᴸ är linje- eller huvudspänning mellan två faser. Uꜰ är spänning">
+              <a:t>U</a:t>
+            </a:r>
+            <a:r>
+              <a:rPr sz="2400" b="1" baseline="-25000">
+                <a:solidFill>
+                  <a:srgbClr val="064F91"/>
+                </a:solidFill>
+                <a:latin typeface="Calibri"/>
+                <a:ea typeface="Calibri"/>
+                <a:cs typeface="Calibri"/>
+              </a:rPr>
+              <a:t>F</a:t>
+            </a:r>
+            <a:r>
+              <a:rPr sz="2400" b="1">
+                <a:solidFill>
+                  <a:srgbClr val="064F91"/>
+                </a:solidFill>
+                <a:latin typeface="Calibri"/>
+                <a:ea typeface="Calibri"/>
+                <a:cs typeface="Calibri"/>
+              </a:rPr>
+              <a:t> = U</a:t>
+            </a:r>
+            <a:r>
+              <a:rPr sz="2400" b="1" baseline="-25000">
+                <a:solidFill>
+                  <a:srgbClr val="064F91"/>
+                </a:solidFill>
+                <a:latin typeface="Calibri"/>
+                <a:ea typeface="Calibri"/>
+                <a:cs typeface="Calibri"/>
+              </a:rPr>
+              <a:t>L</a:t>
+            </a:r>
+            <a:r>
+              <a:rPr sz="2400" b="1">
+                <a:solidFill>
+                  <a:srgbClr val="064F91"/>
+                </a:solidFill>
+                <a:latin typeface="Calibri"/>
+                <a:ea typeface="Calibri"/>
+                <a:cs typeface="Calibri"/>
+              </a:rPr>
+              <a:t>/√3</a:t>
+            </a:r>
+          </a:p>
+        </p:txBody>
+      </p:sp>
+      <p:sp>
+        <p:nvSpPr>
+          <p:cNvPr id="11" name="UL är linje- eller huvudspänning mellan två faser. UF är spänning">
             <a:extLst xmlns:a="http://schemas.openxmlformats.org/drawingml/2006/main">
               <a:ext uri="{FF2B5EF4-FFF2-40B4-BE49-F238E27FC236}">
                 <a16:creationId xmlns:a16="http://schemas.microsoft.com/office/drawing/2014/main" id="{61879C50-7F9A-4500-90E3-C7FC821B0FA3}"/>
@@ -7098,14 +7190,58 @@
                 <a:ea typeface="Calibri"/>
                 <a:cs typeface="Calibri"/>
               </a:rPr>
-              <a:t>Uᴸ är linje- eller huvudspänning mellan två faser. Uꜰ är spänning mellan fas och källans neutralpunkt.</a:t>
-            </a:r>
-          </a:p>
-        </p:txBody>
-      </p:sp>
-      <p:sp>
-        <p:nvSpPr>
-          <p:cNvPr id="12" name="Förutsättningar: Symmetrisk trefaskälla med Uᴸ = 400 V. √3 ≈ 1,73">
+              <a:t>U</a:t>
+            </a:r>
+            <a:r>
+              <a:rPr sz="2100" b="0" baseline="-25000">
+                <a:solidFill>
+                  <a:srgbClr val="111111"/>
+                </a:solidFill>
+                <a:latin typeface="Calibri"/>
+                <a:ea typeface="Calibri"/>
+                <a:cs typeface="Calibri"/>
+              </a:rPr>
+              <a:t>L</a:t>
+            </a:r>
+            <a:r>
+              <a:rPr sz="2100" b="0">
+                <a:solidFill>
+                  <a:srgbClr val="111111"/>
+                </a:solidFill>
+                <a:latin typeface="Calibri"/>
+                <a:ea typeface="Calibri"/>
+                <a:cs typeface="Calibri"/>
+              </a:rPr>
+              <a:t> är linje- eller huvudspänning mellan två faser. U</a:t>
+            </a:r>
+            <a:r>
+              <a:rPr sz="2100" b="0" baseline="-25000">
+                <a:solidFill>
+                  <a:srgbClr val="111111"/>
+                </a:solidFill>
+                <a:latin typeface="Calibri"/>
+                <a:ea typeface="Calibri"/>
+                <a:cs typeface="Calibri"/>
+              </a:rPr>
+              <a:t>F</a:t>
+            </a:r>
+            <a:r>
+              <a:rPr sz="2100" b="0">
+                <a:solidFill>
+                  <a:srgbClr val="111111"/>
+                </a:solidFill>
+                <a:latin typeface="Calibri"/>
+                <a:ea typeface="Calibri"/>
+                <a:cs typeface="Calibri"/>
+              </a:rPr>
+              <a:t> är spänning mellan fas och källans neutralpunkt.</a:t>
+            </a:r>
+          </a:p>
+        </p:txBody>
+      </p:sp>
+      <p:sp>
+        <p:nvSpPr>
+          <p:cNvPr id="12" name="Förutsättningar: Symmetrisk trefaskälla med UL = 400 V. √3 ≈ 1,73">
             <a:extLst xmlns:a="http://schemas.openxmlformats.org/drawingml/2006/main">
               <a:ext uri="{FF2B5EF4-FFF2-40B4-BE49-F238E27FC236}">
                 <a16:creationId xmlns:a16="http://schemas.microsoft.com/office/drawing/2014/main" id="{68C1E9D0-B401-43EF-81DC-BC715E92D5BC}"/>
@@ -7155,7 +7291,29 @@
                 <a:ea typeface="Calibri"/>
                 <a:cs typeface="Calibri"/>
               </a:rPr>
-              <a:t>Förutsättningar: Symmetrisk trefaskälla med Uᴸ = 400 V. √3 ≈ 1,732.</a:t>
+              <a:t>Förutsättningar: Symmetrisk trefaskälla med U</a:t>
+            </a:r>
+            <a:r>
+              <a:rPr sz="2025" b="0" baseline="-25000">
+                <a:solidFill>
+                  <a:srgbClr val="111111"/>
+                </a:solidFill>
+                <a:latin typeface="Calibri"/>
+                <a:ea typeface="Calibri"/>
+                <a:cs typeface="Calibri"/>
+              </a:rPr>
+              <a:t>L</a:t>
+            </a:r>
+            <a:r>
+              <a:rPr sz="2025" b="0">
+                <a:solidFill>
+                  <a:srgbClr val="111111"/>
+                </a:solidFill>
+                <a:latin typeface="Calibri"/>
+                <a:ea typeface="Calibri"/>
+                <a:cs typeface="Calibri"/>
+              </a:rPr>
+              <a:t> = 400 V. √3 ≈ 1,732.</a:t>
             </a:r>
           </a:p>
         </p:txBody>
@@ -7438,7 +7596,7 @@
       </p:sp>
       <p:sp>
         <p:nvSpPr>
-          <p:cNvPr id="4" name="Uᴸ = 400 V i ett symmetriskt system. Beräkna Uꜰ.">
+          <p:cNvPr id="4" name="UL = 400 V i ett symmetriskt system. Beräkna UF.">
             <a:extLst xmlns:a="http://schemas.openxmlformats.org/drawingml/2006/main">
               <a:ext uri="{FF2B5EF4-FFF2-40B4-BE49-F238E27FC236}">
                 <a16:creationId xmlns:a16="http://schemas.microsoft.com/office/drawing/2014/main" id="{755195FD-F6DC-46CB-9A31-A66530EE8D14}"/>
@@ -7453,7 +7611,7 @@
         <p:spPr>
           <a:xfrm xmlns:a="http://schemas.openxmlformats.org/drawingml/2006/main">
             <a:off x="762000" y="2533650"/>
-            <a:ext cx="7620000" cy="2286000"/>
+            <a:ext cx="3886200" cy="2606040"/>
           </a:xfrm>
           <a:prstGeom xmlns:a="http://schemas.openxmlformats.org/drawingml/2006/main" prst="rect">
             <a:avLst/>
@@ -7489,7 +7647,51 @@
                 <a:ea typeface="Calibri"/>
                 <a:cs typeface="Calibri"/>
               </a:rPr>
-              <a:t>Uᴸ = 400 V i ett symmetriskt system. Beräkna Uꜰ.</a:t>
+              <a:t>U</a:t>
+            </a:r>
+            <a:r>
+              <a:rPr sz="2400" b="0" baseline="-25000">
+                <a:solidFill>
+                  <a:srgbClr val="111111"/>
+                </a:solidFill>
+                <a:latin typeface="Calibri"/>
+                <a:ea typeface="Calibri"/>
+                <a:cs typeface="Calibri"/>
+              </a:rPr>
+              <a:t>L</a:t>
+            </a:r>
+            <a:r>
+              <a:rPr sz="2400" b="0">
+                <a:solidFill>
+                  <a:srgbClr val="111111"/>
+                </a:solidFill>
+                <a:latin typeface="Calibri"/>
+                <a:ea typeface="Calibri"/>
+                <a:cs typeface="Calibri"/>
+              </a:rPr>
+              <a:t> = 400 V i ett symmetriskt system. Beräkna U</a:t>
+            </a:r>
+            <a:r>
+              <a:rPr sz="2400" b="0" baseline="-25000">
+                <a:solidFill>
+                  <a:srgbClr val="111111"/>
+                </a:solidFill>
+                <a:latin typeface="Calibri"/>
+                <a:ea typeface="Calibri"/>
+                <a:cs typeface="Calibri"/>
+              </a:rPr>
+              <a:t>F</a:t>
+            </a:r>
+            <a:r>
+              <a:rPr sz="2400" b="0">
+                <a:solidFill>
+                  <a:srgbClr val="111111"/>
+                </a:solidFill>
+                <a:latin typeface="Calibri"/>
+                <a:ea typeface="Calibri"/>
+                <a:cs typeface="Calibri"/>
+              </a:rPr>
+              <a:t>.</a:t>
             </a:r>
           </a:p>
         </p:txBody>
@@ -7610,6 +7812,30 @@
           </a:p>
         </p:txBody>
       </p:sp>
+      <p:pic xmlns:a="http://schemas.openxmlformats.org/drawingml/2006/main" xmlns:r="http://schemas.openxmlformats.org/officeDocument/2006/relationships">
+        <p:nvPicPr>
+          <p:cNvPr id="9" name="Figur: Ledarna L1, L2, L3 och N; linjespänninge" descr="Ledarna L1, L2, L3 och N; linjespänningen 400 V mellan L1 och L2, fasspänningen okänd"/>
+          <p:cNvPicPr>
+            <a:picLocks noChangeAspect="1"/>
+          </p:cNvPicPr>
+          <p:nvPr/>
+        </p:nvPicPr>
+        <p:blipFill>
+          <a:blip r:embed="rId3"/>
+          <a:stretch>
+            <a:fillRect/>
+          </a:stretch>
+        </p:blipFill>
+        <p:spPr>
+          <a:xfrm>
+            <a:off x="4846320" y="2331720"/>
+            <a:ext cx="3931920" cy="2740984"/>
+          </a:xfrm>
+          <a:prstGeom prst="rect">
+            <a:avLst/>
+          </a:prstGeom>
+        </p:spPr>
+      </p:pic>
     </p:spTree>
     <p:extLst>
       <p:ext uri="{BB962C8B-B14F-4D97-AF65-F5344CB8AC3E}">
@@ -7715,7 +7941,7 @@
       </p:sp>
       <p:sp>
         <p:nvSpPr>
-          <p:cNvPr id="10" name="Uᴸ = √3 · Uꜰ">
+          <p:cNvPr id="10" name="UL = √3 · UF">
             <a:extLst xmlns:a="http://schemas.openxmlformats.org/drawingml/2006/main">
               <a:ext uri="{FF2B5EF4-FFF2-40B4-BE49-F238E27FC236}">
                 <a16:creationId xmlns:a16="http://schemas.microsoft.com/office/drawing/2014/main" id="{40946302-67BF-4737-99C6-DD5E8D138D6E}"/>
@@ -7765,7 +7991,40 @@
                 <a:ea typeface="Calibri"/>
                 <a:cs typeface="Calibri"/>
               </a:rPr>
-              <a:t>Uᴸ = √3 · Uꜰ</a:t>
+              <a:t>U</a:t>
+            </a:r>
+            <a:r>
+              <a:rPr sz="2400" b="1" baseline="-25000">
+                <a:solidFill>
+                  <a:srgbClr val="064F91"/>
+                </a:solidFill>
+                <a:latin typeface="Calibri"/>
+                <a:ea typeface="Calibri"/>
+                <a:cs typeface="Calibri"/>
+              </a:rPr>
+              <a:t>L</a:t>
+            </a:r>
+            <a:r>
+              <a:rPr sz="2400" b="1">
+                <a:solidFill>
+                  <a:srgbClr val="064F91"/>
+                </a:solidFill>
+                <a:latin typeface="Calibri"/>
+                <a:ea typeface="Calibri"/>
+                <a:cs typeface="Calibri"/>
+              </a:rPr>
+              <a:t> = √3 · U</a:t>
+            </a:r>
+            <a:r>
+              <a:rPr sz="2400" b="1" baseline="-25000">
+                <a:solidFill>
+                  <a:srgbClr val="064F91"/>
+                </a:solidFill>
+                <a:latin typeface="Calibri"/>
+                <a:ea typeface="Calibri"/>
+                <a:cs typeface="Calibri"/>
+              </a:rPr>
+              <a:t>F</a:t>
             </a:r>
           </a:p>
         </p:txBody>
@@ -7829,7 +8088,7 @@
       </p:sp>
       <p:sp>
         <p:nvSpPr>
-          <p:cNvPr id="12" name="Förutsättningar: Symmetrisk källa. Uꜰ = 120 V är fas–neutralspänn">
+          <p:cNvPr id="12" name="Förutsättningar: Symmetrisk källa. UF = 120 V är fas–neutralspänn">
             <a:extLst xmlns:a="http://schemas.openxmlformats.org/drawingml/2006/main">
               <a:ext uri="{FF2B5EF4-FFF2-40B4-BE49-F238E27FC236}">
                 <a16:creationId xmlns:a16="http://schemas.microsoft.com/office/drawing/2014/main" id="{6F9BB74E-1A98-4256-AE55-0F7E5BEA000A}"/>
@@ -7879,7 +8138,29 @@
                 <a:ea typeface="Calibri"/>
                 <a:cs typeface="Calibri"/>
               </a:rPr>
-              <a:t>Förutsättningar: Symmetrisk källa. Uꜰ = 120 V är fas–neutralspänning.</a:t>
+              <a:t>Förutsättningar: Symmetrisk källa. U</a:t>
+            </a:r>
+            <a:r>
+              <a:rPr sz="2025" b="0" baseline="-25000">
+                <a:solidFill>
+                  <a:srgbClr val="111111"/>
+                </a:solidFill>
+                <a:latin typeface="Calibri"/>
+                <a:ea typeface="Calibri"/>
+                <a:cs typeface="Calibri"/>
+              </a:rPr>
+              <a:t>F</a:t>
+            </a:r>
+            <a:r>
+              <a:rPr sz="2025" b="0">
+                <a:solidFill>
+                  <a:srgbClr val="111111"/>
+                </a:solidFill>
+                <a:latin typeface="Calibri"/>
+                <a:ea typeface="Calibri"/>
+                <a:cs typeface="Calibri"/>
+              </a:rPr>
+              <a:t> = 120 V är fas–neutralspänning.</a:t>
             </a:r>
           </a:p>
         </p:txBody>
@@ -7936,7 +8217,29 @@
                 <a:ea typeface="Calibri"/>
                 <a:cs typeface="Calibri"/>
               </a:rPr>
-              <a:t>Arbetsgång: Multiplicera med √3. Förväxla inte linjespänningen med summan 2Uꜰ.</a:t>
+              <a:t>Arbetsgång: Multiplicera med √3. Förväxla inte linjespänningen med summan 2U</a:t>
+            </a:r>
+            <a:r>
+              <a:rPr sz="2025" b="0" baseline="-25000">
+                <a:solidFill>
+                  <a:srgbClr val="111111"/>
+                </a:solidFill>
+                <a:latin typeface="Calibri"/>
+                <a:ea typeface="Calibri"/>
+                <a:cs typeface="Calibri"/>
+              </a:rPr>
+              <a:t>F</a:t>
+            </a:r>
+            <a:r>
+              <a:rPr sz="2025" b="0">
+                <a:solidFill>
+                  <a:srgbClr val="111111"/>
+                </a:solidFill>
+                <a:latin typeface="Calibri"/>
+                <a:ea typeface="Calibri"/>
+                <a:cs typeface="Calibri"/>
+              </a:rPr>
+              <a:t>.</a:t>
             </a:r>
           </a:p>
         </p:txBody>
@@ -8162,7 +8465,7 @@
       </p:sp>
       <p:sp>
         <p:nvSpPr>
-          <p:cNvPr id="4" name="Uꜰ = 120 V. Beräkna linjespänningen i ett symmetriskt system.">
+          <p:cNvPr id="4" name="UF = 120 V. Beräkna linjespänningen i ett symmetriskt system.">
             <a:extLst xmlns:a="http://schemas.openxmlformats.org/drawingml/2006/main">
               <a:ext uri="{FF2B5EF4-FFF2-40B4-BE49-F238E27FC236}">
                 <a16:creationId xmlns:a16="http://schemas.microsoft.com/office/drawing/2014/main" id="{3B2B7150-BF5B-4FF2-927B-78BD38ED0A65}"/>
@@ -8177,7 +8480,7 @@
         <p:spPr>
           <a:xfrm xmlns:a="http://schemas.openxmlformats.org/drawingml/2006/main">
             <a:off x="762000" y="2533650"/>
-            <a:ext cx="7620000" cy="2286000"/>
+            <a:ext cx="3886200" cy="2606040"/>
           </a:xfrm>
           <a:prstGeom xmlns:a="http://schemas.openxmlformats.org/drawingml/2006/main" prst="rect">
             <a:avLst/>
@@ -8213,7 +8516,29 @@
                 <a:ea typeface="Calibri"/>
                 <a:cs typeface="Calibri"/>
               </a:rPr>
-              <a:t>Uꜰ = 120 V. Beräkna linjespänningen i ett symmetriskt system.</a:t>
+              <a:t>U</a:t>
+            </a:r>
+            <a:r>
+              <a:rPr sz="2400" b="0" baseline="-25000">
+                <a:solidFill>
+                  <a:srgbClr val="111111"/>
+                </a:solidFill>
+                <a:latin typeface="Calibri"/>
+                <a:ea typeface="Calibri"/>
+                <a:cs typeface="Calibri"/>
+              </a:rPr>
+              <a:t>F</a:t>
+            </a:r>
+            <a:r>
+              <a:rPr sz="2400" b="0">
+                <a:solidFill>
+                  <a:srgbClr val="111111"/>
+                </a:solidFill>
+                <a:latin typeface="Calibri"/>
+                <a:ea typeface="Calibri"/>
+                <a:cs typeface="Calibri"/>
+              </a:rPr>
+              <a:t> = 120 V. Beräkna linjespänningen i ett symmetriskt system.</a:t>
             </a:r>
           </a:p>
         </p:txBody>
@@ -8334,6 +8659,30 @@
           </a:p>
         </p:txBody>
       </p:sp>
+      <p:pic xmlns:a="http://schemas.openxmlformats.org/drawingml/2006/main" xmlns:r="http://schemas.openxmlformats.org/officeDocument/2006/relationships">
+        <p:nvPicPr>
+          <p:cNvPr id="9" name="Figur: Ledarna L1, L2, L3 och N; fasspänningen " descr="Ledarna L1, L2, L3 och N; fasspänningen 120 V mellan L1 och N, linjespänningen okänd"/>
+          <p:cNvPicPr>
+            <a:picLocks noChangeAspect="1"/>
+          </p:cNvPicPr>
+          <p:nvPr/>
+        </p:nvPicPr>
+        <p:blipFill>
+          <a:blip r:embed="rId3"/>
+          <a:stretch>
+            <a:fillRect/>
+          </a:stretch>
+        </p:blipFill>
+        <p:spPr>
+          <a:xfrm>
+            <a:off x="4846320" y="2331720"/>
+            <a:ext cx="3931920" cy="2740984"/>
+          </a:xfrm>
+          <a:prstGeom prst="rect">
+            <a:avLst/>
+          </a:prstGeom>
+        </p:spPr>
+      </p:pic>
     </p:spTree>
     <p:extLst>
       <p:ext uri="{BB962C8B-B14F-4D97-AF65-F5344CB8AC3E}">
@@ -8439,7 +8788,7 @@
       </p:sp>
       <p:sp>
         <p:nvSpPr>
-          <p:cNvPr id="10" name="Ugren,Y = Uᴸ/√3">
+          <p:cNvPr id="10" name="Ugren,Y = UL/√3">
             <a:extLst xmlns:a="http://schemas.openxmlformats.org/drawingml/2006/main">
               <a:ext uri="{FF2B5EF4-FFF2-40B4-BE49-F238E27FC236}">
                 <a16:creationId xmlns:a16="http://schemas.microsoft.com/office/drawing/2014/main" id="{843430DE-C25E-4028-AA32-CDD21D4A8F92}"/>
@@ -8489,7 +8838,29 @@
                 <a:ea typeface="Calibri"/>
                 <a:cs typeface="Calibri"/>
               </a:rPr>
-              <a:t>Ugren,Y = Uᴸ/√3</a:t>
+              <a:t>Ugren,Y = U</a:t>
+            </a:r>
+            <a:r>
+              <a:rPr sz="2400" b="1" baseline="-25000">
+                <a:solidFill>
+                  <a:srgbClr val="064F91"/>
+                </a:solidFill>
+                <a:latin typeface="Calibri"/>
+                <a:ea typeface="Calibri"/>
+                <a:cs typeface="Calibri"/>
+              </a:rPr>
+              <a:t>L</a:t>
+            </a:r>
+            <a:r>
+              <a:rPr sz="2400" b="1">
+                <a:solidFill>
+                  <a:srgbClr val="064F91"/>
+                </a:solidFill>
+                <a:latin typeface="Calibri"/>
+                <a:ea typeface="Calibri"/>
+                <a:cs typeface="Calibri"/>
+              </a:rPr>
+              <a:t>/√3</a:t>
             </a:r>
           </a:p>
         </p:txBody>
@@ -8553,7 +8924,7 @@
       </p:sp>
       <p:sp>
         <p:nvSpPr>
-          <p:cNvPr id="12" name="Förutsättningar: Avsedd tränare med Uᴸ = 12,0 V, lika fasimpedans">
+          <p:cNvPr id="12" name="Förutsättningar: Avsedd tränare med UL = 12,0 V, lika fasimpedans">
             <a:extLst xmlns:a="http://schemas.openxmlformats.org/drawingml/2006/main">
               <a:ext uri="{FF2B5EF4-FFF2-40B4-BE49-F238E27FC236}">
                 <a16:creationId xmlns:a16="http://schemas.microsoft.com/office/drawing/2014/main" id="{F9F75C3D-39F3-4BCE-BF90-A54056BDE9C9}"/>
@@ -8603,7 +8974,29 @@
                 <a:ea typeface="Calibri"/>
                 <a:cs typeface="Calibri"/>
               </a:rPr>
-              <a:t>Förutsättningar: Avsedd tränare med Uᴸ = 12,0 V, lika fasimpedanser och symmetrisk källa.</a:t>
+              <a:t>Förutsättningar: Avsedd tränare med U</a:t>
+            </a:r>
+            <a:r>
+              <a:rPr sz="2025" b="0" baseline="-25000">
+                <a:solidFill>
+                  <a:srgbClr val="111111"/>
+                </a:solidFill>
+                <a:latin typeface="Calibri"/>
+                <a:ea typeface="Calibri"/>
+                <a:cs typeface="Calibri"/>
+              </a:rPr>
+              <a:t>L</a:t>
+            </a:r>
+            <a:r>
+              <a:rPr sz="2025" b="0">
+                <a:solidFill>
+                  <a:srgbClr val="111111"/>
+                </a:solidFill>
+                <a:latin typeface="Calibri"/>
+                <a:ea typeface="Calibri"/>
+                <a:cs typeface="Calibri"/>
+              </a:rPr>
+              <a:t> = 12,0 V, lika fasimpedanser och symmetrisk källa.</a:t>
             </a:r>
           </a:p>
         </p:txBody>
@@ -8901,7 +9294,7 @@
         <p:spPr>
           <a:xfrm xmlns:a="http://schemas.openxmlformats.org/drawingml/2006/main">
             <a:off x="762000" y="2533650"/>
-            <a:ext cx="7620000" cy="2286000"/>
+            <a:ext cx="3886200" cy="2606040"/>
           </a:xfrm>
           <a:prstGeom xmlns:a="http://schemas.openxmlformats.org/drawingml/2006/main" prst="rect">
             <a:avLst/>
@@ -8937,7 +9330,7 @@
                 <a:ea typeface="Calibri"/>
                 <a:cs typeface="Calibri"/>
               </a:rPr>
-              <a:t>En avsedd trefastränare ger 12,0 V mellan faserna. Vilken spänning förväntas över varje gren i en symmetrisk Y-last?</a:t>
+              <a:t>En avsedd trefastränare ger 12,0 V mellan faserna. Vilken spänning förväntas över varje gren i en symmetrisk Y-last?</a:t>
             </a:r>
           </a:p>
         </p:txBody>
@@ -9058,6 +9451,30 @@
           </a:p>
         </p:txBody>
       </p:sp>
+      <p:pic xmlns:a="http://schemas.openxmlformats.org/drawingml/2006/main" xmlns:r="http://schemas.openxmlformats.org/officeDocument/2006/relationships">
+        <p:nvPicPr>
+          <p:cNvPr id="9" name="Figur: Symmetrisk Y-last på trefastränare med l" descr="Symmetrisk Y-last på trefastränare med linjespänningen 12,0 V; grenspänningen okänd"/>
+          <p:cNvPicPr>
+            <a:picLocks noChangeAspect="1"/>
+          </p:cNvPicPr>
+          <p:nvPr/>
+        </p:nvPicPr>
+        <p:blipFill>
+          <a:blip r:embed="rId3"/>
+          <a:stretch>
+            <a:fillRect/>
+          </a:stretch>
+        </p:blipFill>
+        <p:spPr>
+          <a:xfrm>
+            <a:off x="4846320" y="2331720"/>
+            <a:ext cx="3931920" cy="2740984"/>
+          </a:xfrm>
+          <a:prstGeom prst="rect">
+            <a:avLst/>
+          </a:prstGeom>
+        </p:spPr>
+      </p:pic>
     </p:spTree>
     <p:extLst>
       <p:ext uri="{BB962C8B-B14F-4D97-AF65-F5344CB8AC3E}">
@@ -9923,7 +10340,7 @@
         <p:spPr>
           <a:xfrm xmlns:a="http://schemas.openxmlformats.org/drawingml/2006/main">
             <a:off x="762000" y="1619250"/>
-            <a:ext cx="7620000" cy="1466850"/>
+            <a:ext cx="3977639" cy="1466850"/>
           </a:xfrm>
           <a:prstGeom xmlns:a="http://schemas.openxmlformats.org/drawingml/2006/main" prst="rect">
             <a:avLst/>
@@ -9951,7 +10368,7 @@
               </a:defRPr>
             </a:pPr>
             <a:r>
-              <a:rPr sz="2400" b="0">
+              <a:rPr sz="2100" b="0">
                 <a:solidFill>
                   <a:srgbClr val="111111"/>
                 </a:solidFill>
@@ -9975,7 +10392,7 @@
               </a:defRPr>
             </a:pPr>
             <a:r>
-              <a:rPr sz="2400" b="0">
+              <a:rPr sz="2100" b="0">
                 <a:solidFill>
                   <a:srgbClr val="111111"/>
                 </a:solidFill>
@@ -10005,7 +10422,7 @@
         <p:spPr>
           <a:xfrm xmlns:a="http://schemas.openxmlformats.org/drawingml/2006/main">
             <a:off x="762000" y="3200400"/>
-            <a:ext cx="7620000" cy="838200"/>
+            <a:ext cx="3977639" cy="838200"/>
           </a:xfrm>
           <a:prstGeom xmlns:a="http://schemas.openxmlformats.org/drawingml/2006/main" prst="rect">
             <a:avLst/>
@@ -10033,7 +10450,7 @@
               </a:defRPr>
             </a:pPr>
             <a:r>
-              <a:rPr sz="2925" b="1">
+              <a:rPr sz="2650" b="1">
                 <a:solidFill>
                   <a:srgbClr val="064F91"/>
                 </a:solidFill>
@@ -10041,7 +10458,7 @@
                 <a:ea typeface="Calibri"/>
                 <a:cs typeface="Calibri"/>
               </a:rPr>
-              <a:t>I⃗N = −(I⃗₁ + I⃗₂ + I⃗₃)</a:t>
+              <a:t>I⃗N = −(I⃗₁ + I⃗₂ + I⃗₃)</a:t>
             </a:r>
           </a:p>
         </p:txBody>
@@ -10063,7 +10480,7 @@
         <p:spPr>
           <a:xfrm xmlns:a="http://schemas.openxmlformats.org/drawingml/2006/main">
             <a:off x="762000" y="4429125"/>
-            <a:ext cx="7620000" cy="1352550"/>
+            <a:ext cx="3977639" cy="1352550"/>
           </a:xfrm>
           <a:prstGeom xmlns:a="http://schemas.openxmlformats.org/drawingml/2006/main" prst="rect">
             <a:avLst/>
@@ -10091,15 +10508,15 @@
               </a:defRPr>
             </a:pPr>
             <a:r>
-              <a:rPr sz="2250" b="0">
-                <a:solidFill>
-                  <a:srgbClr val="111111"/>
-                </a:solidFill>
-                <a:latin typeface="Calibri"/>
-                <a:ea typeface="Calibri"/>
-                <a:cs typeface="Calibri"/>
-              </a:rPr>
-              <a:t>10 A i varje fas ger 0 A i neutralledaren</a:t>
+              <a:rPr sz="2100" b="0">
+                <a:solidFill>
+                  <a:srgbClr val="111111"/>
+                </a:solidFill>
+                <a:latin typeface="Calibri"/>
+                <a:ea typeface="Calibri"/>
+                <a:cs typeface="Calibri"/>
+              </a:rPr>
+              <a:t>10 A i varje fas ger 0 A i neutralledaren</a:t>
             </a:r>
           </a:p>
           <a:p xmlns:a="http://schemas.openxmlformats.org/drawingml/2006/main">
@@ -10115,7 +10532,7 @@
               </a:defRPr>
             </a:pPr>
             <a:r>
-              <a:rPr sz="2250" b="0">
+              <a:rPr sz="2100" b="0">
                 <a:solidFill>
                   <a:srgbClr val="111111"/>
                 </a:solidFill>
@@ -10186,6 +10603,30 @@
           </a:p>
         </p:txBody>
       </p:sp>
+      <p:pic xmlns:a="http://schemas.openxmlformats.org/drawingml/2006/main" xmlns:r="http://schemas.openxmlformats.org/officeDocument/2006/relationships">
+        <p:nvPicPr>
+          <p:cNvPr id="9" name="Figur: Tre lika strömvisare lagda efter varandr" descr="Tre lika strömvisare lagda efter varandra bildar en sluten triangel; neutralströmmen blir noll"/>
+          <p:cNvPicPr>
+            <a:picLocks noChangeAspect="1"/>
+          </p:cNvPicPr>
+          <p:nvPr/>
+        </p:nvPicPr>
+        <p:blipFill>
+          <a:blip r:embed="rId3"/>
+          <a:stretch>
+            <a:fillRect/>
+          </a:stretch>
+        </p:blipFill>
+        <p:spPr>
+          <a:xfrm>
+            <a:off x="4892040" y="1645920"/>
+            <a:ext cx="3886200" cy="3252383"/>
+          </a:xfrm>
+          <a:prstGeom prst="rect">
+            <a:avLst/>
+          </a:prstGeom>
+        </p:spPr>
+      </p:pic>
     </p:spTree>
     <p:extLst>
       <p:ext uri="{BB962C8B-B14F-4D97-AF65-F5344CB8AC3E}">
@@ -10307,7 +10748,7 @@
         <p:spPr>
           <a:xfrm xmlns:a="http://schemas.openxmlformats.org/drawingml/2006/main">
             <a:off x="762000" y="1619250"/>
-            <a:ext cx="7620000" cy="1466850"/>
+            <a:ext cx="3977639" cy="1466850"/>
           </a:xfrm>
           <a:prstGeom xmlns:a="http://schemas.openxmlformats.org/drawingml/2006/main" prst="rect">
             <a:avLst/>
@@ -10335,7 +10776,7 @@
               </a:defRPr>
             </a:pPr>
             <a:r>
-              <a:rPr sz="2400" b="0">
+              <a:rPr sz="2350" b="0">
                 <a:solidFill>
                   <a:srgbClr val="111111"/>
                 </a:solidFill>
@@ -10359,7 +10800,7 @@
               </a:defRPr>
             </a:pPr>
             <a:r>
-              <a:rPr sz="2400" b="0">
+              <a:rPr sz="2350" b="0">
                 <a:solidFill>
                   <a:srgbClr val="111111"/>
                 </a:solidFill>
@@ -10389,7 +10830,7 @@
         <p:spPr>
           <a:xfrm xmlns:a="http://schemas.openxmlformats.org/drawingml/2006/main">
             <a:off x="762000" y="3200400"/>
-            <a:ext cx="7620000" cy="838200"/>
+            <a:ext cx="3977639" cy="838200"/>
           </a:xfrm>
           <a:prstGeom xmlns:a="http://schemas.openxmlformats.org/drawingml/2006/main" prst="rect">
             <a:avLst/>
@@ -10417,7 +10858,7 @@
               </a:defRPr>
             </a:pPr>
             <a:r>
-              <a:rPr sz="2925" b="1">
+              <a:rPr sz="2650" b="1">
                 <a:solidFill>
                   <a:srgbClr val="064F91"/>
                 </a:solidFill>
@@ -10425,7 +10866,7 @@
                 <a:ea typeface="Calibri"/>
                 <a:cs typeface="Calibri"/>
               </a:rPr>
-              <a:t>10 A + 10 A + 10 A är ingen visarsumma</a:t>
+              <a:t>10 A + 10 A + 10 A är ingen visarsumma</a:t>
             </a:r>
           </a:p>
         </p:txBody>
@@ -10447,7 +10888,7 @@
         <p:spPr>
           <a:xfrm xmlns:a="http://schemas.openxmlformats.org/drawingml/2006/main">
             <a:off x="762000" y="4429125"/>
-            <a:ext cx="7620000" cy="1352550"/>
+            <a:ext cx="3977639" cy="1352550"/>
           </a:xfrm>
           <a:prstGeom xmlns:a="http://schemas.openxmlformats.org/drawingml/2006/main" prst="rect">
             <a:avLst/>
@@ -10475,7 +10916,7 @@
               </a:defRPr>
             </a:pPr>
             <a:r>
-              <a:rPr sz="2250" b="0">
+              <a:rPr sz="1800" b="0">
                 <a:solidFill>
                   <a:srgbClr val="111111"/>
                 </a:solidFill>
@@ -10499,7 +10940,7 @@
               </a:defRPr>
             </a:pPr>
             <a:r>
-              <a:rPr sz="2250" b="0">
+              <a:rPr sz="1800" b="0">
                 <a:solidFill>
                   <a:srgbClr val="111111"/>
                 </a:solidFill>
@@ -10570,6 +11011,30 @@
           </a:p>
         </p:txBody>
       </p:sp>
+      <p:pic xmlns:a="http://schemas.openxmlformats.org/drawingml/2006/main" xmlns:r="http://schemas.openxmlformats.org/officeDocument/2006/relationships">
+        <p:nvPicPr>
+          <p:cNvPr id="9" name="Figur: Olika fasströmmar 10, 10 och 4 A sluter " descr="Olika fasströmmar 10, 10 och 4 A sluter inte triangeln; neutralströmmen sluter den"/>
+          <p:cNvPicPr>
+            <a:picLocks noChangeAspect="1"/>
+          </p:cNvPicPr>
+          <p:nvPr/>
+        </p:nvPicPr>
+        <p:blipFill>
+          <a:blip r:embed="rId3"/>
+          <a:stretch>
+            <a:fillRect/>
+          </a:stretch>
+        </p:blipFill>
+        <p:spPr>
+          <a:xfrm>
+            <a:off x="4892040" y="1645920"/>
+            <a:ext cx="3886200" cy="3252383"/>
+          </a:xfrm>
+          <a:prstGeom prst="rect">
+            <a:avLst/>
+          </a:prstGeom>
+        </p:spPr>
+      </p:pic>
     </p:spTree>
     <p:extLst>
       <p:ext uri="{BB962C8B-B14F-4D97-AF65-F5344CB8AC3E}">
@@ -10691,7 +11156,7 @@
         <p:spPr>
           <a:xfrm xmlns:a="http://schemas.openxmlformats.org/drawingml/2006/main">
             <a:off x="762000" y="1619250"/>
-            <a:ext cx="7620000" cy="1466850"/>
+            <a:ext cx="3977639" cy="1466850"/>
           </a:xfrm>
           <a:prstGeom xmlns:a="http://schemas.openxmlformats.org/drawingml/2006/main" prst="rect">
             <a:avLst/>
@@ -10719,7 +11184,7 @@
               </a:defRPr>
             </a:pPr>
             <a:r>
-              <a:rPr sz="2400" b="0">
+              <a:rPr sz="1900" b="0">
                 <a:solidFill>
                   <a:srgbClr val="111111"/>
                 </a:solidFill>
@@ -10743,7 +11208,7 @@
               </a:defRPr>
             </a:pPr>
             <a:r>
-              <a:rPr sz="2400" b="0">
+              <a:rPr sz="1900" b="0">
                 <a:solidFill>
                   <a:srgbClr val="111111"/>
                 </a:solidFill>
@@ -10773,7 +11238,7 @@
         <p:spPr>
           <a:xfrm xmlns:a="http://schemas.openxmlformats.org/drawingml/2006/main">
             <a:off x="762000" y="3200400"/>
-            <a:ext cx="7620000" cy="838200"/>
+            <a:ext cx="3977639" cy="838200"/>
           </a:xfrm>
           <a:prstGeom xmlns:a="http://schemas.openxmlformats.org/drawingml/2006/main" prst="rect">
             <a:avLst/>
@@ -10801,7 +11266,7 @@
               </a:defRPr>
             </a:pPr>
             <a:r>
-              <a:rPr sz="2925" b="1">
+              <a:rPr sz="2650" b="1">
                 <a:solidFill>
                   <a:srgbClr val="064F91"/>
                 </a:solidFill>
@@ -10831,7 +11296,7 @@
         <p:spPr>
           <a:xfrm xmlns:a="http://schemas.openxmlformats.org/drawingml/2006/main">
             <a:off x="762000" y="4429125"/>
-            <a:ext cx="7620000" cy="1352550"/>
+            <a:ext cx="3977639" cy="1352550"/>
           </a:xfrm>
           <a:prstGeom xmlns:a="http://schemas.openxmlformats.org/drawingml/2006/main" prst="rect">
             <a:avLst/>
@@ -10859,7 +11324,7 @@
               </a:defRPr>
             </a:pPr>
             <a:r>
-              <a:rPr sz="2250" b="0">
+              <a:rPr sz="1800" b="0">
                 <a:solidFill>
                   <a:srgbClr val="111111"/>
                 </a:solidFill>
@@ -10883,15 +11348,15 @@
               </a:defRPr>
             </a:pPr>
             <a:r>
-              <a:rPr sz="2250" b="0">
-                <a:solidFill>
-                  <a:srgbClr val="111111"/>
-                </a:solidFill>
-                <a:latin typeface="Calibri"/>
-                <a:ea typeface="Calibri"/>
-                <a:cs typeface="Calibri"/>
-              </a:rPr>
-              <a:t>400 V mellan faser visar inte att varje fas–jordvärde är 230 V.</a:t>
+              <a:rPr sz="1800" b="0">
+                <a:solidFill>
+                  <a:srgbClr val="111111"/>
+                </a:solidFill>
+                <a:latin typeface="Calibri"/>
+                <a:ea typeface="Calibri"/>
+                <a:cs typeface="Calibri"/>
+              </a:rPr>
+              <a:t>400 V mellan faser visar inte att varje fas–jordvärde är 230 V.</a:t>
             </a:r>
           </a:p>
         </p:txBody>
@@ -10954,6 +11419,30 @@
           </a:p>
         </p:txBody>
       </p:sp>
+      <p:pic xmlns:a="http://schemas.openxmlformats.org/drawingml/2006/main" xmlns:r="http://schemas.openxmlformats.org/officeDocument/2006/relationships">
+        <p:nvPicPr>
+          <p:cNvPr id="9" name="Figur: Mätpunkter för linjespänningarna U12, U2" descr="Mätpunkter för linjespänningarna U12, U23, U31 och fasspänningen U1N"/>
+          <p:cNvPicPr>
+            <a:picLocks noChangeAspect="1"/>
+          </p:cNvPicPr>
+          <p:nvPr/>
+        </p:nvPicPr>
+        <p:blipFill>
+          <a:blip r:embed="rId3"/>
+          <a:stretch>
+            <a:fillRect/>
+          </a:stretch>
+        </p:blipFill>
+        <p:spPr>
+          <a:xfrm>
+            <a:off x="4892040" y="1645920"/>
+            <a:ext cx="3886200" cy="3071293"/>
+          </a:xfrm>
+          <a:prstGeom prst="rect">
+            <a:avLst/>
+          </a:prstGeom>
+        </p:spPr>
+      </p:pic>
     </p:spTree>
     <p:extLst>
       <p:ext uri="{BB962C8B-B14F-4D97-AF65-F5344CB8AC3E}">
@@ -11955,7 +12444,7 @@
         <p:spPr>
           <a:xfrm xmlns:a="http://schemas.openxmlformats.org/drawingml/2006/main">
             <a:off x="762000" y="2533650"/>
-            <a:ext cx="7620000" cy="2286000"/>
+            <a:ext cx="3886200" cy="2606040"/>
           </a:xfrm>
           <a:prstGeom xmlns:a="http://schemas.openxmlformats.org/drawingml/2006/main" prst="rect">
             <a:avLst/>
@@ -11991,7 +12480,7 @@
                 <a:ea typeface="Calibri"/>
                 <a:cs typeface="Calibri"/>
               </a:rPr>
-              <a:t>Tre rena sinusströmmar på 8,0 A har 120° mellan faserna. Bestäm neutralströmmens RMS-värde.</a:t>
+              <a:t>Tre rena sinusströmmar på 8,0 A har 120° mellan faserna. Bestäm neutralströmmens RMS-värde.</a:t>
             </a:r>
           </a:p>
         </p:txBody>
@@ -12112,6 +12601,30 @@
           </a:p>
         </p:txBody>
       </p:sp>
+      <p:pic xmlns:a="http://schemas.openxmlformats.org/drawingml/2006/main" xmlns:r="http://schemas.openxmlformats.org/officeDocument/2006/relationships">
+        <p:nvPicPr>
+          <p:cNvPr id="9" name="Figur: Tre strömvisare på 8,0 A med 120 grader " descr="Tre strömvisare på 8,0 A med 120 grader mellan; neutralströmmen okänd"/>
+          <p:cNvPicPr>
+            <a:picLocks noChangeAspect="1"/>
+          </p:cNvPicPr>
+          <p:nvPr/>
+        </p:nvPicPr>
+        <p:blipFill>
+          <a:blip r:embed="rId3"/>
+          <a:stretch>
+            <a:fillRect/>
+          </a:stretch>
+        </p:blipFill>
+        <p:spPr>
+          <a:xfrm>
+            <a:off x="4846320" y="2331720"/>
+            <a:ext cx="3931920" cy="2740984"/>
+          </a:xfrm>
+          <a:prstGeom prst="rect">
+            <a:avLst/>
+          </a:prstGeom>
+        </p:spPr>
+      </p:pic>
     </p:spTree>
     <p:extLst>
       <p:ext uri="{BB962C8B-B14F-4D97-AF65-F5344CB8AC3E}">
@@ -12679,7 +13192,7 @@
         <p:spPr>
           <a:xfrm xmlns:a="http://schemas.openxmlformats.org/drawingml/2006/main">
             <a:off x="762000" y="2533650"/>
-            <a:ext cx="7620000" cy="2286000"/>
+            <a:ext cx="3886200" cy="2606040"/>
           </a:xfrm>
           <a:prstGeom xmlns:a="http://schemas.openxmlformats.org/drawingml/2006/main" prst="rect">
             <a:avLst/>
@@ -12715,7 +13228,7 @@
                 <a:ea typeface="Calibri"/>
                 <a:cs typeface="Calibri"/>
               </a:rPr>
-              <a:t>En enda fas–neutral-last tar 5,0 A. De två andra fasströmmarna är noll. Bestäm neutralströmmen.</a:t>
+              <a:t>En enda fas–neutral-last tar 5,0 A. De två andra fasströmmarna är noll. Bestäm neutralströmmen.</a:t>
             </a:r>
           </a:p>
         </p:txBody>
@@ -12836,6 +13349,30 @@
           </a:p>
         </p:txBody>
       </p:sp>
+      <p:pic xmlns:a="http://schemas.openxmlformats.org/drawingml/2006/main" xmlns:r="http://schemas.openxmlformats.org/officeDocument/2006/relationships">
+        <p:nvPicPr>
+          <p:cNvPr id="9" name="Figur: En last mellan L1 och N som tar 5,0 A; n" descr="En last mellan L1 och N som tar 5,0 A; neutralströmmen okänd"/>
+          <p:cNvPicPr>
+            <a:picLocks noChangeAspect="1"/>
+          </p:cNvPicPr>
+          <p:nvPr/>
+        </p:nvPicPr>
+        <p:blipFill>
+          <a:blip r:embed="rId3"/>
+          <a:stretch>
+            <a:fillRect/>
+          </a:stretch>
+        </p:blipFill>
+        <p:spPr>
+          <a:xfrm>
+            <a:off x="4846320" y="2331720"/>
+            <a:ext cx="3931920" cy="2740984"/>
+          </a:xfrm>
+          <a:prstGeom prst="rect">
+            <a:avLst/>
+          </a:prstGeom>
+        </p:spPr>
+      </p:pic>
     </p:spTree>
     <p:extLst>
       <p:ext uri="{BB962C8B-B14F-4D97-AF65-F5344CB8AC3E}">
@@ -13917,7 +14454,7 @@
         <p:spPr>
           <a:xfrm xmlns:a="http://schemas.openxmlformats.org/drawingml/2006/main">
             <a:off x="762000" y="2533650"/>
-            <a:ext cx="7620000" cy="2286000"/>
+            <a:ext cx="3886200" cy="2606040"/>
           </a:xfrm>
           <a:prstGeom xmlns:a="http://schemas.openxmlformats.org/drawingml/2006/main" prst="rect">
             <a:avLst/>
@@ -13953,7 +14490,7 @@
                 <a:ea typeface="Calibri"/>
                 <a:cs typeface="Calibri"/>
               </a:rPr>
-              <a:t>Två fasströmmar är 10 A med 120° emellan. Den tredje är noll. Bestäm neutralströmmens belopp.</a:t>
+              <a:t>Två fasströmmar är 10 A med 120° emellan. Den tredje är noll. Bestäm neutralströmmens belopp.</a:t>
             </a:r>
           </a:p>
         </p:txBody>
@@ -14074,6 +14611,30 @@
           </a:p>
         </p:txBody>
       </p:sp>
+      <p:pic xmlns:a="http://schemas.openxmlformats.org/drawingml/2006/main" xmlns:r="http://schemas.openxmlformats.org/officeDocument/2006/relationships">
+        <p:nvPicPr>
+          <p:cNvPr id="9" name="Figur: Två strömvisare på 10 A med 120 grader m" descr="Två strömvisare på 10 A med 120 grader mellan, tredje strömmen noll; neutralströmmen okänd"/>
+          <p:cNvPicPr>
+            <a:picLocks noChangeAspect="1"/>
+          </p:cNvPicPr>
+          <p:nvPr/>
+        </p:nvPicPr>
+        <p:blipFill>
+          <a:blip r:embed="rId3"/>
+          <a:stretch>
+            <a:fillRect/>
+          </a:stretch>
+        </p:blipFill>
+        <p:spPr>
+          <a:xfrm>
+            <a:off x="4846320" y="2331720"/>
+            <a:ext cx="3931920" cy="2740984"/>
+          </a:xfrm>
+          <a:prstGeom prst="rect">
+            <a:avLst/>
+          </a:prstGeom>
+        </p:spPr>
+      </p:pic>
     </p:spTree>
     <p:extLst>
       <p:ext uri="{BB962C8B-B14F-4D97-AF65-F5344CB8AC3E}">
@@ -14664,7 +15225,7 @@
         <p:spPr>
           <a:xfrm xmlns:a="http://schemas.openxmlformats.org/drawingml/2006/main">
             <a:off x="762000" y="2533650"/>
-            <a:ext cx="7620000" cy="2286000"/>
+            <a:ext cx="3886200" cy="2606040"/>
           </a:xfrm>
           <a:prstGeom xmlns:a="http://schemas.openxmlformats.org/drawingml/2006/main" prst="rect">
             <a:avLst/>
@@ -14700,7 +15261,7 @@
                 <a:ea typeface="Calibri"/>
                 <a:cs typeface="Calibri"/>
               </a:rPr>
-              <a:t>U₁₂ = 400 V, U₂₃ = 402 V och U₃₁ = 398 V. Beräkna medelvärdet och största avvikelsen i procent av medlet.</a:t>
+              <a:t>U₁₂ = 400 V, U₂₃ = 402 V och U₃₁ = 398 V. Beräkna medelvärdet och största avvikelsen i procent av medlet.</a:t>
             </a:r>
           </a:p>
         </p:txBody>
@@ -14821,6 +15382,30 @@
           </a:p>
         </p:txBody>
       </p:sp>
+      <p:pic xmlns:a="http://schemas.openxmlformats.org/drawingml/2006/main" xmlns:r="http://schemas.openxmlformats.org/officeDocument/2006/relationships">
+        <p:nvPicPr>
+          <p:cNvPr id="9" name="Figur: Stapeldiagram med linjespänningarna 400," descr="Stapeldiagram med linjespänningarna 400, 402 och 398 V; medelvärde och avvikelse okända"/>
+          <p:cNvPicPr>
+            <a:picLocks noChangeAspect="1"/>
+          </p:cNvPicPr>
+          <p:nvPr/>
+        </p:nvPicPr>
+        <p:blipFill>
+          <a:blip r:embed="rId3"/>
+          <a:stretch>
+            <a:fillRect/>
+          </a:stretch>
+        </p:blipFill>
+        <p:spPr>
+          <a:xfrm>
+            <a:off x="4846320" y="2331720"/>
+            <a:ext cx="3931920" cy="2740984"/>
+          </a:xfrm>
+          <a:prstGeom prst="rect">
+            <a:avLst/>
+          </a:prstGeom>
+        </p:spPr>
+      </p:pic>
     </p:spTree>
     <p:extLst>
       <p:ext uri="{BB962C8B-B14F-4D97-AF65-F5344CB8AC3E}">
@@ -15388,7 +15973,7 @@
         <p:spPr>
           <a:xfrm xmlns:a="http://schemas.openxmlformats.org/drawingml/2006/main">
             <a:off x="762000" y="2533650"/>
-            <a:ext cx="7620000" cy="2286000"/>
+            <a:ext cx="3886200" cy="2606040"/>
           </a:xfrm>
           <a:prstGeom xmlns:a="http://schemas.openxmlformats.org/drawingml/2006/main" prst="rect">
             <a:avLst/>
@@ -15545,6 +16130,30 @@
           </a:p>
         </p:txBody>
       </p:sp>
+      <p:pic xmlns:a="http://schemas.openxmlformats.org/drawingml/2006/main" xmlns:r="http://schemas.openxmlformats.org/officeDocument/2006/relationships">
+        <p:nvPicPr>
+          <p:cNvPr id="9" name="Figur: Två olika laster Ra och Rb från L1 och L" descr="Två olika laster Ra och Rb från L1 och L2 till en gemensam punkt där neutralledaren är bruten"/>
+          <p:cNvPicPr>
+            <a:picLocks noChangeAspect="1"/>
+          </p:cNvPicPr>
+          <p:nvPr/>
+        </p:nvPicPr>
+        <p:blipFill>
+          <a:blip r:embed="rId3"/>
+          <a:stretch>
+            <a:fillRect/>
+          </a:stretch>
+        </p:blipFill>
+        <p:spPr>
+          <a:xfrm>
+            <a:off x="4846320" y="2331720"/>
+            <a:ext cx="3931920" cy="2740984"/>
+          </a:xfrm>
+          <a:prstGeom prst="rect">
+            <a:avLst/>
+          </a:prstGeom>
+        </p:spPr>
+      </p:pic>
     </p:spTree>
     <p:extLst>
       <p:ext uri="{BB962C8B-B14F-4D97-AF65-F5344CB8AC3E}">
@@ -15651,7 +16260,7 @@
       </p:sp>
       <p:sp>
         <p:nvSpPr>
-          <p:cNvPr id="3" name="Vilka två anslutningar använder du för att definiera Uᴸ respektiv">
+          <p:cNvPr id="3" name="Vilka två anslutningar använder du för att definiera UL respektiv">
             <a:extLst xmlns:a="http://schemas.openxmlformats.org/drawingml/2006/main">
               <a:ext uri="{FF2B5EF4-FFF2-40B4-BE49-F238E27FC236}">
                 <a16:creationId xmlns:a16="http://schemas.microsoft.com/office/drawing/2014/main" id="{62F86BB0-E23B-45F6-A5E8-986B537DD950}"/>
@@ -15702,7 +16311,51 @@
                 <a:ea typeface="Calibri"/>
                 <a:cs typeface="Calibri"/>
               </a:rPr>
-              <a:t>Vilka två anslutningar använder du för att definiera Uᴸ respektive Uꜰ?</a:t>
+              <a:t>Vilka två anslutningar använder du för att definiera U</a:t>
+            </a:r>
+            <a:r>
+              <a:rPr sz="2550" b="1" baseline="-25000">
+                <a:solidFill>
+                  <a:srgbClr val="064F91"/>
+                </a:solidFill>
+                <a:latin typeface="Calibri"/>
+                <a:ea typeface="Calibri"/>
+                <a:cs typeface="Calibri"/>
+              </a:rPr>
+              <a:t>L</a:t>
+            </a:r>
+            <a:r>
+              <a:rPr sz="2550" b="1">
+                <a:solidFill>
+                  <a:srgbClr val="064F91"/>
+                </a:solidFill>
+                <a:latin typeface="Calibri"/>
+                <a:ea typeface="Calibri"/>
+                <a:cs typeface="Calibri"/>
+              </a:rPr>
+              <a:t> respektive U</a:t>
+            </a:r>
+            <a:r>
+              <a:rPr sz="2550" b="1" baseline="-25000">
+                <a:solidFill>
+                  <a:srgbClr val="064F91"/>
+                </a:solidFill>
+                <a:latin typeface="Calibri"/>
+                <a:ea typeface="Calibri"/>
+                <a:cs typeface="Calibri"/>
+              </a:rPr>
+              <a:t>F</a:t>
+            </a:r>
+            <a:r>
+              <a:rPr sz="2550" b="1">
+                <a:solidFill>
+                  <a:srgbClr val="064F91"/>
+                </a:solidFill>
+                <a:latin typeface="Calibri"/>
+                <a:ea typeface="Calibri"/>
+                <a:cs typeface="Calibri"/>
+              </a:rPr>
+              <a:t>?</a:t>
             </a:r>
           </a:p>
         </p:txBody>
@@ -16129,64 +16782,6 @@
       </p:sp>
       <p:sp>
         <p:nvSpPr>
-          <p:cNvPr id="6" name="Källor och lärarstöd finns även i bildanteckningarna.">
-            <a:extLst xmlns:a="http://schemas.openxmlformats.org/drawingml/2006/main">
-              <a:ext uri="{FF2B5EF4-FFF2-40B4-BE49-F238E27FC236}">
-                <a16:creationId xmlns:a16="http://schemas.microsoft.com/office/drawing/2014/main" id="{AE78F7BC-E9EE-450B-AAC0-401DBB4118AD}"/>
-              </a:ext>
-            </a:extLst>
-          </p:cNvPr>
-          <p:cNvSpPr>
-            <a:spLocks xmlns:a="http://schemas.openxmlformats.org/drawingml/2006/main" noGrp="1"/>
-          </p:cNvSpPr>
-          <p:nvPr/>
-        </p:nvSpPr>
-        <p:spPr>
-          <a:xfrm xmlns:a="http://schemas.openxmlformats.org/drawingml/2006/main">
-            <a:off x="762000" y="5676900"/>
-            <a:ext cx="7620000" cy="352425"/>
-          </a:xfrm>
-          <a:prstGeom xmlns:a="http://schemas.openxmlformats.org/drawingml/2006/main" prst="rect">
-            <a:avLst/>
-          </a:prstGeom>
-          <a:noFill xmlns:a="http://schemas.openxmlformats.org/drawingml/2006/main"/>
-          <a:ln xmlns:a="http://schemas.openxmlformats.org/drawingml/2006/main" w="0">
-            <a:noFill/>
-          </a:ln>
-        </p:spPr>
-        <p:txBody>
-          <a:bodyPr xmlns:a="http://schemas.openxmlformats.org/drawingml/2006/main" wrap="square" lIns="0" tIns="0" rIns="0" bIns="0" anchor="t">
-            <a:noAutofit/>
-          </a:bodyPr>
-          <a:lstStyle xmlns:a="http://schemas.openxmlformats.org/drawingml/2006/main"/>
-          <a:p xmlns:a="http://schemas.openxmlformats.org/drawingml/2006/main">
-            <a:pPr algn="l">
-              <a:buNone/>
-              <a:defRPr sz="1800" b="0">
-                <a:solidFill>
-                  <a:srgbClr val="111111"/>
-                </a:solidFill>
-                <a:latin typeface="Calibri"/>
-                <a:ea typeface="Calibri"/>
-                <a:cs typeface="Calibri"/>
-              </a:defRPr>
-            </a:pPr>
-            <a:r>
-              <a:rPr sz="1800" b="0">
-                <a:solidFill>
-                  <a:srgbClr val="111111"/>
-                </a:solidFill>
-                <a:latin typeface="Calibri"/>
-                <a:ea typeface="Calibri"/>
-                <a:cs typeface="Calibri"/>
-              </a:rPr>
-              <a:t>Källor och lärarstöd finns även i bildanteckningarna.</a:t>
-            </a:r>
-          </a:p>
-        </p:txBody>
-      </p:sp>
-      <p:sp>
-        <p:nvSpPr>
           <p:cNvPr id="7" name="22">
             <a:extLst xmlns:a="http://schemas.openxmlformats.org/drawingml/2006/main">
               <a:ext uri="{FF2B5EF4-FFF2-40B4-BE49-F238E27FC236}">
@@ -16348,7 +16943,7 @@
       </p:sp>
       <p:sp>
         <p:nvSpPr>
-          <p:cNvPr id="10" name="Uᴸ mäts mellan två faser och kallas även huvudspänning.">
+          <p:cNvPr id="10" name="UL mäts mellan två faser och kallas även huvudspänning.">
             <a:extLst xmlns:a="http://schemas.openxmlformats.org/drawingml/2006/main">
               <a:ext uri="{FF2B5EF4-FFF2-40B4-BE49-F238E27FC236}">
                 <a16:creationId xmlns:a16="http://schemas.microsoft.com/office/drawing/2014/main" id="{A5005403-33F4-4DA3-8A26-4EDEB8CBF7D0}"/>
@@ -16398,14 +16993,36 @@
                 <a:ea typeface="Calibri"/>
                 <a:cs typeface="Calibri"/>
               </a:rPr>
-              <a:t>Uᴸ mäts mellan två faser och kallas även huvudspänning.</a:t>
-            </a:r>
-          </a:p>
-        </p:txBody>
-      </p:sp>
-      <p:sp>
-        <p:nvSpPr>
-          <p:cNvPr id="11" name="Uꜰ mäts mellan en fas och källans neutralpunkt.">
+              <a:t>U</a:t>
+            </a:r>
+            <a:r>
+              <a:rPr sz="2250" b="0" baseline="-25000">
+                <a:solidFill>
+                  <a:srgbClr val="111111"/>
+                </a:solidFill>
+                <a:latin typeface="Calibri"/>
+                <a:ea typeface="Calibri"/>
+                <a:cs typeface="Calibri"/>
+              </a:rPr>
+              <a:t>L</a:t>
+            </a:r>
+            <a:r>
+              <a:rPr sz="2250" b="0">
+                <a:solidFill>
+                  <a:srgbClr val="111111"/>
+                </a:solidFill>
+                <a:latin typeface="Calibri"/>
+                <a:ea typeface="Calibri"/>
+                <a:cs typeface="Calibri"/>
+              </a:rPr>
+              <a:t> mäts mellan två faser och kallas även huvudspänning.</a:t>
+            </a:r>
+          </a:p>
+        </p:txBody>
+      </p:sp>
+      <p:sp>
+        <p:nvSpPr>
+          <p:cNvPr id="11" name="UF mäts mellan en fas och källans neutralpunkt.">
             <a:extLst xmlns:a="http://schemas.openxmlformats.org/drawingml/2006/main">
               <a:ext uri="{FF2B5EF4-FFF2-40B4-BE49-F238E27FC236}">
                 <a16:creationId xmlns:a16="http://schemas.microsoft.com/office/drawing/2014/main" id="{221797B2-5F83-4BE9-98C2-B19CE9AD2451}"/>
@@ -16455,7 +17072,29 @@
                 <a:ea typeface="Calibri"/>
                 <a:cs typeface="Calibri"/>
               </a:rPr>
-              <a:t>Uꜰ mäts mellan en fas och källans neutralpunkt.</a:t>
+              <a:t>U</a:t>
+            </a:r>
+            <a:r>
+              <a:rPr sz="2250" b="0" baseline="-25000">
+                <a:solidFill>
+                  <a:srgbClr val="111111"/>
+                </a:solidFill>
+                <a:latin typeface="Calibri"/>
+                <a:ea typeface="Calibri"/>
+                <a:cs typeface="Calibri"/>
+              </a:rPr>
+              <a:t>F</a:t>
+            </a:r>
+            <a:r>
+              <a:rPr sz="2250" b="0">
+                <a:solidFill>
+                  <a:srgbClr val="111111"/>
+                </a:solidFill>
+                <a:latin typeface="Calibri"/>
+                <a:ea typeface="Calibri"/>
+                <a:cs typeface="Calibri"/>
+              </a:rPr>
+              <a:t> mäts mellan en fas och källans neutralpunkt.</a:t>
             </a:r>
           </a:p>
         </p:txBody>
@@ -17662,7 +18301,7 @@
       </p:sp>
       <p:sp>
         <p:nvSpPr>
-          <p:cNvPr id="3" name="Fasspänning Uꜰ: mellan fas och källans neutralpunkt.&#10;Linjespännin">
+          <p:cNvPr id="3" name="Fasspänning UF: mellan fas och källans neutralpunkt.&#10;Linjespännin">
             <a:extLst xmlns:a="http://schemas.openxmlformats.org/drawingml/2006/main">
               <a:ext uri="{FF2B5EF4-FFF2-40B4-BE49-F238E27FC236}">
                 <a16:creationId xmlns:a16="http://schemas.microsoft.com/office/drawing/2014/main" id="{371A25E3-E2BE-4FFB-A83B-21D3BD190A89}"/>
@@ -17677,7 +18316,7 @@
         <p:spPr>
           <a:xfrm xmlns:a="http://schemas.openxmlformats.org/drawingml/2006/main">
             <a:off x="762000" y="1619250"/>
-            <a:ext cx="7620000" cy="1466850"/>
+            <a:ext cx="3977639" cy="1466850"/>
           </a:xfrm>
           <a:prstGeom xmlns:a="http://schemas.openxmlformats.org/drawingml/2006/main" prst="rect">
             <a:avLst/>
@@ -17705,15 +18344,37 @@
               </a:defRPr>
             </a:pPr>
             <a:r>
-              <a:rPr sz="2400" b="0">
-                <a:solidFill>
-                  <a:srgbClr val="111111"/>
-                </a:solidFill>
-                <a:latin typeface="Calibri"/>
-                <a:ea typeface="Calibri"/>
-                <a:cs typeface="Calibri"/>
-              </a:rPr>
-              <a:t>Fasspänning Uꜰ: mellan fas och källans neutralpunkt.</a:t>
+              <a:rPr sz="1800" b="0">
+                <a:solidFill>
+                  <a:srgbClr val="111111"/>
+                </a:solidFill>
+                <a:latin typeface="Calibri"/>
+                <a:ea typeface="Calibri"/>
+                <a:cs typeface="Calibri"/>
+              </a:rPr>
+              <a:t>Fasspänning U</a:t>
+            </a:r>
+            <a:r>
+              <a:rPr sz="1800" b="0" baseline="-25000">
+                <a:solidFill>
+                  <a:srgbClr val="111111"/>
+                </a:solidFill>
+                <a:latin typeface="Calibri"/>
+                <a:ea typeface="Calibri"/>
+                <a:cs typeface="Calibri"/>
+              </a:rPr>
+              <a:t>F</a:t>
+            </a:r>
+            <a:r>
+              <a:rPr sz="1800" b="0">
+                <a:solidFill>
+                  <a:srgbClr val="111111"/>
+                </a:solidFill>
+                <a:latin typeface="Calibri"/>
+                <a:ea typeface="Calibri"/>
+                <a:cs typeface="Calibri"/>
+              </a:rPr>
+              <a:t>: mellan fas och källans neutralpunkt.</a:t>
             </a:r>
           </a:p>
           <a:p xmlns:a="http://schemas.openxmlformats.org/drawingml/2006/main">
@@ -17729,22 +18390,44 @@
               </a:defRPr>
             </a:pPr>
             <a:r>
-              <a:rPr sz="2400" b="0">
-                <a:solidFill>
-                  <a:srgbClr val="111111"/>
-                </a:solidFill>
-                <a:latin typeface="Calibri"/>
-                <a:ea typeface="Calibri"/>
-                <a:cs typeface="Calibri"/>
-              </a:rPr>
-              <a:t>Linjespänning Uᴸ: mellan två faser, även kallad huvudspänning.</a:t>
-            </a:r>
-          </a:p>
-        </p:txBody>
-      </p:sp>
-      <p:sp>
-        <p:nvSpPr>
-          <p:cNvPr id="4" name="Uᴸ = √3 · Uꜰ">
+              <a:rPr sz="1800" b="0">
+                <a:solidFill>
+                  <a:srgbClr val="111111"/>
+                </a:solidFill>
+                <a:latin typeface="Calibri"/>
+                <a:ea typeface="Calibri"/>
+                <a:cs typeface="Calibri"/>
+              </a:rPr>
+              <a:t>Linjespänning U</a:t>
+            </a:r>
+            <a:r>
+              <a:rPr sz="1800" b="0" baseline="-25000">
+                <a:solidFill>
+                  <a:srgbClr val="111111"/>
+                </a:solidFill>
+                <a:latin typeface="Calibri"/>
+                <a:ea typeface="Calibri"/>
+                <a:cs typeface="Calibri"/>
+              </a:rPr>
+              <a:t>L</a:t>
+            </a:r>
+            <a:r>
+              <a:rPr sz="1800" b="0">
+                <a:solidFill>
+                  <a:srgbClr val="111111"/>
+                </a:solidFill>
+                <a:latin typeface="Calibri"/>
+                <a:ea typeface="Calibri"/>
+                <a:cs typeface="Calibri"/>
+              </a:rPr>
+              <a:t>: mellan två faser, även kallad huvudspänning.</a:t>
+            </a:r>
+          </a:p>
+        </p:txBody>
+      </p:sp>
+      <p:sp>
+        <p:nvSpPr>
+          <p:cNvPr id="4" name="UL = √3 · UF">
             <a:extLst xmlns:a="http://schemas.openxmlformats.org/drawingml/2006/main">
               <a:ext uri="{FF2B5EF4-FFF2-40B4-BE49-F238E27FC236}">
                 <a16:creationId xmlns:a16="http://schemas.microsoft.com/office/drawing/2014/main" id="{B86F4B34-4E16-490A-ABFD-A29D3E807BF5}"/>
@@ -17759,7 +18442,7 @@
         <p:spPr>
           <a:xfrm xmlns:a="http://schemas.openxmlformats.org/drawingml/2006/main">
             <a:off x="762000" y="3200400"/>
-            <a:ext cx="7620000" cy="838200"/>
+            <a:ext cx="3977639" cy="838200"/>
           </a:xfrm>
           <a:prstGeom xmlns:a="http://schemas.openxmlformats.org/drawingml/2006/main" prst="rect">
             <a:avLst/>
@@ -17795,14 +18478,47 @@
                 <a:ea typeface="Calibri"/>
                 <a:cs typeface="Calibri"/>
               </a:rPr>
-              <a:t>Uᴸ = √3 · Uꜰ</a:t>
-            </a:r>
-          </a:p>
-        </p:txBody>
-      </p:sp>
-      <p:sp>
-        <p:nvSpPr>
-          <p:cNvPr id="5" name="I ett symmetriskt 400 V-system är Uꜰ ≈ 231 V.&#10;Använd inte 400 V s">
+              <a:t>U</a:t>
+            </a:r>
+            <a:r>
+              <a:rPr sz="2925" b="1" baseline="-25000">
+                <a:solidFill>
+                  <a:srgbClr val="064F91"/>
+                </a:solidFill>
+                <a:latin typeface="Calibri"/>
+                <a:ea typeface="Calibri"/>
+                <a:cs typeface="Calibri"/>
+              </a:rPr>
+              <a:t>L</a:t>
+            </a:r>
+            <a:r>
+              <a:rPr sz="2925" b="1">
+                <a:solidFill>
+                  <a:srgbClr val="064F91"/>
+                </a:solidFill>
+                <a:latin typeface="Calibri"/>
+                <a:ea typeface="Calibri"/>
+                <a:cs typeface="Calibri"/>
+              </a:rPr>
+              <a:t> = √3 · U</a:t>
+            </a:r>
+            <a:r>
+              <a:rPr sz="2925" b="1" baseline="-25000">
+                <a:solidFill>
+                  <a:srgbClr val="064F91"/>
+                </a:solidFill>
+                <a:latin typeface="Calibri"/>
+                <a:ea typeface="Calibri"/>
+                <a:cs typeface="Calibri"/>
+              </a:rPr>
+              <a:t>F</a:t>
+            </a:r>
+          </a:p>
+        </p:txBody>
+      </p:sp>
+      <p:sp>
+        <p:nvSpPr>
+          <p:cNvPr id="5" name="I ett symmetriskt 400 V-system är UF ≈ 231 V.&#10;Använd inte 400 V s">
             <a:extLst xmlns:a="http://schemas.openxmlformats.org/drawingml/2006/main">
               <a:ext uri="{FF2B5EF4-FFF2-40B4-BE49-F238E27FC236}">
                 <a16:creationId xmlns:a16="http://schemas.microsoft.com/office/drawing/2014/main" id="{B39D32FC-6D48-4E43-A113-3FB2AC56690E}"/>
@@ -17817,7 +18533,7 @@
         <p:spPr>
           <a:xfrm xmlns:a="http://schemas.openxmlformats.org/drawingml/2006/main">
             <a:off x="762000" y="4429125"/>
-            <a:ext cx="7620000" cy="1352550"/>
+            <a:ext cx="3977639" cy="1352550"/>
           </a:xfrm>
           <a:prstGeom xmlns:a="http://schemas.openxmlformats.org/drawingml/2006/main" prst="rect">
             <a:avLst/>
@@ -17845,15 +18561,37 @@
               </a:defRPr>
             </a:pPr>
             <a:r>
-              <a:rPr sz="2250" b="0">
-                <a:solidFill>
-                  <a:srgbClr val="111111"/>
-                </a:solidFill>
-                <a:latin typeface="Calibri"/>
-                <a:ea typeface="Calibri"/>
-                <a:cs typeface="Calibri"/>
-              </a:rPr>
-              <a:t>I ett symmetriskt 400 V-system är Uꜰ ≈ 231 V.</a:t>
+              <a:rPr sz="2100" b="0">
+                <a:solidFill>
+                  <a:srgbClr val="111111"/>
+                </a:solidFill>
+                <a:latin typeface="Calibri"/>
+                <a:ea typeface="Calibri"/>
+                <a:cs typeface="Calibri"/>
+              </a:rPr>
+              <a:t>Ombord är 440 V vanligt: då är U</a:t>
+            </a:r>
+            <a:r>
+              <a:rPr sz="2100" b="0" baseline="-25000">
+                <a:solidFill>
+                  <a:srgbClr val="111111"/>
+                </a:solidFill>
+                <a:latin typeface="Calibri"/>
+                <a:ea typeface="Calibri"/>
+                <a:cs typeface="Calibri"/>
+              </a:rPr>
+              <a:t>F</a:t>
+            </a:r>
+            <a:r>
+              <a:rPr sz="2100" b="0">
+                <a:solidFill>
+                  <a:srgbClr val="111111"/>
+                </a:solidFill>
+                <a:latin typeface="Calibri"/>
+                <a:ea typeface="Calibri"/>
+                <a:cs typeface="Calibri"/>
+              </a:rPr>
+              <a:t> ≈ 254 V.</a:t>
             </a:r>
           </a:p>
           <a:p xmlns:a="http://schemas.openxmlformats.org/drawingml/2006/main">
@@ -17869,15 +18607,15 @@
               </a:defRPr>
             </a:pPr>
             <a:r>
-              <a:rPr sz="2250" b="0">
-                <a:solidFill>
-                  <a:srgbClr val="111111"/>
-                </a:solidFill>
-                <a:latin typeface="Calibri"/>
-                <a:ea typeface="Calibri"/>
-                <a:cs typeface="Calibri"/>
-              </a:rPr>
-              <a:t>Använd inte 400 V som fas–neutralspänning.</a:t>
+              <a:rPr sz="2100" b="0">
+                <a:solidFill>
+                  <a:srgbClr val="111111"/>
+                </a:solidFill>
+                <a:latin typeface="Calibri"/>
+                <a:ea typeface="Calibri"/>
+                <a:cs typeface="Calibri"/>
+              </a:rPr>
+              <a:t>Använd inte linjespänningen som fas–neutralspänning.</a:t>
             </a:r>
           </a:p>
         </p:txBody>
@@ -17940,6 +18678,30 @@
           </a:p>
         </p:txBody>
       </p:sp>
+      <p:pic xmlns:a="http://schemas.openxmlformats.org/drawingml/2006/main" xmlns:r="http://schemas.openxmlformats.org/officeDocument/2006/relationships">
+        <p:nvPicPr>
+          <p:cNvPr id="9" name="Figur: Tre fasspänningsvisare 120 grader isär; " descr="Tre fasspänningsvisare 120 grader isär; linjespänningen U12 är sträckan mellan två visarspetsar"/>
+          <p:cNvPicPr>
+            <a:picLocks noChangeAspect="1"/>
+          </p:cNvPicPr>
+          <p:nvPr/>
+        </p:nvPicPr>
+        <p:blipFill>
+          <a:blip r:embed="rId3"/>
+          <a:stretch>
+            <a:fillRect/>
+          </a:stretch>
+        </p:blipFill>
+        <p:spPr>
+          <a:xfrm>
+            <a:off x="4892040" y="1645920"/>
+            <a:ext cx="3886200" cy="3252383"/>
+          </a:xfrm>
+          <a:prstGeom prst="rect">
+            <a:avLst/>
+          </a:prstGeom>
+        </p:spPr>
+      </p:pic>
     </p:spTree>
     <p:extLst>
       <p:ext uri="{BB962C8B-B14F-4D97-AF65-F5344CB8AC3E}">
@@ -18061,7 +18823,7 @@
         <p:spPr>
           <a:xfrm xmlns:a="http://schemas.openxmlformats.org/drawingml/2006/main">
             <a:off x="762000" y="1619250"/>
-            <a:ext cx="7620000" cy="1466850"/>
+            <a:ext cx="3977639" cy="1466850"/>
           </a:xfrm>
           <a:prstGeom xmlns:a="http://schemas.openxmlformats.org/drawingml/2006/main" prst="rect">
             <a:avLst/>
@@ -18089,7 +18851,7 @@
               </a:defRPr>
             </a:pPr>
             <a:r>
-              <a:rPr sz="2400" b="0">
+              <a:rPr sz="2200" b="0">
                 <a:solidFill>
                   <a:srgbClr val="111111"/>
                 </a:solidFill>
@@ -18113,7 +18875,7 @@
               </a:defRPr>
             </a:pPr>
             <a:r>
-              <a:rPr sz="2400" b="0">
+              <a:rPr sz="2200" b="0">
                 <a:solidFill>
                   <a:srgbClr val="111111"/>
                 </a:solidFill>
@@ -18128,7 +18890,7 @@
       </p:sp>
       <p:sp>
         <p:nvSpPr>
-          <p:cNvPr id="4" name="Uᴸ² = Uꜰ² + Uꜰ² − 2Uꜰ² cos 120°">
+          <p:cNvPr id="4" name="UL² = UF² + UF² − 2UF² cos 120°">
             <a:extLst xmlns:a="http://schemas.openxmlformats.org/drawingml/2006/main">
               <a:ext uri="{FF2B5EF4-FFF2-40B4-BE49-F238E27FC236}">
                 <a16:creationId xmlns:a16="http://schemas.microsoft.com/office/drawing/2014/main" id="{FBC03102-DDD6-4D28-9712-FD5015CCE20C}"/>
@@ -18143,7 +18905,7 @@
         <p:spPr>
           <a:xfrm xmlns:a="http://schemas.openxmlformats.org/drawingml/2006/main">
             <a:off x="762000" y="3200400"/>
-            <a:ext cx="7620000" cy="838200"/>
+            <a:ext cx="3977639" cy="838200"/>
           </a:xfrm>
           <a:prstGeom xmlns:a="http://schemas.openxmlformats.org/drawingml/2006/main" prst="rect">
             <a:avLst/>
@@ -18171,7 +18933,7 @@
               </a:defRPr>
             </a:pPr>
             <a:r>
-              <a:rPr sz="2925" b="1">
+              <a:rPr sz="2650" b="1">
                 <a:solidFill>
                   <a:srgbClr val="064F91"/>
                 </a:solidFill>
@@ -18179,14 +18941,102 @@
                 <a:ea typeface="Calibri"/>
                 <a:cs typeface="Calibri"/>
               </a:rPr>
-              <a:t>Uᴸ² = Uꜰ² + Uꜰ² − 2Uꜰ² cos 120°</a:t>
-            </a:r>
-          </a:p>
-        </p:txBody>
-      </p:sp>
-      <p:sp>
-        <p:nvSpPr>
-          <p:cNvPr id="5" name="cos 120° = −0,5 ger Uᴸ² = 3Uꜰ².&#10;Därför blir Uᴸ = √3 Uꜰ.">
+              <a:t>U</a:t>
+            </a:r>
+            <a:r>
+              <a:rPr sz="2650" b="1" baseline="-25000">
+                <a:solidFill>
+                  <a:srgbClr val="064F91"/>
+                </a:solidFill>
+                <a:latin typeface="Calibri"/>
+                <a:ea typeface="Calibri"/>
+                <a:cs typeface="Calibri"/>
+              </a:rPr>
+              <a:t>L</a:t>
+            </a:r>
+            <a:r>
+              <a:rPr sz="2650" b="1">
+                <a:solidFill>
+                  <a:srgbClr val="064F91"/>
+                </a:solidFill>
+                <a:latin typeface="Calibri"/>
+                <a:ea typeface="Calibri"/>
+                <a:cs typeface="Calibri"/>
+              </a:rPr>
+              <a:t>² = U</a:t>
+            </a:r>
+            <a:r>
+              <a:rPr sz="2650" b="1" baseline="-25000">
+                <a:solidFill>
+                  <a:srgbClr val="064F91"/>
+                </a:solidFill>
+                <a:latin typeface="Calibri"/>
+                <a:ea typeface="Calibri"/>
+                <a:cs typeface="Calibri"/>
+              </a:rPr>
+              <a:t>F</a:t>
+            </a:r>
+            <a:r>
+              <a:rPr sz="2650" b="1">
+                <a:solidFill>
+                  <a:srgbClr val="064F91"/>
+                </a:solidFill>
+                <a:latin typeface="Calibri"/>
+                <a:ea typeface="Calibri"/>
+                <a:cs typeface="Calibri"/>
+              </a:rPr>
+              <a:t>² + U</a:t>
+            </a:r>
+            <a:r>
+              <a:rPr sz="2650" b="1" baseline="-25000">
+                <a:solidFill>
+                  <a:srgbClr val="064F91"/>
+                </a:solidFill>
+                <a:latin typeface="Calibri"/>
+                <a:ea typeface="Calibri"/>
+                <a:cs typeface="Calibri"/>
+              </a:rPr>
+              <a:t>F</a:t>
+            </a:r>
+            <a:r>
+              <a:rPr sz="2650" b="1">
+                <a:solidFill>
+                  <a:srgbClr val="064F91"/>
+                </a:solidFill>
+                <a:latin typeface="Calibri"/>
+                <a:ea typeface="Calibri"/>
+                <a:cs typeface="Calibri"/>
+              </a:rPr>
+              <a:t>² − 2U</a:t>
+            </a:r>
+            <a:r>
+              <a:rPr sz="2650" b="1" baseline="-25000">
+                <a:solidFill>
+                  <a:srgbClr val="064F91"/>
+                </a:solidFill>
+                <a:latin typeface="Calibri"/>
+                <a:ea typeface="Calibri"/>
+                <a:cs typeface="Calibri"/>
+              </a:rPr>
+              <a:t>F</a:t>
+            </a:r>
+            <a:r>
+              <a:rPr sz="2650" b="1">
+                <a:solidFill>
+                  <a:srgbClr val="064F91"/>
+                </a:solidFill>
+                <a:latin typeface="Calibri"/>
+                <a:ea typeface="Calibri"/>
+                <a:cs typeface="Calibri"/>
+              </a:rPr>
+              <a:t>² cos 120°</a:t>
+            </a:r>
+          </a:p>
+        </p:txBody>
+      </p:sp>
+      <p:sp>
+        <p:nvSpPr>
+          <p:cNvPr id="5" name="cos 120° = −0,5 ger UL² = 3UF².&#10;Därför blir UL = √3 UF.">
             <a:extLst xmlns:a="http://schemas.openxmlformats.org/drawingml/2006/main">
               <a:ext uri="{FF2B5EF4-FFF2-40B4-BE49-F238E27FC236}">
                 <a16:creationId xmlns:a16="http://schemas.microsoft.com/office/drawing/2014/main" id="{A53BA81C-D003-4770-B757-BF38CDA1B2C2}"/>
@@ -18201,7 +19051,7 @@
         <p:spPr>
           <a:xfrm xmlns:a="http://schemas.openxmlformats.org/drawingml/2006/main">
             <a:off x="762000" y="4429125"/>
-            <a:ext cx="7620000" cy="1352550"/>
+            <a:ext cx="3977639" cy="1352550"/>
           </a:xfrm>
           <a:prstGeom xmlns:a="http://schemas.openxmlformats.org/drawingml/2006/main" prst="rect">
             <a:avLst/>
@@ -18237,7 +19087,51 @@
                 <a:ea typeface="Calibri"/>
                 <a:cs typeface="Calibri"/>
               </a:rPr>
-              <a:t>cos 120° = −0,5 ger Uᴸ² = 3Uꜰ².</a:t>
+              <a:t>cos 120° = −0,5 ger U</a:t>
+            </a:r>
+            <a:r>
+              <a:rPr sz="2250" b="0" baseline="-25000">
+                <a:solidFill>
+                  <a:srgbClr val="111111"/>
+                </a:solidFill>
+                <a:latin typeface="Calibri"/>
+                <a:ea typeface="Calibri"/>
+                <a:cs typeface="Calibri"/>
+              </a:rPr>
+              <a:t>L</a:t>
+            </a:r>
+            <a:r>
+              <a:rPr sz="2250" b="0">
+                <a:solidFill>
+                  <a:srgbClr val="111111"/>
+                </a:solidFill>
+                <a:latin typeface="Calibri"/>
+                <a:ea typeface="Calibri"/>
+                <a:cs typeface="Calibri"/>
+              </a:rPr>
+              <a:t>² = 3U</a:t>
+            </a:r>
+            <a:r>
+              <a:rPr sz="2250" b="0" baseline="-25000">
+                <a:solidFill>
+                  <a:srgbClr val="111111"/>
+                </a:solidFill>
+                <a:latin typeface="Calibri"/>
+                <a:ea typeface="Calibri"/>
+                <a:cs typeface="Calibri"/>
+              </a:rPr>
+              <a:t>F</a:t>
+            </a:r>
+            <a:r>
+              <a:rPr sz="2250" b="0">
+                <a:solidFill>
+                  <a:srgbClr val="111111"/>
+                </a:solidFill>
+                <a:latin typeface="Calibri"/>
+                <a:ea typeface="Calibri"/>
+                <a:cs typeface="Calibri"/>
+              </a:rPr>
+              <a:t>².</a:t>
             </a:r>
           </a:p>
           <a:p xmlns:a="http://schemas.openxmlformats.org/drawingml/2006/main">
@@ -18261,7 +19155,51 @@
                 <a:ea typeface="Calibri"/>
                 <a:cs typeface="Calibri"/>
               </a:rPr>
-              <a:t>Därför blir Uᴸ = √3 Uꜰ.</a:t>
+              <a:t>Därför blir U</a:t>
+            </a:r>
+            <a:r>
+              <a:rPr sz="2250" b="0" baseline="-25000">
+                <a:solidFill>
+                  <a:srgbClr val="111111"/>
+                </a:solidFill>
+                <a:latin typeface="Calibri"/>
+                <a:ea typeface="Calibri"/>
+                <a:cs typeface="Calibri"/>
+              </a:rPr>
+              <a:t>L</a:t>
+            </a:r>
+            <a:r>
+              <a:rPr sz="2250" b="0">
+                <a:solidFill>
+                  <a:srgbClr val="111111"/>
+                </a:solidFill>
+                <a:latin typeface="Calibri"/>
+                <a:ea typeface="Calibri"/>
+                <a:cs typeface="Calibri"/>
+              </a:rPr>
+              <a:t> = √3 U</a:t>
+            </a:r>
+            <a:r>
+              <a:rPr sz="2250" b="0" baseline="-25000">
+                <a:solidFill>
+                  <a:srgbClr val="111111"/>
+                </a:solidFill>
+                <a:latin typeface="Calibri"/>
+                <a:ea typeface="Calibri"/>
+                <a:cs typeface="Calibri"/>
+              </a:rPr>
+              <a:t>F</a:t>
+            </a:r>
+            <a:r>
+              <a:rPr sz="2250" b="0">
+                <a:solidFill>
+                  <a:srgbClr val="111111"/>
+                </a:solidFill>
+                <a:latin typeface="Calibri"/>
+                <a:ea typeface="Calibri"/>
+                <a:cs typeface="Calibri"/>
+              </a:rPr>
+              <a:t>.</a:t>
             </a:r>
           </a:p>
         </p:txBody>
@@ -18324,6 +19262,30 @@
           </a:p>
         </p:txBody>
       </p:sp>
+      <p:pic xmlns:a="http://schemas.openxmlformats.org/drawingml/2006/main" xmlns:r="http://schemas.openxmlformats.org/officeDocument/2006/relationships">
+        <p:nvPicPr>
+          <p:cNvPr id="9" name="Figur: Linjespänningen U12 som skillnaden mella" descr="Linjespänningen U12 som skillnaden mellan fasvisarna U1N och U2N med 120 grader mellan dem"/>
+          <p:cNvPicPr>
+            <a:picLocks noChangeAspect="1"/>
+          </p:cNvPicPr>
+          <p:nvPr/>
+        </p:nvPicPr>
+        <p:blipFill>
+          <a:blip r:embed="rId3"/>
+          <a:stretch>
+            <a:fillRect/>
+          </a:stretch>
+        </p:blipFill>
+        <p:spPr>
+          <a:xfrm>
+            <a:off x="4892040" y="1645920"/>
+            <a:ext cx="3886200" cy="3252383"/>
+          </a:xfrm>
+          <a:prstGeom prst="rect">
+            <a:avLst/>
+          </a:prstGeom>
+        </p:spPr>
+      </p:pic>
     </p:spTree>
     <p:extLst>
       <p:ext uri="{BB962C8B-B14F-4D97-AF65-F5344CB8AC3E}">
@@ -18429,7 +19391,7 @@
       </p:sp>
       <p:sp>
         <p:nvSpPr>
-          <p:cNvPr id="10" name="En symmetrisk trefaskälla ger Uꜰ = 100 V vid f = 60 Hz. Sök Uᴸ oc">
+          <p:cNvPr id="10" name="En symmetrisk trefaskälla ger UF = 100 V vid f = 60 Hz. Sök UL oc">
             <a:extLst xmlns:a="http://schemas.openxmlformats.org/drawingml/2006/main">
               <a:ext uri="{FF2B5EF4-FFF2-40B4-BE49-F238E27FC236}">
                 <a16:creationId xmlns:a16="http://schemas.microsoft.com/office/drawing/2014/main" id="{41F0F78C-990B-433E-BA30-5139AF5AB51C}"/>
@@ -18479,14 +19441,58 @@
                 <a:ea typeface="Calibri"/>
                 <a:cs typeface="Calibri"/>
               </a:rPr>
-              <a:t>En symmetrisk trefaskälla ger Uꜰ = 100 V vid f = 60 Hz. Sök Uᴸ och tidsavståndet 120°.</a:t>
-            </a:r>
-          </a:p>
-        </p:txBody>
-      </p:sp>
-      <p:sp>
-        <p:nvSpPr>
-          <p:cNvPr id="11" name="Uᴸ = √3 Uꜰ     Δt = (1/f)/3">
+              <a:t>En symmetrisk trefaskälla ger U</a:t>
+            </a:r>
+            <a:r>
+              <a:rPr sz="2175" b="0" baseline="-25000">
+                <a:solidFill>
+                  <a:srgbClr val="111111"/>
+                </a:solidFill>
+                <a:latin typeface="Calibri"/>
+                <a:ea typeface="Calibri"/>
+                <a:cs typeface="Calibri"/>
+              </a:rPr>
+              <a:t>F</a:t>
+            </a:r>
+            <a:r>
+              <a:rPr sz="2175" b="0">
+                <a:solidFill>
+                  <a:srgbClr val="111111"/>
+                </a:solidFill>
+                <a:latin typeface="Calibri"/>
+                <a:ea typeface="Calibri"/>
+                <a:cs typeface="Calibri"/>
+              </a:rPr>
+              <a:t> = 100 V vid f = 60 Hz. Sök U</a:t>
+            </a:r>
+            <a:r>
+              <a:rPr sz="2175" b="0" baseline="-25000">
+                <a:solidFill>
+                  <a:srgbClr val="111111"/>
+                </a:solidFill>
+                <a:latin typeface="Calibri"/>
+                <a:ea typeface="Calibri"/>
+                <a:cs typeface="Calibri"/>
+              </a:rPr>
+              <a:t>L</a:t>
+            </a:r>
+            <a:r>
+              <a:rPr sz="2175" b="0">
+                <a:solidFill>
+                  <a:srgbClr val="111111"/>
+                </a:solidFill>
+                <a:latin typeface="Calibri"/>
+                <a:ea typeface="Calibri"/>
+                <a:cs typeface="Calibri"/>
+              </a:rPr>
+              <a:t> och tidsavståndet 120°.</a:t>
+            </a:r>
+          </a:p>
+        </p:txBody>
+      </p:sp>
+      <p:sp>
+        <p:nvSpPr>
+          <p:cNvPr id="11" name="UL = √3 UF     Δt = (1/f)/3">
             <a:extLst xmlns:a="http://schemas.openxmlformats.org/drawingml/2006/main">
               <a:ext uri="{FF2B5EF4-FFF2-40B4-BE49-F238E27FC236}">
                 <a16:creationId xmlns:a16="http://schemas.microsoft.com/office/drawing/2014/main" id="{5A600AFE-7C15-473C-93C8-41E07A947F05}"/>
@@ -18536,14 +19542,58 @@
                 <a:ea typeface="Calibri"/>
                 <a:cs typeface="Calibri"/>
               </a:rPr>
-              <a:t>Uᴸ = √3 Uꜰ     Δt = (1/f)/3</a:t>
-            </a:r>
-          </a:p>
-        </p:txBody>
-      </p:sp>
-      <p:sp>
-        <p:nvSpPr>
-          <p:cNvPr id="12" name="1. Uᴸ = √3 · 100 ≈ 173,2 V.&#10;2. T = 1/60 ≈ 0,01667 s = 16,67 ms.&#10;3">
+              <a:t>U</a:t>
+            </a:r>
+            <a:r>
+              <a:rPr sz="2325" b="1" baseline="-25000">
+                <a:solidFill>
+                  <a:srgbClr val="064F91"/>
+                </a:solidFill>
+                <a:latin typeface="Calibri"/>
+                <a:ea typeface="Calibri"/>
+                <a:cs typeface="Calibri"/>
+              </a:rPr>
+              <a:t>L</a:t>
+            </a:r>
+            <a:r>
+              <a:rPr sz="2325" b="1">
+                <a:solidFill>
+                  <a:srgbClr val="064F91"/>
+                </a:solidFill>
+                <a:latin typeface="Calibri"/>
+                <a:ea typeface="Calibri"/>
+                <a:cs typeface="Calibri"/>
+              </a:rPr>
+              <a:t> = √3 U</a:t>
+            </a:r>
+            <a:r>
+              <a:rPr sz="2325" b="1" baseline="-25000">
+                <a:solidFill>
+                  <a:srgbClr val="064F91"/>
+                </a:solidFill>
+                <a:latin typeface="Calibri"/>
+                <a:ea typeface="Calibri"/>
+                <a:cs typeface="Calibri"/>
+              </a:rPr>
+              <a:t>F</a:t>
+            </a:r>
+            <a:r>
+              <a:rPr sz="2325" b="1">
+                <a:solidFill>
+                  <a:srgbClr val="064F91"/>
+                </a:solidFill>
+                <a:latin typeface="Calibri"/>
+                <a:ea typeface="Calibri"/>
+                <a:cs typeface="Calibri"/>
+              </a:rPr>
+              <a:t>     Δt = (1/f)/3</a:t>
+            </a:r>
+          </a:p>
+        </p:txBody>
+      </p:sp>
+      <p:sp>
+        <p:nvSpPr>
+          <p:cNvPr id="12" name="1. UL = √3 · 100 ≈ 173,2 V.&#10;2. T = 1/60 ≈ 0,01667 s = 16,67 ms.&#10;3">
             <a:extLst xmlns:a="http://schemas.openxmlformats.org/drawingml/2006/main">
               <a:ext uri="{FF2B5EF4-FFF2-40B4-BE49-F238E27FC236}">
                 <a16:creationId xmlns:a16="http://schemas.microsoft.com/office/drawing/2014/main" id="{7F45F91B-0AA8-445B-8C18-E922D76626B7}"/>
@@ -18593,7 +19643,29 @@
                 <a:ea typeface="Calibri"/>
                 <a:cs typeface="Calibri"/>
               </a:rPr>
-              <a:t>1. Uᴸ = √3 · 100 ≈ 173,2 V.</a:t>
+              <a:t>1. U</a:t>
+            </a:r>
+            <a:r>
+              <a:rPr sz="2063" b="0" baseline="-25000">
+                <a:solidFill>
+                  <a:srgbClr val="111111"/>
+                </a:solidFill>
+                <a:latin typeface="Calibri"/>
+                <a:ea typeface="Calibri"/>
+                <a:cs typeface="Calibri"/>
+              </a:rPr>
+              <a:t>L</a:t>
+            </a:r>
+            <a:r>
+              <a:rPr sz="2063" b="0">
+                <a:solidFill>
+                  <a:srgbClr val="111111"/>
+                </a:solidFill>
+                <a:latin typeface="Calibri"/>
+                <a:ea typeface="Calibri"/>
+                <a:cs typeface="Calibri"/>
+              </a:rPr>
+              <a:t> = √3 · 100 ≈ 173,2 V.</a:t>
             </a:r>
           </a:p>
           <a:p xmlns:a="http://schemas.openxmlformats.org/drawingml/2006/main">

</xml_diff>

<commit_message>
Vecka 41: lärargranskningens rättelser i presentationer, figurer och Trefaslabbet
- Nya exempeltal som inte upprepar övningarnas svar, stödbilder utan facit
- Rött endast för sökt storhet, svenska ordval (rigg i stället för tränare)
- Trefaslabbet: laster kopplas bort med kryssruta, R 5–300 Ω, uppgifter
  visar inte svaret grafiskt, lösningssteg efter svar, Δ som startläge

Co-Authored-By: Claude Opus 5.5 <noreply@anthropic.com>
Claude-Session: https://claude.ai/code/session_011V9KjBb53XrDm23Dw58SH3
</commit_message>
<xml_diff>
--- a/sjoskolan/vecka-41/aktuell/v41_01_Trefassystemets_grunder_elev.pptx
+++ b/sjoskolan/vecka-41/aktuell/v41_01_Trefassystemets_grunder_elev.pptx
@@ -5263,6 +5263,10 @@
             <a:noFill/>
           </a:ln>
         </p:spPr>
+        <p:txBody xmlns:a="http://schemas.openxmlformats.org/drawingml/2006/main">
+          <a:bodyPr/>
+          <a:p/>
+        </p:txBody>
       </p:sp>
       <p:sp>
         <p:nvSpPr>
@@ -6041,7 +6045,7 @@
                 <a:ea typeface="Calibri"/>
                 <a:cs typeface="Calibri"/>
               </a:rPr>
-              <a:t>Tre faser delar en hel period jämnt. Beräkna vinkel mellan faserna.</a:t>
+              <a:t>Tre faser delar en hel period jämnt. Beräkna vinkeln mellan faserna.</a:t>
             </a:r>
           </a:p>
         </p:txBody>
@@ -8974,7 +8978,7 @@
                 <a:ea typeface="Calibri"/>
                 <a:cs typeface="Calibri"/>
               </a:rPr>
-              <a:t>Förutsättningar: Avsedd tränare med U</a:t>
+              <a:t>Förutsättningar: Avsedd övningsrigg med U</a:t>
             </a:r>
             <a:r>
               <a:rPr sz="2025" b="0" baseline="-25000">
@@ -9272,7 +9276,7 @@
                 <a:ea typeface="Calibri"/>
                 <a:cs typeface="Calibri"/>
               </a:rPr>
-              <a:t>Trefastränaren</a:t>
+              <a:t>Trefasriggen</a:t>
             </a:r>
           </a:p>
         </p:txBody>
@@ -9330,7 +9334,7 @@
                 <a:ea typeface="Calibri"/>
                 <a:cs typeface="Calibri"/>
               </a:rPr>
-              <a:t>En avsedd trefastränare ger 12,0 V mellan faserna. Vilken spänning förväntas över varje gren i en symmetrisk Y-last?</a:t>
+              <a:t>En avsedd trefasrigg ger 12,0 V mellan faserna. Vilken spänning förväntas över varje gren i en symmetrisk Y-last?</a:t>
             </a:r>
           </a:p>
         </p:txBody>
@@ -12203,7 +12207,7 @@
                 <a:ea typeface="Calibri"/>
                 <a:cs typeface="Calibri"/>
               </a:rPr>
-              <a:t>Arbetsgång: Föreställ dig tre lika visare jämnt runt ett varv. Deras komponenter tar ut varandra.</a:t>
+              <a:t>Arbetsgång: Rita de tre visarna efter varandra, spets mot fot. Vad blir summan?</a:t>
             </a:r>
           </a:p>
         </p:txBody>
@@ -12780,7 +12784,7 @@
                 <a:ea typeface="Calibri"/>
                 <a:cs typeface="Calibri"/>
               </a:rPr>
-              <a:t>|IN| = |Ifas| vid en enda faslast</a:t>
+              <a:t>Nodlagen: Σ in = Σ ut</a:t>
             </a:r>
           </a:p>
         </p:txBody>
@@ -12837,7 +12841,7 @@
                 <a:ea typeface="Calibri"/>
                 <a:cs typeface="Calibri"/>
               </a:rPr>
-              <a:t>IN är neutralledarens ström. Den återför strömmen från den enda aktiva fas–neutral-lasten.</a:t>
+              <a:t>Iɴ är neutralledarens ström. Den för tillbaka strömmen från fas–neutral-lasterna.</a:t>
             </a:r>
           </a:p>
         </p:txBody>
@@ -18561,37 +18565,15 @@
               </a:defRPr>
             </a:pPr>
             <a:r>
-              <a:rPr sz="2100" b="0">
-                <a:solidFill>
-                  <a:srgbClr val="111111"/>
-                </a:solidFill>
-                <a:latin typeface="Calibri"/>
-                <a:ea typeface="Calibri"/>
-                <a:cs typeface="Calibri"/>
-              </a:rPr>
-              <a:t>Ombord är 440 V vanligt: då är U</a:t>
-            </a:r>
-            <a:r>
-              <a:rPr sz="2100" b="0" baseline="-25000">
-                <a:solidFill>
-                  <a:srgbClr val="111111"/>
-                </a:solidFill>
-                <a:latin typeface="Calibri"/>
-                <a:ea typeface="Calibri"/>
-                <a:cs typeface="Calibri"/>
-              </a:rPr>
-              <a:t>F</a:t>
-            </a:r>
-            <a:r>
-              <a:rPr sz="2100" b="0">
-                <a:solidFill>
-                  <a:srgbClr val="111111"/>
-                </a:solidFill>
-                <a:latin typeface="Calibri"/>
-                <a:ea typeface="Calibri"/>
-                <a:cs typeface="Calibri"/>
-              </a:rPr>
-              <a:t> ≈ 254 V.</a:t>
+              <a:rPr sz="1700" b="0">
+                <a:solidFill>
+                  <a:srgbClr val="111111"/>
+                </a:solidFill>
+                <a:latin typeface="Calibri"/>
+                <a:ea typeface="Calibri"/>
+                <a:cs typeface="Calibri"/>
+              </a:rPr>
+              <a:t>Ombord är 440 V vanligt. Generatorns fasspänning i Y är ≈ 254 V,</a:t>
             </a:r>
           </a:p>
           <a:p xmlns:a="http://schemas.openxmlformats.org/drawingml/2006/main">
@@ -18607,15 +18589,15 @@
               </a:defRPr>
             </a:pPr>
             <a:r>
-              <a:rPr sz="2100" b="0">
-                <a:solidFill>
-                  <a:srgbClr val="111111"/>
-                </a:solidFill>
-                <a:latin typeface="Calibri"/>
-                <a:ea typeface="Calibri"/>
-                <a:cs typeface="Calibri"/>
-              </a:rPr>
-              <a:t>Använd inte linjespänningen som fas–neutralspänning.</a:t>
+              <a:rPr sz="1700" b="0">
+                <a:solidFill>
+                  <a:srgbClr val="111111"/>
+                </a:solidFill>
+                <a:latin typeface="Calibri"/>
+                <a:ea typeface="Calibri"/>
+                <a:cs typeface="Calibri"/>
+              </a:rPr>
+              <a:t>men nätet har oftast ingen neutralledare. Vid ett jordfel kan en fas ha hela 440 V mot skrovet.</a:t>
             </a:r>
           </a:p>
         </p:txBody>

</xml_diff>

<commit_message>
Sjöskolan: växelströmsfilmen med kursens notation, index före upphöjd siffra
- acfilm: U_{pp}, U_{RMS}, X_{L}, X_{C}, U_{R}, U_{L}, U_{C}, Q_{C} i bildtexten,
  ritade nedsänkta av txt(); spelaren byggd om; filmens källor ingår i notationskontrollen
- notation.py: en upphöjd siffra (UL², XL²) avslutar ordet, så varianter framför den hittas
- rättade förekomster i v41, v45, EL-000235 och EL-000341 med presentationer, PDF och bildspel

Co-Authored-By: Claude Opus 5.5 <noreply@anthropic.com>
Claude-Session: https://claude.ai/code/session_011V9KjBb53XrDm23Dw58SH3
</commit_message>
<xml_diff>
--- a/sjoskolan/vecka-41/aktuell/v41_01_Trefassystemets_grunder_elev.pptx
+++ b/sjoskolan/vecka-41/aktuell/v41_01_Trefassystemets_grunder_elev.pptx
@@ -11805,7 +11805,29 @@
                 <a:ea typeface="Calibri"/>
                 <a:cs typeface="Calibri"/>
               </a:rPr>
-              <a:t>2. IN² = 6² + 6² + 2 · 6 · 6 · (−0,5) = 36.</a:t>
+              <a:t>2. I</a:t>
+            </a:r>
+            <a:r>
+              <a:rPr sz="2063" b="0" baseline="-25000">
+                <a:solidFill>
+                  <a:srgbClr val="111111"/>
+                </a:solidFill>
+                <a:latin typeface="Calibri"/>
+                <a:ea typeface="Calibri"/>
+                <a:cs typeface="Calibri"/>
+              </a:rPr>
+              <a:t>N</a:t>
+            </a:r>
+            <a:r>
+              <a:rPr sz="2063" b="0">
+                <a:solidFill>
+                  <a:srgbClr val="111111"/>
+                </a:solidFill>
+                <a:latin typeface="Calibri"/>
+                <a:ea typeface="Calibri"/>
+                <a:cs typeface="Calibri"/>
+              </a:rPr>
+              <a:t>² = 6² + 6² + 2 · 6 · 6 · (−0,5) = 36.</a:t>
             </a:r>
           </a:p>
           <a:p xmlns:a="http://schemas.openxmlformats.org/drawingml/2006/main">

</xml_diff>

<commit_message>
Sjöskolan: verkliga exempel från fartyget, ändringslogg med lärdomar och nya kontroller
- genomräknade exempel: fas och linje 254/440 V vid 60 Hz, Y och Δ på fartygets 440 V
  (20 Ω; tidigare gav exemplet övningarnas svar), styrtransformator 230/24 V. Ändrat på
  övningssidorna, i boken (text och figurer 10.2, 11.2, 17.1) och i presentationerna
  v41_01, v41_02 (16 Ω -> 20 Ω, som boken) och v43_02 med PDF och bildspel
- boken satt om (223 sidor), krypterad; provkapitel, förhandsbilder och manifest byggda om
- ANDRINGSLOGG.md: regler från tidigare fel och en logg; CLAUDE.md pekar dit
- CI: ledtrådar får inte innehålla övningens svar; notation: understreck utan klammer
  (hittade X_L på veckosidan, veckosidornas generator renderar nu X_{L} nedsänkt)

Co-Authored-By: Claude Opus 5.5 <noreply@anthropic.com>
Claude-Session: https://claude.ai/code/session_011V9KjBb53XrDm23Dw58SH3
</commit_message>
<xml_diff>
--- a/sjoskolan/vecka-41/aktuell/v41_01_Trefassystemets_grunder_elev.pptx
+++ b/sjoskolan/vecka-41/aktuell/v41_01_Trefassystemets_grunder_elev.pptx
@@ -20028,7 +20028,7 @@
                 <a:ea typeface="Calibri"/>
                 <a:cs typeface="Calibri"/>
               </a:rPr>
-              <a:t>En symmetrisk trefaskälla ger U</a:t>
+              <a:t>En symmetrisk trefaskälla ombord ger U</a:t>
             </a:r>
             <a:r>
               <a:rPr sz="2175" b="0" baseline="-25000">
@@ -20050,7 +20050,7 @@
                 <a:ea typeface="Calibri"/>
                 <a:cs typeface="Calibri"/>
               </a:rPr>
-              <a:t> = 100 V vid f = 60 Hz. Sök U</a:t>
+              <a:t> = 254 V vid f = 60 Hz. Sök U</a:t>
             </a:r>
             <a:r>
               <a:rPr sz="2175" b="0" baseline="-25000">
@@ -20252,7 +20252,7 @@
                 <a:ea typeface="Calibri"/>
                 <a:cs typeface="Calibri"/>
               </a:rPr>
-              <a:t> = √3 · 100 ≈ 173,2 V.</a:t>
+              <a:t> = √3 · 254 ≈ 440 V, fartygets vanliga huvudspänning.</a:t>
             </a:r>
           </a:p>
           <a:p xmlns:a="http://schemas.openxmlformats.org/drawingml/2006/main">

</xml_diff>

<commit_message>
Sjöskolan: verkliga exempel i vecka 40, svar som inte läcker, ny bok-PDF
- Momentanvärde: 440 V/60 Hz vid 2,0 ms (övningssida, bok, figur 7.3).
- Kompensering: pumpmotor 1 380 W vid 230 V (övningssida, bok, figur 9.3),
  metodrutan räknar med 1 440 W så att labbens reglage räcker.
- Labbens pumpuppgifter 1 500 W, så att lektionens exempel inte ger svaret.
- Övningar med utländska nät: U_{F} = 230 V -> 398 V, transformator 230 V.
- Revisioner registrerade med skyddade filer. Boken satt om (223 sidor).

Co-Authored-By: Claude Opus 5.5 <noreply@anthropic.com>
Claude-Session: https://claude.ai/code/session_011V9KjBb53XrDm23Dw58SH3
</commit_message>
<xml_diff>
--- a/sjoskolan/vecka-41/aktuell/v41_01_Trefassystemets_grunder_elev.pptx
+++ b/sjoskolan/vecka-41/aktuell/v41_01_Trefassystemets_grunder_elev.pptx
@@ -8164,7 +8164,7 @@
                 <a:ea typeface="Calibri"/>
                 <a:cs typeface="Calibri"/>
               </a:rPr>
-              <a:t> = 120 V mellan fas och neutral.</a:t>
+              <a:t> = 230 V mellan fas och neutral.</a:t>
             </a:r>
           </a:p>
         </p:txBody>
@@ -8232,7 +8232,7 @@
                 <a:ea typeface="Calibri"/>
                 <a:cs typeface="Calibri"/>
               </a:rPr>
-              <a:t>fas</a:t>
+              <a:t>F</a:t>
             </a:r>
             <a:r>
               <a:rPr sz="2025" b="0">
@@ -8542,7 +8542,7 @@
                 <a:ea typeface="Calibri"/>
                 <a:cs typeface="Calibri"/>
               </a:rPr>
-              <a:t> = 120 V. Beräkna linjespänningen i ett symmetriskt system.</a:t>
+              <a:t> = 230 V. Beräkna linjespänningen i ett symmetriskt system.</a:t>
             </a:r>
           </a:p>
         </p:txBody>

</xml_diff>

<commit_message>
Sjöskolan: vecka 40 låst, presentationsrubriker från vecka 41 följer numreringen
verktyg/las/veckolas.py håller SHA-256 för vecka 40:s filer; CI och innehall.py kontrollera stoppar ändringar. Bildrubrikerna i vecka 41–45 heter Övning d.k och Stöd till övning d.k som på webben.

Co-Authored-By: Claude Opus 5.5 <noreply@anthropic.com>
Claude-Session: https://claude.ai/code/session_011V9KjBb53XrDm23Dw58SH3
</commit_message>
<xml_diff>
--- a/sjoskolan/vecka-41/aktuell/v41_01_Trefassystemets_grunder_elev.pptx
+++ b/sjoskolan/vecka-41/aktuell/v41_01_Trefassystemets_grunder_elev.pptx
@@ -5540,7 +5540,7 @@
                 <a:ea typeface="Calibri"/>
                 <a:cs typeface="Calibri"/>
               </a:rPr>
-              <a:t>Stöd till övning 1</a:t>
+              <a:t>Stöd till övning 1.1</a:t>
             </a:r>
           </a:p>
         </p:txBody>
@@ -5929,7 +5929,7 @@
                 <a:ea typeface="Calibri"/>
                 <a:cs typeface="Calibri"/>
               </a:rPr>
-              <a:t>Övning 1</a:t>
+              <a:t>Övning 1.1</a:t>
             </a:r>
           </a:p>
         </p:txBody>
@@ -6288,7 +6288,7 @@
                 <a:ea typeface="Calibri"/>
                 <a:cs typeface="Calibri"/>
               </a:rPr>
-              <a:t>Stöd till övning 2</a:t>
+              <a:t>Stöd till övning 1.2</a:t>
             </a:r>
           </a:p>
         </p:txBody>
@@ -6677,7 +6677,7 @@
                 <a:ea typeface="Calibri"/>
                 <a:cs typeface="Calibri"/>
               </a:rPr>
-              <a:t>Övning 2</a:t>
+              <a:t>Övning 1.2</a:t>
             </a:r>
           </a:p>
         </p:txBody>
@@ -7036,7 +7036,7 @@
                 <a:ea typeface="Calibri"/>
                 <a:cs typeface="Calibri"/>
               </a:rPr>
-              <a:t>Stöd till övning 3</a:t>
+              <a:t>Stöd till övning 1.3</a:t>
             </a:r>
           </a:p>
         </p:txBody>
@@ -7535,7 +7535,7 @@
                 <a:ea typeface="Calibri"/>
                 <a:cs typeface="Calibri"/>
               </a:rPr>
-              <a:t>Övning 3</a:t>
+              <a:t>Övning 1.3</a:t>
             </a:r>
           </a:p>
         </p:txBody>
@@ -7938,7 +7938,7 @@
                 <a:ea typeface="Calibri"/>
                 <a:cs typeface="Calibri"/>
               </a:rPr>
-              <a:t>Stöd till övning 4</a:t>
+              <a:t>Stöd till övning 1.4</a:t>
             </a:r>
           </a:p>
         </p:txBody>
@@ -8404,7 +8404,7 @@
                 <a:ea typeface="Calibri"/>
                 <a:cs typeface="Calibri"/>
               </a:rPr>
-              <a:t>Övning 4</a:t>
+              <a:t>Övning 1.4</a:t>
             </a:r>
           </a:p>
         </p:txBody>
@@ -8785,7 +8785,7 @@
                 <a:ea typeface="Calibri"/>
                 <a:cs typeface="Calibri"/>
               </a:rPr>
-              <a:t>Stöd till övning 5</a:t>
+              <a:t>Stöd till övning 1.5</a:t>
             </a:r>
           </a:p>
         </p:txBody>
@@ -9262,7 +9262,7 @@
                 <a:ea typeface="Calibri"/>
                 <a:cs typeface="Calibri"/>
               </a:rPr>
-              <a:t>Övning 5</a:t>
+              <a:t>Övning 1.5</a:t>
             </a:r>
           </a:p>
         </p:txBody>
@@ -12089,7 +12089,7 @@
                 <a:ea typeface="Calibri"/>
                 <a:cs typeface="Calibri"/>
               </a:rPr>
-              <a:t>Stöd till övning 6</a:t>
+              <a:t>Stöd till övning 1.6</a:t>
             </a:r>
           </a:p>
         </p:txBody>
@@ -12566,7 +12566,7 @@
                 <a:ea typeface="Calibri"/>
                 <a:cs typeface="Calibri"/>
               </a:rPr>
-              <a:t>Övning 6</a:t>
+              <a:t>Övning 1.6</a:t>
             </a:r>
           </a:p>
         </p:txBody>
@@ -12925,7 +12925,7 @@
                 <a:ea typeface="Calibri"/>
                 <a:cs typeface="Calibri"/>
               </a:rPr>
-              <a:t>Stöd till övning 7</a:t>
+              <a:t>Stöd till övning 1.7</a:t>
             </a:r>
           </a:p>
         </p:txBody>
@@ -13336,7 +13336,7 @@
                 <a:ea typeface="Calibri"/>
                 <a:cs typeface="Calibri"/>
               </a:rPr>
-              <a:t>Övning 7</a:t>
+              <a:t>Övning 1.7</a:t>
             </a:r>
           </a:p>
         </p:txBody>
@@ -13695,7 +13695,7 @@
                 <a:ea typeface="Calibri"/>
                 <a:cs typeface="Calibri"/>
               </a:rPr>
-              <a:t>Stöd till övning 8</a:t>
+              <a:t>Stöd till övning 1.8</a:t>
             </a:r>
           </a:p>
         </p:txBody>
@@ -14774,7 +14774,7 @@
                 <a:ea typeface="Calibri"/>
                 <a:cs typeface="Calibri"/>
               </a:rPr>
-              <a:t>Övning 8</a:t>
+              <a:t>Övning 1.8</a:t>
             </a:r>
           </a:p>
         </p:txBody>
@@ -15133,7 +15133,7 @@
                 <a:ea typeface="Calibri"/>
                 <a:cs typeface="Calibri"/>
               </a:rPr>
-              <a:t>Stöd till övning 9</a:t>
+              <a:t>Stöd till övning 1.9</a:t>
             </a:r>
           </a:p>
         </p:txBody>
@@ -15688,7 +15688,7 @@
                 <a:ea typeface="Calibri"/>
                 <a:cs typeface="Calibri"/>
               </a:rPr>
-              <a:t>Övning 9</a:t>
+              <a:t>Övning 1.9</a:t>
             </a:r>
           </a:p>
         </p:txBody>
@@ -16113,7 +16113,7 @@
                 <a:ea typeface="Calibri"/>
                 <a:cs typeface="Calibri"/>
               </a:rPr>
-              <a:t>Stöd till övning 10</a:t>
+              <a:t>Stöd till övning 1.10</a:t>
             </a:r>
           </a:p>
         </p:txBody>
@@ -16502,7 +16502,7 @@
                 <a:ea typeface="Calibri"/>
                 <a:cs typeface="Calibri"/>
               </a:rPr>
-              <a:t>Övning 10</a:t>
+              <a:t>Övning 1.10</a:t>
             </a:r>
           </a:p>
         </p:txBody>

</xml_diff>

<commit_message>
Sjöskolan vecka 41–42: presentationerna först, lärarkopior med manus, ritningar som bilder
Veckosidorna från vecka 41 börjar med Veckans presentationer. Lärarkopior med manus och facit (verktyg/larare/lararmanus.py) i lärarportalen vecka 41 och 42. Diagram och scheman i vecka 41 som bilder. Övningsnummer d.k i passbilderna. Databasstädning: 0 anmärkningar i validera.

Co-Authored-By: Claude Opus 5.5 <noreply@anthropic.com>
Claude-Session: https://claude.ai/code/session_011V9KjBb53XrDm23Dw58SH3
</commit_message>
<xml_diff>
--- a/sjoskolan/vecka-41/aktuell/v41_01_Trefassystemets_grunder_elev.pptx
+++ b/sjoskolan/vecka-41/aktuell/v41_01_Trefassystemets_grunder_elev.pptx
@@ -3400,1757 +3400,6 @@
 </a:theme>
 </file>
 
-<file path=ppt/slides/charts/chart1.xml><?xml version="1.0" encoding="utf-8"?>
-<c:chartSpace xmlns:c="http://schemas.openxmlformats.org/drawingml/2006/chart" xmlns:r="http://schemas.openxmlformats.org/officeDocument/2006/relationships">
-  <c:lang val="en-US"/>
-  <c:chart>
-    <c:plotArea>
-      <c:scatterChart>
-        <c:scatterStyle val="line"/>
-        <c:ser>
-          <c:idx val="0"/>
-          <c:order val="0"/>
-          <c:tx>
-            <c:v>L1</c:v>
-          </c:tx>
-          <c:spPr>
-            <a:ln xmlns:a="http://schemas.openxmlformats.org/drawingml/2006/main" w="23813">
-              <a:solidFill>
-                <a:srgbClr val="064F91"/>
-              </a:solidFill>
-            </a:ln>
-          </c:spPr>
-          <c:marker>
-            <c:symbol val="none"/>
-          </c:marker>
-          <c:xVal>
-            <c:numRef>
-              <c:f>'Chart Data'!$A$2:$A$82</c:f>
-              <c:numCache>
-                <c:formatCode>General</c:formatCode>
-                <c:ptCount val="81"/>
-                <c:pt idx="0">
-                  <c:v>0</c:v>
-                </c:pt>
-                <c:pt idx="1">
-                  <c:v>0.25</c:v>
-                </c:pt>
-                <c:pt idx="2">
-                  <c:v>0.5</c:v>
-                </c:pt>
-                <c:pt idx="3">
-                  <c:v>0.75</c:v>
-                </c:pt>
-                <c:pt idx="4">
-                  <c:v>1</c:v>
-                </c:pt>
-                <c:pt idx="5">
-                  <c:v>1.25</c:v>
-                </c:pt>
-                <c:pt idx="6">
-                  <c:v>1.5</c:v>
-                </c:pt>
-                <c:pt idx="7">
-                  <c:v>1.75</c:v>
-                </c:pt>
-                <c:pt idx="8">
-                  <c:v>2</c:v>
-                </c:pt>
-                <c:pt idx="9">
-                  <c:v>2.25</c:v>
-                </c:pt>
-                <c:pt idx="10">
-                  <c:v>2.5</c:v>
-                </c:pt>
-                <c:pt idx="11">
-                  <c:v>2.75</c:v>
-                </c:pt>
-                <c:pt idx="12">
-                  <c:v>3</c:v>
-                </c:pt>
-                <c:pt idx="13">
-                  <c:v>3.25</c:v>
-                </c:pt>
-                <c:pt idx="14">
-                  <c:v>3.5</c:v>
-                </c:pt>
-                <c:pt idx="15">
-                  <c:v>3.75</c:v>
-                </c:pt>
-                <c:pt idx="16">
-                  <c:v>4</c:v>
-                </c:pt>
-                <c:pt idx="17">
-                  <c:v>4.25</c:v>
-                </c:pt>
-                <c:pt idx="18">
-                  <c:v>4.5</c:v>
-                </c:pt>
-                <c:pt idx="19">
-                  <c:v>4.75</c:v>
-                </c:pt>
-                <c:pt idx="20">
-                  <c:v>5</c:v>
-                </c:pt>
-                <c:pt idx="21">
-                  <c:v>5.25</c:v>
-                </c:pt>
-                <c:pt idx="22">
-                  <c:v>5.5</c:v>
-                </c:pt>
-                <c:pt idx="23">
-                  <c:v>5.75</c:v>
-                </c:pt>
-                <c:pt idx="24">
-                  <c:v>6</c:v>
-                </c:pt>
-                <c:pt idx="25">
-                  <c:v>6.25</c:v>
-                </c:pt>
-                <c:pt idx="26">
-                  <c:v>6.5</c:v>
-                </c:pt>
-                <c:pt idx="27">
-                  <c:v>6.75</c:v>
-                </c:pt>
-                <c:pt idx="28">
-                  <c:v>7</c:v>
-                </c:pt>
-                <c:pt idx="29">
-                  <c:v>7.25</c:v>
-                </c:pt>
-                <c:pt idx="30">
-                  <c:v>7.5</c:v>
-                </c:pt>
-                <c:pt idx="31">
-                  <c:v>7.75</c:v>
-                </c:pt>
-                <c:pt idx="32">
-                  <c:v>8</c:v>
-                </c:pt>
-                <c:pt idx="33">
-                  <c:v>8.25</c:v>
-                </c:pt>
-                <c:pt idx="34">
-                  <c:v>8.5</c:v>
-                </c:pt>
-                <c:pt idx="35">
-                  <c:v>8.75</c:v>
-                </c:pt>
-                <c:pt idx="36">
-                  <c:v>9</c:v>
-                </c:pt>
-                <c:pt idx="37">
-                  <c:v>9.25</c:v>
-                </c:pt>
-                <c:pt idx="38">
-                  <c:v>9.5</c:v>
-                </c:pt>
-                <c:pt idx="39">
-                  <c:v>9.75</c:v>
-                </c:pt>
-                <c:pt idx="40">
-                  <c:v>10</c:v>
-                </c:pt>
-                <c:pt idx="41">
-                  <c:v>10.25</c:v>
-                </c:pt>
-                <c:pt idx="42">
-                  <c:v>10.5</c:v>
-                </c:pt>
-                <c:pt idx="43">
-                  <c:v>10.75</c:v>
-                </c:pt>
-                <c:pt idx="44">
-                  <c:v>11</c:v>
-                </c:pt>
-                <c:pt idx="45">
-                  <c:v>11.25</c:v>
-                </c:pt>
-                <c:pt idx="46">
-                  <c:v>11.5</c:v>
-                </c:pt>
-                <c:pt idx="47">
-                  <c:v>11.75</c:v>
-                </c:pt>
-                <c:pt idx="48">
-                  <c:v>12</c:v>
-                </c:pt>
-                <c:pt idx="49">
-                  <c:v>12.25</c:v>
-                </c:pt>
-                <c:pt idx="50">
-                  <c:v>12.5</c:v>
-                </c:pt>
-                <c:pt idx="51">
-                  <c:v>12.75</c:v>
-                </c:pt>
-                <c:pt idx="52">
-                  <c:v>13</c:v>
-                </c:pt>
-                <c:pt idx="53">
-                  <c:v>13.25</c:v>
-                </c:pt>
-                <c:pt idx="54">
-                  <c:v>13.5</c:v>
-                </c:pt>
-                <c:pt idx="55">
-                  <c:v>13.75</c:v>
-                </c:pt>
-                <c:pt idx="56">
-                  <c:v>14</c:v>
-                </c:pt>
-                <c:pt idx="57">
-                  <c:v>14.25</c:v>
-                </c:pt>
-                <c:pt idx="58">
-                  <c:v>14.5</c:v>
-                </c:pt>
-                <c:pt idx="59">
-                  <c:v>14.75</c:v>
-                </c:pt>
-                <c:pt idx="60">
-                  <c:v>15</c:v>
-                </c:pt>
-                <c:pt idx="61">
-                  <c:v>15.25</c:v>
-                </c:pt>
-                <c:pt idx="62">
-                  <c:v>15.5</c:v>
-                </c:pt>
-                <c:pt idx="63">
-                  <c:v>15.75</c:v>
-                </c:pt>
-                <c:pt idx="64">
-                  <c:v>16</c:v>
-                </c:pt>
-                <c:pt idx="65">
-                  <c:v>16.25</c:v>
-                </c:pt>
-                <c:pt idx="66">
-                  <c:v>16.5</c:v>
-                </c:pt>
-                <c:pt idx="67">
-                  <c:v>16.75</c:v>
-                </c:pt>
-                <c:pt idx="68">
-                  <c:v>17</c:v>
-                </c:pt>
-                <c:pt idx="69">
-                  <c:v>17.25</c:v>
-                </c:pt>
-                <c:pt idx="70">
-                  <c:v>17.5</c:v>
-                </c:pt>
-                <c:pt idx="71">
-                  <c:v>17.75</c:v>
-                </c:pt>
-                <c:pt idx="72">
-                  <c:v>18</c:v>
-                </c:pt>
-                <c:pt idx="73">
-                  <c:v>18.25</c:v>
-                </c:pt>
-                <c:pt idx="74">
-                  <c:v>18.5</c:v>
-                </c:pt>
-                <c:pt idx="75">
-                  <c:v>18.75</c:v>
-                </c:pt>
-                <c:pt idx="76">
-                  <c:v>19</c:v>
-                </c:pt>
-                <c:pt idx="77">
-                  <c:v>19.25</c:v>
-                </c:pt>
-                <c:pt idx="78">
-                  <c:v>19.5</c:v>
-                </c:pt>
-                <c:pt idx="79">
-                  <c:v>19.75</c:v>
-                </c:pt>
-                <c:pt idx="80">
-                  <c:v>20</c:v>
-                </c:pt>
-              </c:numCache>
-            </c:numRef>
-          </c:xVal>
-          <c:yVal>
-            <c:numRef>
-              <c:f>'Chart Data'!$B$2:$B$82</c:f>
-              <c:numCache>
-                <c:formatCode>0</c:formatCode>
-                <c:ptCount val="81"/>
-                <c:pt idx="0">
-                  <c:v>0</c:v>
-                </c:pt>
-                <c:pt idx="1">
-                  <c:v>0.0784590957278449</c:v>
-                </c:pt>
-                <c:pt idx="2">
-                  <c:v>0.156434465040231</c:v>
-                </c:pt>
-                <c:pt idx="3">
-                  <c:v>0.233445363855905</c:v>
-                </c:pt>
-                <c:pt idx="4">
-                  <c:v>0.309016994374947</c:v>
-                </c:pt>
-                <c:pt idx="5">
-                  <c:v>0.38268343236509</c:v>
-                </c:pt>
-                <c:pt idx="6">
-                  <c:v>0.453990499739547</c:v>
-                </c:pt>
-                <c:pt idx="7">
-                  <c:v>0.522498564715949</c:v>
-                </c:pt>
-                <c:pt idx="8">
-                  <c:v>0.587785252292473</c:v>
-                </c:pt>
-                <c:pt idx="9">
-                  <c:v>0.649448048330184</c:v>
-                </c:pt>
-                <c:pt idx="10">
-                  <c:v>0.707106781186547</c:v>
-                </c:pt>
-                <c:pt idx="11">
-                  <c:v>0.760405965600031</c:v>
-                </c:pt>
-                <c:pt idx="12">
-                  <c:v>0.809016994374947</c:v>
-                </c:pt>
-                <c:pt idx="13">
-                  <c:v>0.852640164354092</c:v>
-                </c:pt>
-                <c:pt idx="14">
-                  <c:v>0.891006524188368</c:v>
-                </c:pt>
-                <c:pt idx="15">
-                  <c:v>0.923879532511287</c:v>
-                </c:pt>
-                <c:pt idx="16">
-                  <c:v>0.951056516295154</c:v>
-                </c:pt>
-                <c:pt idx="17">
-                  <c:v>0.972369920397677</c:v>
-                </c:pt>
-                <c:pt idx="18">
-                  <c:v>0.987688340595138</c:v>
-                </c:pt>
-                <c:pt idx="19">
-                  <c:v>0.996917333733128</c:v>
-                </c:pt>
-                <c:pt idx="20">
-                  <c:v>1</c:v>
-                </c:pt>
-                <c:pt idx="21">
-                  <c:v>0.996917333733128</c:v>
-                </c:pt>
-                <c:pt idx="22">
-                  <c:v>0.987688340595138</c:v>
-                </c:pt>
-                <c:pt idx="23">
-                  <c:v>0.972369920397677</c:v>
-                </c:pt>
-                <c:pt idx="24">
-                  <c:v>0.951056516295154</c:v>
-                </c:pt>
-                <c:pt idx="25">
-                  <c:v>0.923879532511287</c:v>
-                </c:pt>
-                <c:pt idx="26">
-                  <c:v>0.891006524188368</c:v>
-                </c:pt>
-                <c:pt idx="27">
-                  <c:v>0.852640164354092</c:v>
-                </c:pt>
-                <c:pt idx="28">
-                  <c:v>0.809016994374947</c:v>
-                </c:pt>
-                <c:pt idx="29">
-                  <c:v>0.760405965600031</c:v>
-                </c:pt>
-                <c:pt idx="30">
-                  <c:v>0.707106781186548</c:v>
-                </c:pt>
-                <c:pt idx="31">
-                  <c:v>0.649448048330184</c:v>
-                </c:pt>
-                <c:pt idx="32">
-                  <c:v>0.587785252292473</c:v>
-                </c:pt>
-                <c:pt idx="33">
-                  <c:v>0.522498564715949</c:v>
-                </c:pt>
-                <c:pt idx="34">
-                  <c:v>0.453990499739547</c:v>
-                </c:pt>
-                <c:pt idx="35">
-                  <c:v>0.38268343236509</c:v>
-                </c:pt>
-                <c:pt idx="36">
-                  <c:v>0.309016994374948</c:v>
-                </c:pt>
-                <c:pt idx="37">
-                  <c:v>0.233445363855906</c:v>
-                </c:pt>
-                <c:pt idx="38">
-                  <c:v>0.156434465040231</c:v>
-                </c:pt>
-                <c:pt idx="39">
-                  <c:v>0.0784590957278451</c:v>
-                </c:pt>
-                <c:pt idx="40">
-                  <c:v>1.22464679914735e-16</c:v>
-                </c:pt>
-                <c:pt idx="41">
-                  <c:v>-0.0784590957278444</c:v>
-                </c:pt>
-                <c:pt idx="42">
-                  <c:v>-0.156434465040231</c:v>
-                </c:pt>
-                <c:pt idx="43">
-                  <c:v>-0.233445363855905</c:v>
-                </c:pt>
-                <c:pt idx="44">
-                  <c:v>-0.309016994374947</c:v>
-                </c:pt>
-                <c:pt idx="45">
-                  <c:v>-0.38268343236509</c:v>
-                </c:pt>
-                <c:pt idx="46">
-                  <c:v>-0.453990499739547</c:v>
-                </c:pt>
-                <c:pt idx="47">
-                  <c:v>-0.522498564715949</c:v>
-                </c:pt>
-                <c:pt idx="48">
-                  <c:v>-0.587785252292473</c:v>
-                </c:pt>
-                <c:pt idx="49">
-                  <c:v>-0.649448048330183</c:v>
-                </c:pt>
-                <c:pt idx="50">
-                  <c:v>-0.707106781186547</c:v>
-                </c:pt>
-                <c:pt idx="51">
-                  <c:v>-0.760405965600031</c:v>
-                </c:pt>
-                <c:pt idx="52">
-                  <c:v>-0.809016994374947</c:v>
-                </c:pt>
-                <c:pt idx="53">
-                  <c:v>-0.852640164354092</c:v>
-                </c:pt>
-                <c:pt idx="54">
-                  <c:v>-0.891006524188368</c:v>
-                </c:pt>
-                <c:pt idx="55">
-                  <c:v>-0.923879532511287</c:v>
-                </c:pt>
-                <c:pt idx="56">
-                  <c:v>-0.951056516295154</c:v>
-                </c:pt>
-                <c:pt idx="57">
-                  <c:v>-0.972369920397676</c:v>
-                </c:pt>
-                <c:pt idx="58">
-                  <c:v>-0.987688340595138</c:v>
-                </c:pt>
-                <c:pt idx="59">
-                  <c:v>-0.996917333733128</c:v>
-                </c:pt>
-                <c:pt idx="60">
-                  <c:v>-1</c:v>
-                </c:pt>
-                <c:pt idx="61">
-                  <c:v>-0.996917333733128</c:v>
-                </c:pt>
-                <c:pt idx="62">
-                  <c:v>-0.987688340595138</c:v>
-                </c:pt>
-                <c:pt idx="63">
-                  <c:v>-0.972369920397677</c:v>
-                </c:pt>
-                <c:pt idx="64">
-                  <c:v>-0.951056516295154</c:v>
-                </c:pt>
-                <c:pt idx="65">
-                  <c:v>-0.923879532511287</c:v>
-                </c:pt>
-                <c:pt idx="66">
-                  <c:v>-0.891006524188368</c:v>
-                </c:pt>
-                <c:pt idx="67">
-                  <c:v>-0.852640164354093</c:v>
-                </c:pt>
-                <c:pt idx="68">
-                  <c:v>-0.809016994374948</c:v>
-                </c:pt>
-                <c:pt idx="69">
-                  <c:v>-0.760405965600031</c:v>
-                </c:pt>
-                <c:pt idx="70">
-                  <c:v>-0.707106781186548</c:v>
-                </c:pt>
-                <c:pt idx="71">
-                  <c:v>-0.649448048330183</c:v>
-                </c:pt>
-                <c:pt idx="72">
-                  <c:v>-0.587785252292473</c:v>
-                </c:pt>
-                <c:pt idx="73">
-                  <c:v>-0.522498564715949</c:v>
-                </c:pt>
-                <c:pt idx="74">
-                  <c:v>-0.453990499739547</c:v>
-                </c:pt>
-                <c:pt idx="75">
-                  <c:v>-0.38268343236509</c:v>
-                </c:pt>
-                <c:pt idx="76">
-                  <c:v>-0.309016994374948</c:v>
-                </c:pt>
-                <c:pt idx="77">
-                  <c:v>-0.233445363855905</c:v>
-                </c:pt>
-                <c:pt idx="78">
-                  <c:v>-0.156434465040231</c:v>
-                </c:pt>
-                <c:pt idx="79">
-                  <c:v>-0.0784590957278447</c:v>
-                </c:pt>
-                <c:pt idx="80">
-                  <c:v>-2.44929359829471e-16</c:v>
-                </c:pt>
-              </c:numCache>
-            </c:numRef>
-          </c:yVal>
-        </c:ser>
-        <c:ser>
-          <c:idx val="1"/>
-          <c:order val="1"/>
-          <c:tx>
-            <c:v>L2</c:v>
-          </c:tx>
-          <c:spPr>
-            <a:ln xmlns:a="http://schemas.openxmlformats.org/drawingml/2006/main" w="23813">
-              <a:solidFill>
-                <a:srgbClr val="B44C21"/>
-              </a:solidFill>
-            </a:ln>
-          </c:spPr>
-          <c:marker>
-            <c:symbol val="none"/>
-          </c:marker>
-          <c:xVal>
-            <c:numRef>
-              <c:f>'Chart Data'!$C$2:$C$82</c:f>
-              <c:numCache>
-                <c:formatCode>General</c:formatCode>
-                <c:ptCount val="81"/>
-                <c:pt idx="0">
-                  <c:v>0</c:v>
-                </c:pt>
-                <c:pt idx="1">
-                  <c:v>0.25</c:v>
-                </c:pt>
-                <c:pt idx="2">
-                  <c:v>0.5</c:v>
-                </c:pt>
-                <c:pt idx="3">
-                  <c:v>0.75</c:v>
-                </c:pt>
-                <c:pt idx="4">
-                  <c:v>1</c:v>
-                </c:pt>
-                <c:pt idx="5">
-                  <c:v>1.25</c:v>
-                </c:pt>
-                <c:pt idx="6">
-                  <c:v>1.5</c:v>
-                </c:pt>
-                <c:pt idx="7">
-                  <c:v>1.75</c:v>
-                </c:pt>
-                <c:pt idx="8">
-                  <c:v>2</c:v>
-                </c:pt>
-                <c:pt idx="9">
-                  <c:v>2.25</c:v>
-                </c:pt>
-                <c:pt idx="10">
-                  <c:v>2.5</c:v>
-                </c:pt>
-                <c:pt idx="11">
-                  <c:v>2.75</c:v>
-                </c:pt>
-                <c:pt idx="12">
-                  <c:v>3</c:v>
-                </c:pt>
-                <c:pt idx="13">
-                  <c:v>3.25</c:v>
-                </c:pt>
-                <c:pt idx="14">
-                  <c:v>3.5</c:v>
-                </c:pt>
-                <c:pt idx="15">
-                  <c:v>3.75</c:v>
-                </c:pt>
-                <c:pt idx="16">
-                  <c:v>4</c:v>
-                </c:pt>
-                <c:pt idx="17">
-                  <c:v>4.25</c:v>
-                </c:pt>
-                <c:pt idx="18">
-                  <c:v>4.5</c:v>
-                </c:pt>
-                <c:pt idx="19">
-                  <c:v>4.75</c:v>
-                </c:pt>
-                <c:pt idx="20">
-                  <c:v>5</c:v>
-                </c:pt>
-                <c:pt idx="21">
-                  <c:v>5.25</c:v>
-                </c:pt>
-                <c:pt idx="22">
-                  <c:v>5.5</c:v>
-                </c:pt>
-                <c:pt idx="23">
-                  <c:v>5.75</c:v>
-                </c:pt>
-                <c:pt idx="24">
-                  <c:v>6</c:v>
-                </c:pt>
-                <c:pt idx="25">
-                  <c:v>6.25</c:v>
-                </c:pt>
-                <c:pt idx="26">
-                  <c:v>6.5</c:v>
-                </c:pt>
-                <c:pt idx="27">
-                  <c:v>6.75</c:v>
-                </c:pt>
-                <c:pt idx="28">
-                  <c:v>7</c:v>
-                </c:pt>
-                <c:pt idx="29">
-                  <c:v>7.25</c:v>
-                </c:pt>
-                <c:pt idx="30">
-                  <c:v>7.5</c:v>
-                </c:pt>
-                <c:pt idx="31">
-                  <c:v>7.75</c:v>
-                </c:pt>
-                <c:pt idx="32">
-                  <c:v>8</c:v>
-                </c:pt>
-                <c:pt idx="33">
-                  <c:v>8.25</c:v>
-                </c:pt>
-                <c:pt idx="34">
-                  <c:v>8.5</c:v>
-                </c:pt>
-                <c:pt idx="35">
-                  <c:v>8.75</c:v>
-                </c:pt>
-                <c:pt idx="36">
-                  <c:v>9</c:v>
-                </c:pt>
-                <c:pt idx="37">
-                  <c:v>9.25</c:v>
-                </c:pt>
-                <c:pt idx="38">
-                  <c:v>9.5</c:v>
-                </c:pt>
-                <c:pt idx="39">
-                  <c:v>9.75</c:v>
-                </c:pt>
-                <c:pt idx="40">
-                  <c:v>10</c:v>
-                </c:pt>
-                <c:pt idx="41">
-                  <c:v>10.25</c:v>
-                </c:pt>
-                <c:pt idx="42">
-                  <c:v>10.5</c:v>
-                </c:pt>
-                <c:pt idx="43">
-                  <c:v>10.75</c:v>
-                </c:pt>
-                <c:pt idx="44">
-                  <c:v>11</c:v>
-                </c:pt>
-                <c:pt idx="45">
-                  <c:v>11.25</c:v>
-                </c:pt>
-                <c:pt idx="46">
-                  <c:v>11.5</c:v>
-                </c:pt>
-                <c:pt idx="47">
-                  <c:v>11.75</c:v>
-                </c:pt>
-                <c:pt idx="48">
-                  <c:v>12</c:v>
-                </c:pt>
-                <c:pt idx="49">
-                  <c:v>12.25</c:v>
-                </c:pt>
-                <c:pt idx="50">
-                  <c:v>12.5</c:v>
-                </c:pt>
-                <c:pt idx="51">
-                  <c:v>12.75</c:v>
-                </c:pt>
-                <c:pt idx="52">
-                  <c:v>13</c:v>
-                </c:pt>
-                <c:pt idx="53">
-                  <c:v>13.25</c:v>
-                </c:pt>
-                <c:pt idx="54">
-                  <c:v>13.5</c:v>
-                </c:pt>
-                <c:pt idx="55">
-                  <c:v>13.75</c:v>
-                </c:pt>
-                <c:pt idx="56">
-                  <c:v>14</c:v>
-                </c:pt>
-                <c:pt idx="57">
-                  <c:v>14.25</c:v>
-                </c:pt>
-                <c:pt idx="58">
-                  <c:v>14.5</c:v>
-                </c:pt>
-                <c:pt idx="59">
-                  <c:v>14.75</c:v>
-                </c:pt>
-                <c:pt idx="60">
-                  <c:v>15</c:v>
-                </c:pt>
-                <c:pt idx="61">
-                  <c:v>15.25</c:v>
-                </c:pt>
-                <c:pt idx="62">
-                  <c:v>15.5</c:v>
-                </c:pt>
-                <c:pt idx="63">
-                  <c:v>15.75</c:v>
-                </c:pt>
-                <c:pt idx="64">
-                  <c:v>16</c:v>
-                </c:pt>
-                <c:pt idx="65">
-                  <c:v>16.25</c:v>
-                </c:pt>
-                <c:pt idx="66">
-                  <c:v>16.5</c:v>
-                </c:pt>
-                <c:pt idx="67">
-                  <c:v>16.75</c:v>
-                </c:pt>
-                <c:pt idx="68">
-                  <c:v>17</c:v>
-                </c:pt>
-                <c:pt idx="69">
-                  <c:v>17.25</c:v>
-                </c:pt>
-                <c:pt idx="70">
-                  <c:v>17.5</c:v>
-                </c:pt>
-                <c:pt idx="71">
-                  <c:v>17.75</c:v>
-                </c:pt>
-                <c:pt idx="72">
-                  <c:v>18</c:v>
-                </c:pt>
-                <c:pt idx="73">
-                  <c:v>18.25</c:v>
-                </c:pt>
-                <c:pt idx="74">
-                  <c:v>18.5</c:v>
-                </c:pt>
-                <c:pt idx="75">
-                  <c:v>18.75</c:v>
-                </c:pt>
-                <c:pt idx="76">
-                  <c:v>19</c:v>
-                </c:pt>
-                <c:pt idx="77">
-                  <c:v>19.25</c:v>
-                </c:pt>
-                <c:pt idx="78">
-                  <c:v>19.5</c:v>
-                </c:pt>
-                <c:pt idx="79">
-                  <c:v>19.75</c:v>
-                </c:pt>
-                <c:pt idx="80">
-                  <c:v>20</c:v>
-                </c:pt>
-              </c:numCache>
-            </c:numRef>
-          </c:xVal>
-          <c:yVal>
-            <c:numRef>
-              <c:f>'Chart Data'!$D$2:$D$82</c:f>
-              <c:numCache>
-                <c:formatCode>0</c:formatCode>
-                <c:ptCount val="81"/>
-                <c:pt idx="0">
-                  <c:v>-0.866025403784439</c:v>
-                </c:pt>
-                <c:pt idx="1">
-                  <c:v>-0.902585284349861</c:v>
-                </c:pt>
-                <c:pt idx="2">
-                  <c:v>-0.933580426497202</c:v>
-                </c:pt>
-                <c:pt idx="3">
-                  <c:v>-0.958819734868193</c:v>
-                </c:pt>
-                <c:pt idx="4">
-                  <c:v>-0.978147600733806</c:v>
-                </c:pt>
-                <c:pt idx="5">
-                  <c:v>-0.99144486137381</c:v>
-                </c:pt>
-                <c:pt idx="6">
-                  <c:v>-0.998629534754574</c:v>
-                </c:pt>
-                <c:pt idx="7">
-                  <c:v>-0.999657324975557</c:v>
-                </c:pt>
-                <c:pt idx="8">
-                  <c:v>-0.994521895368273</c:v>
-                </c:pt>
-                <c:pt idx="9">
-                  <c:v>-0.983254907563955</c:v>
-                </c:pt>
-                <c:pt idx="10">
-                  <c:v>-0.965925826289068</c:v>
-                </c:pt>
-                <c:pt idx="11">
-                  <c:v>-0.942641491092178</c:v>
-                </c:pt>
-                <c:pt idx="12">
-                  <c:v>-0.913545457642601</c:v>
-                </c:pt>
-                <c:pt idx="13">
-                  <c:v>-0.878817112661965</c:v>
-                </c:pt>
-                <c:pt idx="14">
-                  <c:v>-0.838670567945424</c:v>
-                </c:pt>
-                <c:pt idx="15">
-                  <c:v>-0.793353340291235</c:v>
-                </c:pt>
-                <c:pt idx="16">
-                  <c:v>-0.743144825477394</c:v>
-                </c:pt>
-                <c:pt idx="17">
-                  <c:v>-0.688354575693754</c:v>
-                </c:pt>
-                <c:pt idx="18">
-                  <c:v>-0.629320391049837</c:v>
-                </c:pt>
-                <c:pt idx="19">
-                  <c:v>-0.566406236924833</c:v>
-                </c:pt>
-                <c:pt idx="20">
-                  <c:v>-0.5</c:v>
-                </c:pt>
-                <c:pt idx="21">
-                  <c:v>-0.430511096808295</c:v>
-                </c:pt>
-                <c:pt idx="22">
-                  <c:v>-0.3583679495453</c:v>
-                </c:pt>
-                <c:pt idx="23">
-                  <c:v>-0.284015344703922</c:v>
-                </c:pt>
-                <c:pt idx="24">
-                  <c:v>-0.207911690817759</c:v>
-                </c:pt>
-                <c:pt idx="25">
-                  <c:v>-0.130526192220051</c:v>
-                </c:pt>
-                <c:pt idx="26">
-                  <c:v>-0.0523359562429437</c:v>
-                </c:pt>
-                <c:pt idx="27">
-                  <c:v>0.0261769483078733</c:v>
-                </c:pt>
-                <c:pt idx="28">
-                  <c:v>0.104528463267654</c:v>
-                </c:pt>
-                <c:pt idx="29">
-                  <c:v>0.182235525492148</c:v>
-                </c:pt>
-                <c:pt idx="30">
-                  <c:v>0.258819045102521</c:v>
-                </c:pt>
-                <c:pt idx="31">
-                  <c:v>0.333806859233771</c:v>
-                </c:pt>
-                <c:pt idx="32">
-                  <c:v>0.4067366430758</c:v>
-                </c:pt>
-                <c:pt idx="33">
-                  <c:v>0.477158760259609</c:v>
-                </c:pt>
-                <c:pt idx="34">
-                  <c:v>0.544639035015027</c:v>
-                </c:pt>
-                <c:pt idx="35">
-                  <c:v>0.608761429008721</c:v>
-                </c:pt>
-                <c:pt idx="36">
-                  <c:v>0.669130606358858</c:v>
-                </c:pt>
-                <c:pt idx="37">
-                  <c:v>0.725374371012288</c:v>
-                </c:pt>
-                <c:pt idx="38">
-                  <c:v>0.777145961456971</c:v>
-                </c:pt>
-                <c:pt idx="39">
-                  <c:v>0.824126188622016</c:v>
-                </c:pt>
-                <c:pt idx="40">
-                  <c:v>0.866025403784439</c:v>
-                </c:pt>
-                <c:pt idx="41">
-                  <c:v>0.902585284349861</c:v>
-                </c:pt>
-                <c:pt idx="42">
-                  <c:v>0.933580426497202</c:v>
-                </c:pt>
-                <c:pt idx="43">
-                  <c:v>0.958819734868193</c:v>
-                </c:pt>
-                <c:pt idx="44">
-                  <c:v>0.978147600733806</c:v>
-                </c:pt>
-                <c:pt idx="45">
-                  <c:v>0.99144486137381</c:v>
-                </c:pt>
-                <c:pt idx="46">
-                  <c:v>0.998629534754574</c:v>
-                </c:pt>
-                <c:pt idx="47">
-                  <c:v>0.999657324975557</c:v>
-                </c:pt>
-                <c:pt idx="48">
-                  <c:v>0.994521895368273</c:v>
-                </c:pt>
-                <c:pt idx="49">
-                  <c:v>0.983254907563955</c:v>
-                </c:pt>
-                <c:pt idx="50">
-                  <c:v>0.965925826289068</c:v>
-                </c:pt>
-                <c:pt idx="51">
-                  <c:v>0.942641491092179</c:v>
-                </c:pt>
-                <c:pt idx="52">
-                  <c:v>0.913545457642601</c:v>
-                </c:pt>
-                <c:pt idx="53">
-                  <c:v>0.878817112661965</c:v>
-                </c:pt>
-                <c:pt idx="54">
-                  <c:v>0.838670567945424</c:v>
-                </c:pt>
-                <c:pt idx="55">
-                  <c:v>0.793353340291235</c:v>
-                </c:pt>
-                <c:pt idx="56">
-                  <c:v>0.743144825477394</c:v>
-                </c:pt>
-                <c:pt idx="57">
-                  <c:v>0.688354575693754</c:v>
-                </c:pt>
-                <c:pt idx="58">
-                  <c:v>0.629320391049837</c:v>
-                </c:pt>
-                <c:pt idx="59">
-                  <c:v>0.566406236924833</c:v>
-                </c:pt>
-                <c:pt idx="60">
-                  <c:v>0.5</c:v>
-                </c:pt>
-                <c:pt idx="61">
-                  <c:v>0.430511096808295</c:v>
-                </c:pt>
-                <c:pt idx="62">
-                  <c:v>0.3583679495453</c:v>
-                </c:pt>
-                <c:pt idx="63">
-                  <c:v>0.284015344703922</c:v>
-                </c:pt>
-                <c:pt idx="64">
-                  <c:v>0.207911690817759</c:v>
-                </c:pt>
-                <c:pt idx="65">
-                  <c:v>0.130526192220052</c:v>
-                </c:pt>
-                <c:pt idx="66">
-                  <c:v>0.0523359562429438</c:v>
-                </c:pt>
-                <c:pt idx="67">
-                  <c:v>-0.0261769483078727</c:v>
-                </c:pt>
-                <c:pt idx="68">
-                  <c:v>-0.104528463267653</c:v>
-                </c:pt>
-                <c:pt idx="69">
-                  <c:v>-0.182235525492148</c:v>
-                </c:pt>
-                <c:pt idx="70">
-                  <c:v>-0.258819045102521</c:v>
-                </c:pt>
-                <c:pt idx="71">
-                  <c:v>-0.333806859233771</c:v>
-                </c:pt>
-                <c:pt idx="72">
-                  <c:v>-0.4067366430758</c:v>
-                </c:pt>
-                <c:pt idx="73">
-                  <c:v>-0.477158760259608</c:v>
-                </c:pt>
-                <c:pt idx="74">
-                  <c:v>-0.544639035015027</c:v>
-                </c:pt>
-                <c:pt idx="75">
-                  <c:v>-0.60876142900872</c:v>
-                </c:pt>
-                <c:pt idx="76">
-                  <c:v>-0.669130606358858</c:v>
-                </c:pt>
-                <c:pt idx="77">
-                  <c:v>-0.725374371012288</c:v>
-                </c:pt>
-                <c:pt idx="78">
-                  <c:v>-0.777145961456971</c:v>
-                </c:pt>
-                <c:pt idx="79">
-                  <c:v>-0.824126188622016</c:v>
-                </c:pt>
-                <c:pt idx="80">
-                  <c:v>-0.866025403784439</c:v>
-                </c:pt>
-              </c:numCache>
-            </c:numRef>
-          </c:yVal>
-        </c:ser>
-        <c:ser>
-          <c:idx val="2"/>
-          <c:order val="2"/>
-          <c:tx>
-            <c:v>L3</c:v>
-          </c:tx>
-          <c:spPr>
-            <a:ln xmlns:a="http://schemas.openxmlformats.org/drawingml/2006/main" w="23813">
-              <a:solidFill>
-                <a:srgbClr val="267044"/>
-              </a:solidFill>
-            </a:ln>
-          </c:spPr>
-          <c:marker>
-            <c:symbol val="none"/>
-          </c:marker>
-          <c:xVal>
-            <c:numRef>
-              <c:f>'Chart Data'!$E$2:$E$82</c:f>
-              <c:numCache>
-                <c:formatCode>General</c:formatCode>
-                <c:ptCount val="81"/>
-                <c:pt idx="0">
-                  <c:v>0</c:v>
-                </c:pt>
-                <c:pt idx="1">
-                  <c:v>0.25</c:v>
-                </c:pt>
-                <c:pt idx="2">
-                  <c:v>0.5</c:v>
-                </c:pt>
-                <c:pt idx="3">
-                  <c:v>0.75</c:v>
-                </c:pt>
-                <c:pt idx="4">
-                  <c:v>1</c:v>
-                </c:pt>
-                <c:pt idx="5">
-                  <c:v>1.25</c:v>
-                </c:pt>
-                <c:pt idx="6">
-                  <c:v>1.5</c:v>
-                </c:pt>
-                <c:pt idx="7">
-                  <c:v>1.75</c:v>
-                </c:pt>
-                <c:pt idx="8">
-                  <c:v>2</c:v>
-                </c:pt>
-                <c:pt idx="9">
-                  <c:v>2.25</c:v>
-                </c:pt>
-                <c:pt idx="10">
-                  <c:v>2.5</c:v>
-                </c:pt>
-                <c:pt idx="11">
-                  <c:v>2.75</c:v>
-                </c:pt>
-                <c:pt idx="12">
-                  <c:v>3</c:v>
-                </c:pt>
-                <c:pt idx="13">
-                  <c:v>3.25</c:v>
-                </c:pt>
-                <c:pt idx="14">
-                  <c:v>3.5</c:v>
-                </c:pt>
-                <c:pt idx="15">
-                  <c:v>3.75</c:v>
-                </c:pt>
-                <c:pt idx="16">
-                  <c:v>4</c:v>
-                </c:pt>
-                <c:pt idx="17">
-                  <c:v>4.25</c:v>
-                </c:pt>
-                <c:pt idx="18">
-                  <c:v>4.5</c:v>
-                </c:pt>
-                <c:pt idx="19">
-                  <c:v>4.75</c:v>
-                </c:pt>
-                <c:pt idx="20">
-                  <c:v>5</c:v>
-                </c:pt>
-                <c:pt idx="21">
-                  <c:v>5.25</c:v>
-                </c:pt>
-                <c:pt idx="22">
-                  <c:v>5.5</c:v>
-                </c:pt>
-                <c:pt idx="23">
-                  <c:v>5.75</c:v>
-                </c:pt>
-                <c:pt idx="24">
-                  <c:v>6</c:v>
-                </c:pt>
-                <c:pt idx="25">
-                  <c:v>6.25</c:v>
-                </c:pt>
-                <c:pt idx="26">
-                  <c:v>6.5</c:v>
-                </c:pt>
-                <c:pt idx="27">
-                  <c:v>6.75</c:v>
-                </c:pt>
-                <c:pt idx="28">
-                  <c:v>7</c:v>
-                </c:pt>
-                <c:pt idx="29">
-                  <c:v>7.25</c:v>
-                </c:pt>
-                <c:pt idx="30">
-                  <c:v>7.5</c:v>
-                </c:pt>
-                <c:pt idx="31">
-                  <c:v>7.75</c:v>
-                </c:pt>
-                <c:pt idx="32">
-                  <c:v>8</c:v>
-                </c:pt>
-                <c:pt idx="33">
-                  <c:v>8.25</c:v>
-                </c:pt>
-                <c:pt idx="34">
-                  <c:v>8.5</c:v>
-                </c:pt>
-                <c:pt idx="35">
-                  <c:v>8.75</c:v>
-                </c:pt>
-                <c:pt idx="36">
-                  <c:v>9</c:v>
-                </c:pt>
-                <c:pt idx="37">
-                  <c:v>9.25</c:v>
-                </c:pt>
-                <c:pt idx="38">
-                  <c:v>9.5</c:v>
-                </c:pt>
-                <c:pt idx="39">
-                  <c:v>9.75</c:v>
-                </c:pt>
-                <c:pt idx="40">
-                  <c:v>10</c:v>
-                </c:pt>
-                <c:pt idx="41">
-                  <c:v>10.25</c:v>
-                </c:pt>
-                <c:pt idx="42">
-                  <c:v>10.5</c:v>
-                </c:pt>
-                <c:pt idx="43">
-                  <c:v>10.75</c:v>
-                </c:pt>
-                <c:pt idx="44">
-                  <c:v>11</c:v>
-                </c:pt>
-                <c:pt idx="45">
-                  <c:v>11.25</c:v>
-                </c:pt>
-                <c:pt idx="46">
-                  <c:v>11.5</c:v>
-                </c:pt>
-                <c:pt idx="47">
-                  <c:v>11.75</c:v>
-                </c:pt>
-                <c:pt idx="48">
-                  <c:v>12</c:v>
-                </c:pt>
-                <c:pt idx="49">
-                  <c:v>12.25</c:v>
-                </c:pt>
-                <c:pt idx="50">
-                  <c:v>12.5</c:v>
-                </c:pt>
-                <c:pt idx="51">
-                  <c:v>12.75</c:v>
-                </c:pt>
-                <c:pt idx="52">
-                  <c:v>13</c:v>
-                </c:pt>
-                <c:pt idx="53">
-                  <c:v>13.25</c:v>
-                </c:pt>
-                <c:pt idx="54">
-                  <c:v>13.5</c:v>
-                </c:pt>
-                <c:pt idx="55">
-                  <c:v>13.75</c:v>
-                </c:pt>
-                <c:pt idx="56">
-                  <c:v>14</c:v>
-                </c:pt>
-                <c:pt idx="57">
-                  <c:v>14.25</c:v>
-                </c:pt>
-                <c:pt idx="58">
-                  <c:v>14.5</c:v>
-                </c:pt>
-                <c:pt idx="59">
-                  <c:v>14.75</c:v>
-                </c:pt>
-                <c:pt idx="60">
-                  <c:v>15</c:v>
-                </c:pt>
-                <c:pt idx="61">
-                  <c:v>15.25</c:v>
-                </c:pt>
-                <c:pt idx="62">
-                  <c:v>15.5</c:v>
-                </c:pt>
-                <c:pt idx="63">
-                  <c:v>15.75</c:v>
-                </c:pt>
-                <c:pt idx="64">
-                  <c:v>16</c:v>
-                </c:pt>
-                <c:pt idx="65">
-                  <c:v>16.25</c:v>
-                </c:pt>
-                <c:pt idx="66">
-                  <c:v>16.5</c:v>
-                </c:pt>
-                <c:pt idx="67">
-                  <c:v>16.75</c:v>
-                </c:pt>
-                <c:pt idx="68">
-                  <c:v>17</c:v>
-                </c:pt>
-                <c:pt idx="69">
-                  <c:v>17.25</c:v>
-                </c:pt>
-                <c:pt idx="70">
-                  <c:v>17.5</c:v>
-                </c:pt>
-                <c:pt idx="71">
-                  <c:v>17.75</c:v>
-                </c:pt>
-                <c:pt idx="72">
-                  <c:v>18</c:v>
-                </c:pt>
-                <c:pt idx="73">
-                  <c:v>18.25</c:v>
-                </c:pt>
-                <c:pt idx="74">
-                  <c:v>18.5</c:v>
-                </c:pt>
-                <c:pt idx="75">
-                  <c:v>18.75</c:v>
-                </c:pt>
-                <c:pt idx="76">
-                  <c:v>19</c:v>
-                </c:pt>
-                <c:pt idx="77">
-                  <c:v>19.25</c:v>
-                </c:pt>
-                <c:pt idx="78">
-                  <c:v>19.5</c:v>
-                </c:pt>
-                <c:pt idx="79">
-                  <c:v>19.75</c:v>
-                </c:pt>
-                <c:pt idx="80">
-                  <c:v>20</c:v>
-                </c:pt>
-              </c:numCache>
-            </c:numRef>
-          </c:xVal>
-          <c:yVal>
-            <c:numRef>
-              <c:f>'Chart Data'!$F$2:$F$82</c:f>
-              <c:numCache>
-                <c:formatCode>0</c:formatCode>
-                <c:ptCount val="81"/>
-                <c:pt idx="0">
-                  <c:v>0.866025403784439</c:v>
-                </c:pt>
-                <c:pt idx="1">
-                  <c:v>0.824126188622016</c:v>
-                </c:pt>
-                <c:pt idx="2">
-                  <c:v>0.777145961456971</c:v>
-                </c:pt>
-                <c:pt idx="3">
-                  <c:v>0.725374371012288</c:v>
-                </c:pt>
-                <c:pt idx="4">
-                  <c:v>0.669130606358858</c:v>
-                </c:pt>
-                <c:pt idx="5">
-                  <c:v>0.608761429008721</c:v>
-                </c:pt>
-                <c:pt idx="6">
-                  <c:v>0.544639035015027</c:v>
-                </c:pt>
-                <c:pt idx="7">
-                  <c:v>0.477158760259609</c:v>
-                </c:pt>
-                <c:pt idx="8">
-                  <c:v>0.4067366430758</c:v>
-                </c:pt>
-                <c:pt idx="9">
-                  <c:v>0.333806859233771</c:v>
-                </c:pt>
-                <c:pt idx="10">
-                  <c:v>0.258819045102521</c:v>
-                </c:pt>
-                <c:pt idx="11">
-                  <c:v>0.182235525492148</c:v>
-                </c:pt>
-                <c:pt idx="12">
-                  <c:v>0.104528463267654</c:v>
-                </c:pt>
-                <c:pt idx="13">
-                  <c:v>0.0261769483078734</c:v>
-                </c:pt>
-                <c:pt idx="14">
-                  <c:v>-0.0523359562429436</c:v>
-                </c:pt>
-                <c:pt idx="15">
-                  <c:v>-0.130526192220051</c:v>
-                </c:pt>
-                <c:pt idx="16">
-                  <c:v>-0.207911690817759</c:v>
-                </c:pt>
-                <c:pt idx="17">
-                  <c:v>-0.284015344703922</c:v>
-                </c:pt>
-                <c:pt idx="18">
-                  <c:v>-0.3583679495453</c:v>
-                </c:pt>
-                <c:pt idx="19">
-                  <c:v>-0.430511096808295</c:v>
-                </c:pt>
-                <c:pt idx="20">
-                  <c:v>-0.5</c:v>
-                </c:pt>
-                <c:pt idx="21">
-                  <c:v>-0.566406236924833</c:v>
-                </c:pt>
-                <c:pt idx="22">
-                  <c:v>-0.629320391049837</c:v>
-                </c:pt>
-                <c:pt idx="23">
-                  <c:v>-0.688354575693754</c:v>
-                </c:pt>
-                <c:pt idx="24">
-                  <c:v>-0.743144825477394</c:v>
-                </c:pt>
-                <c:pt idx="25">
-                  <c:v>-0.793353340291235</c:v>
-                </c:pt>
-                <c:pt idx="26">
-                  <c:v>-0.838670567945424</c:v>
-                </c:pt>
-                <c:pt idx="27">
-                  <c:v>-0.878817112661965</c:v>
-                </c:pt>
-                <c:pt idx="28">
-                  <c:v>-0.913545457642601</c:v>
-                </c:pt>
-                <c:pt idx="29">
-                  <c:v>-0.942641491092178</c:v>
-                </c:pt>
-                <c:pt idx="30">
-                  <c:v>-0.965925826289068</c:v>
-                </c:pt>
-                <c:pt idx="31">
-                  <c:v>-0.983254907563955</c:v>
-                </c:pt>
-                <c:pt idx="32">
-                  <c:v>-0.994521895368273</c:v>
-                </c:pt>
-                <c:pt idx="33">
-                  <c:v>-0.999657324975557</c:v>
-                </c:pt>
-                <c:pt idx="34">
-                  <c:v>-0.998629534754574</c:v>
-                </c:pt>
-                <c:pt idx="35">
-                  <c:v>-0.99144486137381</c:v>
-                </c:pt>
-                <c:pt idx="36">
-                  <c:v>-0.978147600733806</c:v>
-                </c:pt>
-                <c:pt idx="37">
-                  <c:v>-0.958819734868193</c:v>
-                </c:pt>
-                <c:pt idx="38">
-                  <c:v>-0.933580426497202</c:v>
-                </c:pt>
-                <c:pt idx="39">
-                  <c:v>-0.902585284349861</c:v>
-                </c:pt>
-                <c:pt idx="40">
-                  <c:v>-0.866025403784439</c:v>
-                </c:pt>
-                <c:pt idx="41">
-                  <c:v>-0.824126188622016</c:v>
-                </c:pt>
-                <c:pt idx="42">
-                  <c:v>-0.777145961456971</c:v>
-                </c:pt>
-                <c:pt idx="43">
-                  <c:v>-0.725374371012288</c:v>
-                </c:pt>
-                <c:pt idx="44">
-                  <c:v>-0.669130606358859</c:v>
-                </c:pt>
-                <c:pt idx="45">
-                  <c:v>-0.608761429008721</c:v>
-                </c:pt>
-                <c:pt idx="46">
-                  <c:v>-0.544639035015027</c:v>
-                </c:pt>
-                <c:pt idx="47">
-                  <c:v>-0.477158760259608</c:v>
-                </c:pt>
-                <c:pt idx="48">
-                  <c:v>-0.406736643075801</c:v>
-                </c:pt>
-                <c:pt idx="49">
-                  <c:v>-0.333806859233771</c:v>
-                </c:pt>
-                <c:pt idx="50">
-                  <c:v>-0.258819045102521</c:v>
-                </c:pt>
-                <c:pt idx="51">
-                  <c:v>-0.182235525492149</c:v>
-                </c:pt>
-                <c:pt idx="52">
-                  <c:v>-0.104528463267654</c:v>
-                </c:pt>
-                <c:pt idx="53">
-                  <c:v>-0.0261769483078735</c:v>
-                </c:pt>
-                <c:pt idx="54">
-                  <c:v>0.0523359562429439</c:v>
-                </c:pt>
-                <c:pt idx="55">
-                  <c:v>0.130526192220052</c:v>
-                </c:pt>
-                <c:pt idx="56">
-                  <c:v>0.207911690817759</c:v>
-                </c:pt>
-                <c:pt idx="57">
-                  <c:v>0.284015344703922</c:v>
-                </c:pt>
-                <c:pt idx="58">
-                  <c:v>0.3583679495453</c:v>
-                </c:pt>
-                <c:pt idx="59">
-                  <c:v>0.430511096808294</c:v>
-                </c:pt>
-                <c:pt idx="60">
-                  <c:v>0.499999999999999</c:v>
-                </c:pt>
-                <c:pt idx="61">
-                  <c:v>0.566406236924832</c:v>
-                </c:pt>
-                <c:pt idx="62">
-                  <c:v>0.629320391049838</c:v>
-                </c:pt>
-                <c:pt idx="63">
-                  <c:v>0.688354575693754</c:v>
-                </c:pt>
-                <c:pt idx="64">
-                  <c:v>0.743144825477394</c:v>
-                </c:pt>
-                <c:pt idx="65">
-                  <c:v>0.793353340291235</c:v>
-                </c:pt>
-                <c:pt idx="66">
-                  <c:v>0.838670567945424</c:v>
-                </c:pt>
-                <c:pt idx="67">
-                  <c:v>0.878817112661965</c:v>
-                </c:pt>
-                <c:pt idx="68">
-                  <c:v>0.913545457642601</c:v>
-                </c:pt>
-                <c:pt idx="69">
-                  <c:v>0.942641491092178</c:v>
-                </c:pt>
-                <c:pt idx="70">
-                  <c:v>0.965925826289068</c:v>
-                </c:pt>
-                <c:pt idx="71">
-                  <c:v>0.983254907563955</c:v>
-                </c:pt>
-                <c:pt idx="72">
-                  <c:v>0.994521895368273</c:v>
-                </c:pt>
-                <c:pt idx="73">
-                  <c:v>0.999657324975557</c:v>
-                </c:pt>
-                <c:pt idx="74">
-                  <c:v>0.998629534754574</c:v>
-                </c:pt>
-                <c:pt idx="75">
-                  <c:v>0.991444861373811</c:v>
-                </c:pt>
-                <c:pt idx="76">
-                  <c:v>0.978147600733806</c:v>
-                </c:pt>
-                <c:pt idx="77">
-                  <c:v>0.958819734868193</c:v>
-                </c:pt>
-                <c:pt idx="78">
-                  <c:v>0.933580426497202</c:v>
-                </c:pt>
-                <c:pt idx="79">
-                  <c:v>0.90258528434986</c:v>
-                </c:pt>
-                <c:pt idx="80">
-                  <c:v>0.866025403784439</c:v>
-                </c:pt>
-              </c:numCache>
-            </c:numRef>
-          </c:yVal>
-        </c:ser>
-        <c:axId val="48650112"/>
-        <c:axId val="48672768"/>
-      </c:scatterChart>
-      <c:valAx>
-        <c:axId val="48672768"/>
-        <c:scaling>
-          <c:orientation val="minMax"/>
-          <c:max val="1"/>
-          <c:min val="-1"/>
-        </c:scaling>
-        <c:delete val="0"/>
-        <c:axPos val="l"/>
-        <c:title>
-          <c:tx>
-            <c:rich>
-              <a:bodyPr xmlns:a="http://schemas.openxmlformats.org/drawingml/2006/main"/>
-              <a:lstStyle xmlns:a="http://schemas.openxmlformats.org/drawingml/2006/main"/>
-              <a:p xmlns:a="http://schemas.openxmlformats.org/drawingml/2006/main">
-                <a:r>
-                  <a:rPr sz="1500">
-                    <a:latin typeface="Calibri"/>
-                    <a:ea typeface="Calibri"/>
-                    <a:cs typeface="Calibri"/>
-                  </a:rPr>
-                  <a:t>u/û</a:t>
-                </a:r>
-              </a:p>
-            </c:rich>
-          </c:tx>
-          <c:overlay val="0"/>
-          <c:txPr>
-            <a:bodyPr xmlns:a="http://schemas.openxmlformats.org/drawingml/2006/main" anchorCtr="1"/>
-            <a:lstStyle xmlns:a="http://schemas.openxmlformats.org/drawingml/2006/main"/>
-            <a:p xmlns:a="http://schemas.openxmlformats.org/drawingml/2006/main">
-              <a:pPr>
-                <a:defRPr sz="1500">
-                  <a:latin typeface="Calibri"/>
-                  <a:ea typeface="Calibri"/>
-                  <a:cs typeface="Calibri"/>
-                </a:defRPr>
-              </a:pPr>
-            </a:p>
-          </c:txPr>
-        </c:title>
-        <c:numFmt formatCode="0"/>
-        <c:majorTickMark val="none"/>
-        <c:minorTickMark val="none"/>
-        <c:spPr>
-          <a:ln xmlns:a="http://schemas.openxmlformats.org/drawingml/2006/main" w="9525">
-            <a:solidFill>
-              <a:srgbClr val="D4D4D4"/>
-            </a:solidFill>
-            <a:prstDash val="solid"/>
-          </a:ln>
-        </c:spPr>
-        <c:txPr>
-          <a:bodyPr xmlns:a="http://schemas.openxmlformats.org/drawingml/2006/main" anchorCtr="1"/>
-          <a:lstStyle xmlns:a="http://schemas.openxmlformats.org/drawingml/2006/main"/>
-          <a:p xmlns:a="http://schemas.openxmlformats.org/drawingml/2006/main">
-            <a:pPr>
-              <a:defRPr sz="1350">
-                <a:solidFill>
-                  <a:srgbClr val="666666"/>
-                </a:solidFill>
-                <a:latin typeface="Calibri"/>
-                <a:ea typeface="Calibri"/>
-                <a:cs typeface="Calibri"/>
-              </a:defRPr>
-            </a:pPr>
-          </a:p>
-        </c:txPr>
-        <c:crossAx val="48650112"/>
-        <c:majorUnit val="1"/>
-      </c:valAx>
-      <c:valAx>
-        <c:axId val="48650112"/>
-        <c:scaling>
-          <c:orientation val="minMax"/>
-          <c:max val="20"/>
-          <c:min val="0"/>
-        </c:scaling>
-        <c:delete val="0"/>
-        <c:axPos val="b"/>
-        <c:title>
-          <c:tx>
-            <c:rich>
-              <a:bodyPr xmlns:a="http://schemas.openxmlformats.org/drawingml/2006/main"/>
-              <a:lstStyle xmlns:a="http://schemas.openxmlformats.org/drawingml/2006/main"/>
-              <a:p xmlns:a="http://schemas.openxmlformats.org/drawingml/2006/main">
-                <a:r>
-                  <a:rPr sz="1500">
-                    <a:latin typeface="Calibri"/>
-                    <a:ea typeface="Calibri"/>
-                    <a:cs typeface="Calibri"/>
-                  </a:rPr>
-                  <a:t>Tid (ms)</a:t>
-                </a:r>
-              </a:p>
-            </c:rich>
-          </c:tx>
-          <c:overlay val="0"/>
-          <c:txPr>
-            <a:bodyPr xmlns:a="http://schemas.openxmlformats.org/drawingml/2006/main" anchorCtr="1"/>
-            <a:lstStyle xmlns:a="http://schemas.openxmlformats.org/drawingml/2006/main"/>
-            <a:p xmlns:a="http://schemas.openxmlformats.org/drawingml/2006/main">
-              <a:pPr>
-                <a:defRPr sz="1500">
-                  <a:latin typeface="Calibri"/>
-                  <a:ea typeface="Calibri"/>
-                  <a:cs typeface="Calibri"/>
-                </a:defRPr>
-              </a:pPr>
-            </a:p>
-          </c:txPr>
-        </c:title>
-        <c:numFmt formatCode="0"/>
-        <c:majorTickMark val="none"/>
-        <c:minorTickMark val="none"/>
-        <c:spPr>
-          <a:ln xmlns:a="http://schemas.openxmlformats.org/drawingml/2006/main" w="9525">
-            <a:solidFill>
-              <a:srgbClr val="D4D4D4"/>
-            </a:solidFill>
-            <a:prstDash val="solid"/>
-          </a:ln>
-        </c:spPr>
-        <c:txPr>
-          <a:bodyPr xmlns:a="http://schemas.openxmlformats.org/drawingml/2006/main" anchorCtr="1"/>
-          <a:lstStyle xmlns:a="http://schemas.openxmlformats.org/drawingml/2006/main"/>
-          <a:p xmlns:a="http://schemas.openxmlformats.org/drawingml/2006/main">
-            <a:pPr>
-              <a:defRPr sz="1350">
-                <a:solidFill>
-                  <a:srgbClr val="666666"/>
-                </a:solidFill>
-                <a:latin typeface="Calibri"/>
-                <a:ea typeface="Calibri"/>
-                <a:cs typeface="Calibri"/>
-              </a:defRPr>
-            </a:pPr>
-          </a:p>
-        </c:txPr>
-        <c:crossAx val="48672768"/>
-        <c:majorUnit val="5"/>
-      </c:valAx>
-      <c:spPr>
-        <a:solidFill xmlns:a="http://schemas.openxmlformats.org/drawingml/2006/main">
-          <a:srgbClr val="FFFFFF"/>
-        </a:solidFill>
-      </c:spPr>
-    </c:plotArea>
-    <c:legend>
-      <c:legendPos val="r"/>
-      <c:overlay val="0"/>
-      <c:txPr>
-        <a:bodyPr xmlns:a="http://schemas.openxmlformats.org/drawingml/2006/main" anchorCtr="1"/>
-        <a:lstStyle xmlns:a="http://schemas.openxmlformats.org/drawingml/2006/main"/>
-        <a:p xmlns:a="http://schemas.openxmlformats.org/drawingml/2006/main">
-          <a:pPr>
-            <a:defRPr sz="1500">
-              <a:latin typeface="Calibri"/>
-              <a:ea typeface="Calibri"/>
-              <a:cs typeface="Calibri"/>
-            </a:defRPr>
-          </a:pPr>
-        </a:p>
-      </c:txPr>
-    </c:legend>
-    <c:plotVisOnly val="1"/>
-  </c:chart>
-  <c:spPr>
-    <a:solidFill xmlns:a="http://schemas.openxmlformats.org/drawingml/2006/main">
-      <a:srgbClr val="FFFFFF"/>
-    </a:solidFill>
-  </c:spPr>
-  <c:externalData r:id="rIdChartSnapshot1">
-    <c:autoUpdate val="0"/>
-  </c:externalData>
-</c:chartSpace>
-</file>
-
 <file path=ppt/slides/slide1.xml><?xml version="1.0" encoding="utf-8"?>
 <p:sld xmlns:p="http://schemas.openxmlformats.org/presentationml/2006/main">
   <p:cSld>
@@ -10180,7 +8429,7 @@
                 <a:ea typeface="Calibri"/>
                 <a:cs typeface="Calibri"/>
               </a:rPr>
-              <a:t>Teori och exempel följs av övning 6–10.</a:t>
+              <a:t>Teori och exempel följs av övning 1.6–1.10.</a:t>
             </a:r>
           </a:p>
           <a:p xmlns:a="http://schemas.openxmlformats.org/drawingml/2006/main">
@@ -14396,7 +12645,7 @@
                 <a:ea typeface="Calibri"/>
                 <a:cs typeface="Calibri"/>
               </a:rPr>
-              <a:t>15 min övning 1, 2, 4, 5 min återkoppling</a:t>
+              <a:t>15 min övning 1.1, 1.2 och 1.4, 5 min återkoppling</a:t>
             </a:r>
           </a:p>
         </p:txBody>
@@ -14510,7 +12759,7 @@
                 <a:ea typeface="Calibri"/>
                 <a:cs typeface="Calibri"/>
               </a:rPr>
-              <a:t>20 min teori och exempel, 15 min övning 6, 7, 8</a:t>
+              <a:t>20 min teori och exempel, 15 min övning 1.6, 1.7 och 1.8</a:t>
             </a:r>
           </a:p>
           <a:p xmlns:a="http://schemas.openxmlformats.org/drawingml/2006/main">
@@ -18590,22 +16839,6 @@
           </a:p>
         </p:txBody>
       </p:sp>
-      <p:graphicFrame>
-        <p:nvGraphicFramePr>
-          <p:cNvPr id="13" name="Chart"/>
-          <p:cNvGraphicFramePr/>
-          <p:nvPr/>
-        </p:nvGraphicFramePr>
-        <p:xfrm>
-          <a:off xmlns:a="http://schemas.openxmlformats.org/drawingml/2006/main" x="1095375" y="2343150"/>
-          <a:ext xmlns:a="http://schemas.openxmlformats.org/drawingml/2006/main" cx="7048500" cy="2371725"/>
-        </p:xfrm>
-        <a:graphic xmlns:a="http://schemas.openxmlformats.org/drawingml/2006/main">
-          <a:graphicData uri="http://schemas.openxmlformats.org/drawingml/2006/chart">
-            <c:chart xmlns:r="http://schemas.openxmlformats.org/officeDocument/2006/relationships" xmlns:c="http://schemas.openxmlformats.org/drawingml/2006/chart" r:id="Rb3f478e257984d20"/>
-          </a:graphicData>
-        </a:graphic>
-      </p:graphicFrame>
       <p:sp>
         <p:nvSpPr>
           <p:cNvPr id="5" name="360°/3 = 120°">
@@ -18804,6 +17037,30 @@
           </a:p>
         </p:txBody>
       </p:sp>
+      <p:pic xmlns:a="http://schemas.openxmlformats.org/drawingml/2006/main" xmlns:r="http://schemas.openxmlformats.org/officeDocument/2006/relationships">
+        <p:nvPicPr>
+          <p:cNvPr id="11" name="schema-sinus" descr="L1, L2 och L3 över 20 ms (50 Hz), normaliserade, 120° isär."/>
+          <p:cNvPicPr>
+            <a:picLocks noChangeAspect="1"/>
+          </p:cNvPicPr>
+          <p:nvPr/>
+        </p:nvPicPr>
+        <p:blipFill>
+          <a:blip r:embed="rId3"/>
+          <a:stretch>
+            <a:fillRect/>
+          </a:stretch>
+        </p:blipFill>
+        <p:spPr>
+          <a:xfrm>
+            <a:off x="1450848" y="2395728"/>
+            <a:ext cx="6242304" cy="2340864"/>
+          </a:xfrm>
+          <a:prstGeom prst="rect">
+            <a:avLst/>
+          </a:prstGeom>
+        </p:spPr>
+      </p:pic>
     </p:spTree>
     <p:extLst>
       <p:ext uri="{BB962C8B-B14F-4D97-AF65-F5344CB8AC3E}">

</xml_diff>

<commit_message>
Sjöskolan: TSFS 2017:26, tre arbetsmetoder enligt SS-EN 50110-1, land/sjö-sammanhang i övningar
Co-Authored-By: Claude Opus 5.5 <noreply@anthropic.com>
Claude-Session: https://claude.ai/code/session_011V9KjBb53XrDm23Dw58SH3
</commit_message>
<xml_diff>
--- a/sjoskolan/vecka-41/aktuell/v41_01_Trefassystemets_grunder_elev.pptx
+++ b/sjoskolan/vecka-41/aktuell/v41_01_Trefassystemets_grunder_elev.pptx
@@ -4708,7 +4708,7 @@
                 <a:ea typeface="Calibri"/>
                 <a:cs typeface="Calibri"/>
               </a:rPr>
-              <a:t>Förutsättningar: f = 50 Hz och φ = 120°.</a:t>
+              <a:t>Förutsättningar: Landnätet vid kaj. f = 50 Hz och φ = 120°.</a:t>
             </a:r>
           </a:p>
         </p:txBody>
@@ -5544,7 +5544,7 @@
                 <a:ea typeface="Calibri"/>
                 <a:cs typeface="Calibri"/>
               </a:rPr>
-              <a:t>Förutsättningar: Symmetrisk trefaskälla med U</a:t>
+              <a:t>Förutsättningar: Landström vid kaj, 50 Hz. Symmetrisk trefaskälla med U</a:t>
             </a:r>
             <a:r>
               <a:rPr sz="2025" b="0" baseline="-25000">
@@ -6391,7 +6391,7 @@
                 <a:ea typeface="Calibri"/>
                 <a:cs typeface="Calibri"/>
               </a:rPr>
-              <a:t>Förutsättningar: Symmetrisk källa. U</a:t>
+              <a:t>Förutsättningar: Landnät 230/400 V. Symmetrisk källa. U</a:t>
             </a:r>
             <a:r>
               <a:rPr sz="2025" b="0" baseline="-25000">

</xml_diff>

<commit_message>
Sjöskolan v41 Del 1: linjespänning som vektoriell skillnad, U12-kurva med toppvärde √3, mätpunkter vid jordfel
Co-Authored-By: Claude Opus 5.5 <noreply@anthropic.com>
Claude-Session: https://claude.ai/code/session_011V9KjBb53XrDm23Dw58SH3
</commit_message>
<xml_diff>
--- a/sjoskolan/vecka-41/aktuell/v41_01_Trefassystemets_grunder_elev.pptx
+++ b/sjoskolan/vecka-41/aktuell/v41_01_Trefassystemets_grunder_elev.pptx
@@ -9629,7 +9629,7 @@
                 <a:ea typeface="Calibri"/>
                 <a:cs typeface="Calibri"/>
               </a:rPr>
-              <a:t>Skriv alltid ut båda mätpunkterna i protokollet.</a:t>
+              <a:t>Skriv alltid ut båda mätpunkterna.</a:t>
             </a:r>
           </a:p>
           <a:p xmlns:a="http://schemas.openxmlformats.org/drawingml/2006/main">
@@ -9653,7 +9653,53 @@
                 <a:ea typeface="Calibri"/>
                 <a:cs typeface="Calibri"/>
               </a:rPr>
-              <a:t>400 V mellan faser visar inte att varje fas–jordvärde är 230 V.</a:t>
+              <a:t>400 V mellan faser visar inte att fas–jord är 230 V.</a:t>
+            </a:r>
+          </a:p>
+          <a:p xmlns:a="http://schemas.openxmlformats.org/drawingml/2006/main">
+            <a:pPr algn="l">
+              <a:buNone/>
+              <a:defRPr sz="2250" b="0">
+                <a:solidFill>
+                  <a:srgbClr val="111111"/>
+                </a:solidFill>
+                <a:latin typeface="Calibri"/>
+                <a:ea typeface="Calibri"/>
+                <a:cs typeface="Calibri"/>
+              </a:defRPr>
+            </a:pPr>
+            <a:r>
+              <a:rPr sz="1800" b="0">
+                <a:solidFill>
+                  <a:srgbClr val="111111"/>
+                </a:solidFill>
+                <a:latin typeface="Calibri"/>
+                <a:ea typeface="Calibri"/>
+                <a:cs typeface="Calibri"/>
+              </a:rPr>
+              <a:t>Vid nollavbrott eller jordfel kan fas–jord visa 0 V till hela U</a:t>
+            </a:r>
+            <a:r>
+              <a:rPr sz="1800" b="0" baseline="-25000">
+                <a:solidFill>
+                  <a:srgbClr val="111111"/>
+                </a:solidFill>
+                <a:latin typeface="Calibri"/>
+                <a:ea typeface="Calibri"/>
+                <a:cs typeface="Calibri"/>
+              </a:rPr>
+              <a:t>L</a:t>
+            </a:r>
+            <a:r>
+              <a:rPr sz="1800" b="0">
+                <a:solidFill>
+                  <a:srgbClr val="111111"/>
+                </a:solidFill>
+                <a:latin typeface="Calibri"/>
+                <a:ea typeface="Calibri"/>
+                <a:cs typeface="Calibri"/>
+              </a:rPr>
+              <a:t>.</a:t>
             </a:r>
           </a:p>
         </p:txBody>
@@ -9718,7 +9764,7 @@
       </p:sp>
       <p:pic xmlns:a="http://schemas.openxmlformats.org/drawingml/2006/main" xmlns:r="http://schemas.openxmlformats.org/officeDocument/2006/relationships">
         <p:nvPicPr>
-          <p:cNvPr id="9" name="Figur: Mätpunkter för linjespänningarna U12, U2" descr="Mätpunkter för linjespänningarna U12, U23, U31 och fasspänningen U1N"/>
+          <p:cNvPr id="9" name="Figur: Mätpunkter för linjespänningarna U12, U2" descr="Mätpunkter: linjespänningarna U12, U23 och U31 mellan två faser, fasspänningen U1N mellan fas och N"/>
           <p:cNvPicPr>
             <a:picLocks noChangeAspect="1"/>
           </p:cNvPicPr>
@@ -16950,7 +16996,7 @@
                 <a:ea typeface="Calibri"/>
                 <a:cs typeface="Calibri"/>
               </a:rPr>
-              <a:t>Vid 50 Hz motsvarar 120° ett tidsavstånd på 6,67 ms.</a:t>
+              <a:t>Vid 50 Hz motsvarar 120° ett tidsavstånd på 6,67 ms.</a:t>
             </a:r>
           </a:p>
           <a:p xmlns:a="http://schemas.openxmlformats.org/drawingml/2006/main">
@@ -16974,7 +17020,29 @@
                 <a:ea typeface="Calibri"/>
                 <a:cs typeface="Calibri"/>
               </a:rPr>
-              <a:t>Kurvorna är normaliserade till samma toppvärde.</a:t>
+              <a:t>Faserna har toppvärdet 1. Streckad: U</a:t>
+            </a:r>
+            <a:r>
+              <a:rPr sz="2000" b="0" baseline="-25000">
+                <a:solidFill>
+                  <a:srgbClr val="111111"/>
+                </a:solidFill>
+                <a:latin typeface="Calibri"/>
+                <a:ea typeface="Calibri"/>
+                <a:cs typeface="Calibri"/>
+              </a:rPr>
+              <a:t>12</a:t>
+            </a:r>
+            <a:r>
+              <a:rPr sz="2000" b="0">
+                <a:solidFill>
+                  <a:srgbClr val="111111"/>
+                </a:solidFill>
+                <a:latin typeface="Calibri"/>
+                <a:ea typeface="Calibri"/>
+                <a:cs typeface="Calibri"/>
+              </a:rPr>
+              <a:t> = L1 − L2 med toppvärdet √3.</a:t>
             </a:r>
           </a:p>
         </p:txBody>
@@ -17039,22 +17107,22 @@
       </p:sp>
       <p:pic xmlns:a="http://schemas.openxmlformats.org/drawingml/2006/main" xmlns:r="http://schemas.openxmlformats.org/officeDocument/2006/relationships">
         <p:nvPicPr>
-          <p:cNvPr id="11" name="schema-sinus" descr="L1, L2 och L3 över 20 ms (50 Hz), normaliserade, 120° isär."/>
+          <p:cNvPr id="11" name="schema-sinus" descr="L1, L2 och L3 över 20 ms (50 Hz) med toppvärdet 1, 120° isär. Streckad: linjespänningen U12 = L1 − L2 med toppvärdet √3 ≈ 1,73."/>
           <p:cNvPicPr>
             <a:picLocks noChangeAspect="1"/>
           </p:cNvPicPr>
           <p:nvPr/>
         </p:nvPicPr>
         <p:blipFill>
-          <a:blip r:embed="rId3"/>
+          <a:blip r:embed="rId5"/>
           <a:stretch>
             <a:fillRect/>
           </a:stretch>
         </p:blipFill>
         <p:spPr>
           <a:xfrm>
-            <a:off x="1450848" y="2395728"/>
-            <a:ext cx="6242304" cy="2340864"/>
+            <a:off x="1710944" y="2395728"/>
+            <a:ext cx="5722112" cy="2340864"/>
           </a:xfrm>
           <a:prstGeom prst="rect">
             <a:avLst/>
@@ -17240,7 +17308,73 @@
                 <a:ea typeface="Calibri"/>
                 <a:cs typeface="Calibri"/>
               </a:rPr>
-              <a:t>: mellan fas och källans neutralpunkt.</a:t>
+              <a:t> (U</a:t>
+            </a:r>
+            <a:r>
+              <a:rPr sz="1800" b="0" baseline="-25000">
+                <a:solidFill>
+                  <a:srgbClr val="111111"/>
+                </a:solidFill>
+                <a:latin typeface="Calibri"/>
+                <a:ea typeface="Calibri"/>
+                <a:cs typeface="Calibri"/>
+              </a:rPr>
+              <a:t>1N</a:t>
+            </a:r>
+            <a:r>
+              <a:rPr sz="1800" b="0">
+                <a:solidFill>
+                  <a:srgbClr val="111111"/>
+                </a:solidFill>
+                <a:latin typeface="Calibri"/>
+                <a:ea typeface="Calibri"/>
+                <a:cs typeface="Calibri"/>
+              </a:rPr>
+              <a:t>, U</a:t>
+            </a:r>
+            <a:r>
+              <a:rPr sz="1800" b="0" baseline="-25000">
+                <a:solidFill>
+                  <a:srgbClr val="111111"/>
+                </a:solidFill>
+                <a:latin typeface="Calibri"/>
+                <a:ea typeface="Calibri"/>
+                <a:cs typeface="Calibri"/>
+              </a:rPr>
+              <a:t>2N</a:t>
+            </a:r>
+            <a:r>
+              <a:rPr sz="1800" b="0">
+                <a:solidFill>
+                  <a:srgbClr val="111111"/>
+                </a:solidFill>
+                <a:latin typeface="Calibri"/>
+                <a:ea typeface="Calibri"/>
+                <a:cs typeface="Calibri"/>
+              </a:rPr>
+              <a:t>, U</a:t>
+            </a:r>
+            <a:r>
+              <a:rPr sz="1800" b="0" baseline="-25000">
+                <a:solidFill>
+                  <a:srgbClr val="111111"/>
+                </a:solidFill>
+                <a:latin typeface="Calibri"/>
+                <a:ea typeface="Calibri"/>
+                <a:cs typeface="Calibri"/>
+              </a:rPr>
+              <a:t>3N</a:t>
+            </a:r>
+            <a:r>
+              <a:rPr sz="1800" b="0">
+                <a:solidFill>
+                  <a:srgbClr val="111111"/>
+                </a:solidFill>
+                <a:latin typeface="Calibri"/>
+                <a:ea typeface="Calibri"/>
+                <a:cs typeface="Calibri"/>
+              </a:rPr>
+              <a:t>): mellan en fas och nollpunkten.</a:t>
             </a:r>
           </a:p>
           <a:p xmlns:a="http://schemas.openxmlformats.org/drawingml/2006/main">
@@ -17286,7 +17420,73 @@
                 <a:ea typeface="Calibri"/>
                 <a:cs typeface="Calibri"/>
               </a:rPr>
-              <a:t>: mellan två faser, även kallad huvudspänning.</a:t>
+              <a:t> (U</a:t>
+            </a:r>
+            <a:r>
+              <a:rPr sz="1800" b="0" baseline="-25000">
+                <a:solidFill>
+                  <a:srgbClr val="111111"/>
+                </a:solidFill>
+                <a:latin typeface="Calibri"/>
+                <a:ea typeface="Calibri"/>
+                <a:cs typeface="Calibri"/>
+              </a:rPr>
+              <a:t>12</a:t>
+            </a:r>
+            <a:r>
+              <a:rPr sz="1800" b="0">
+                <a:solidFill>
+                  <a:srgbClr val="111111"/>
+                </a:solidFill>
+                <a:latin typeface="Calibri"/>
+                <a:ea typeface="Calibri"/>
+                <a:cs typeface="Calibri"/>
+              </a:rPr>
+              <a:t>, U</a:t>
+            </a:r>
+            <a:r>
+              <a:rPr sz="1800" b="0" baseline="-25000">
+                <a:solidFill>
+                  <a:srgbClr val="111111"/>
+                </a:solidFill>
+                <a:latin typeface="Calibri"/>
+                <a:ea typeface="Calibri"/>
+                <a:cs typeface="Calibri"/>
+              </a:rPr>
+              <a:t>23</a:t>
+            </a:r>
+            <a:r>
+              <a:rPr sz="1800" b="0">
+                <a:solidFill>
+                  <a:srgbClr val="111111"/>
+                </a:solidFill>
+                <a:latin typeface="Calibri"/>
+                <a:ea typeface="Calibri"/>
+                <a:cs typeface="Calibri"/>
+              </a:rPr>
+              <a:t>, U</a:t>
+            </a:r>
+            <a:r>
+              <a:rPr sz="1800" b="0" baseline="-25000">
+                <a:solidFill>
+                  <a:srgbClr val="111111"/>
+                </a:solidFill>
+                <a:latin typeface="Calibri"/>
+                <a:ea typeface="Calibri"/>
+                <a:cs typeface="Calibri"/>
+              </a:rPr>
+              <a:t>31</a:t>
+            </a:r>
+            <a:r>
+              <a:rPr sz="1800" b="0">
+                <a:solidFill>
+                  <a:srgbClr val="111111"/>
+                </a:solidFill>
+                <a:latin typeface="Calibri"/>
+                <a:ea typeface="Calibri"/>
+                <a:cs typeface="Calibri"/>
+              </a:rPr>
+              <a:t>): mellan två faser, även kallad huvudspänning.</a:t>
             </a:r>
           </a:p>
         </p:txBody>
@@ -17524,7 +17724,7 @@
       </p:sp>
       <p:pic xmlns:a="http://schemas.openxmlformats.org/drawingml/2006/main" xmlns:r="http://schemas.openxmlformats.org/officeDocument/2006/relationships">
         <p:nvPicPr>
-          <p:cNvPr id="9" name="Figur: Tre fasspänningsvisare 120 grader isär; " descr="Tre fasspänningsvisare 120 grader isär; linjespänningen U12 är sträckan mellan två visarspetsar"/>
+          <p:cNvPr id="9" name="Figur: Tre fasspänningsvisare 120 grader isär; " descr="Fasspänningarna U1N, U2N och U3N (fas–nollpunkt) 120 grader isär; linjespänningen U12 (fas–fas, huvudspänning) är sträckan mellan två visarspetsar"/>
           <p:cNvPicPr>
             <a:picLocks noChangeAspect="1"/>
           </p:cNvPicPr>
@@ -17703,7 +17903,73 @@
                 <a:ea typeface="Calibri"/>
                 <a:cs typeface="Calibri"/>
               </a:rPr>
-              <a:t>Linjespänningen är skillnaden mellan två fasvisare.</a:t>
+              <a:t>U</a:t>
+            </a:r>
+            <a:r>
+              <a:rPr sz="2200" b="0" baseline="-25000">
+                <a:solidFill>
+                  <a:srgbClr val="111111"/>
+                </a:solidFill>
+                <a:latin typeface="Calibri"/>
+                <a:ea typeface="Calibri"/>
+                <a:cs typeface="Calibri"/>
+              </a:rPr>
+              <a:t>12</a:t>
+            </a:r>
+            <a:r>
+              <a:rPr sz="2200" b="0">
+                <a:solidFill>
+                  <a:srgbClr val="111111"/>
+                </a:solidFill>
+                <a:latin typeface="Calibri"/>
+                <a:ea typeface="Calibri"/>
+                <a:cs typeface="Calibri"/>
+              </a:rPr>
+              <a:t> = U</a:t>
+            </a:r>
+            <a:r>
+              <a:rPr sz="2200" b="0" baseline="-25000">
+                <a:solidFill>
+                  <a:srgbClr val="111111"/>
+                </a:solidFill>
+                <a:latin typeface="Calibri"/>
+                <a:ea typeface="Calibri"/>
+                <a:cs typeface="Calibri"/>
+              </a:rPr>
+              <a:t>1N</a:t>
+            </a:r>
+            <a:r>
+              <a:rPr sz="2200" b="0">
+                <a:solidFill>
+                  <a:srgbClr val="111111"/>
+                </a:solidFill>
+                <a:latin typeface="Calibri"/>
+                <a:ea typeface="Calibri"/>
+                <a:cs typeface="Calibri"/>
+              </a:rPr>
+              <a:t> − U</a:t>
+            </a:r>
+            <a:r>
+              <a:rPr sz="2200" b="0" baseline="-25000">
+                <a:solidFill>
+                  <a:srgbClr val="111111"/>
+                </a:solidFill>
+                <a:latin typeface="Calibri"/>
+                <a:ea typeface="Calibri"/>
+                <a:cs typeface="Calibri"/>
+              </a:rPr>
+              <a:t>2N</a:t>
+            </a:r>
+            <a:r>
+              <a:rPr sz="2200" b="0">
+                <a:solidFill>
+                  <a:srgbClr val="111111"/>
+                </a:solidFill>
+                <a:latin typeface="Calibri"/>
+                <a:ea typeface="Calibri"/>
+                <a:cs typeface="Calibri"/>
+              </a:rPr>
+              <a:t> är en vektoriell skillnad.</a:t>
             </a:r>
           </a:p>
           <a:p xmlns:a="http://schemas.openxmlformats.org/drawingml/2006/main">
@@ -17727,7 +17993,7 @@
                 <a:ea typeface="Calibri"/>
                 <a:cs typeface="Calibri"/>
               </a:rPr>
-              <a:t>Visarna har samma längd och ligger 120° isär.</a:t>
+              <a:t>Lika långa visare, 120° isär.</a:t>
             </a:r>
           </a:p>
         </p:txBody>
@@ -17999,7 +18265,7 @@
                 <a:ea typeface="Calibri"/>
                 <a:cs typeface="Calibri"/>
               </a:rPr>
-              <a:t>Därför blir U</a:t>
+              <a:t>Därför är U</a:t>
             </a:r>
             <a:r>
               <a:rPr sz="2250" b="0" baseline="-25000">
@@ -18021,7 +18287,29 @@
                 <a:ea typeface="Calibri"/>
                 <a:cs typeface="Calibri"/>
               </a:rPr>
-              <a:t> = √3 U</a:t>
+              <a:t> = √3 · U</a:t>
+            </a:r>
+            <a:r>
+              <a:rPr sz="2250" b="0" baseline="-25000">
+                <a:solidFill>
+                  <a:srgbClr val="111111"/>
+                </a:solidFill>
+                <a:latin typeface="Calibri"/>
+                <a:ea typeface="Calibri"/>
+                <a:cs typeface="Calibri"/>
+              </a:rPr>
+              <a:t>F</a:t>
+            </a:r>
+            <a:r>
+              <a:rPr sz="2250" b="0">
+                <a:solidFill>
+                  <a:srgbClr val="111111"/>
+                </a:solidFill>
+                <a:latin typeface="Calibri"/>
+                <a:ea typeface="Calibri"/>
+                <a:cs typeface="Calibri"/>
+              </a:rPr>
+              <a:t> i ett symmetriskt system, aldrig 2 · U</a:t>
             </a:r>
             <a:r>
               <a:rPr sz="2250" b="0" baseline="-25000">
@@ -18108,7 +18396,7 @@
       </p:sp>
       <p:pic xmlns:a="http://schemas.openxmlformats.org/drawingml/2006/main" xmlns:r="http://schemas.openxmlformats.org/officeDocument/2006/relationships">
         <p:nvPicPr>
-          <p:cNvPr id="9" name="Figur: Linjespänningen U12 som skillnaden mella" descr="Linjespänningen U12 som skillnaden mellan fasvisarna U1N och U2N med 120 grader mellan dem"/>
+          <p:cNvPr id="9" name="Figur: Linjespänningen U12 som skillnaden mella" descr="Linjespänningen U12 är den vektoriella skillnaden mellan fasspänningarna U1N och U2N, sträckan mellan visarspetsarna; i ett symmetriskt system √3 gånger fasspänningen"/>
           <p:cNvPicPr>
             <a:picLocks noChangeAspect="1"/>
           </p:cNvPicPr>

</xml_diff>

<commit_message>
Sjöskolan v41: 3D-figurer i del 1 och 2 och interaktiv generator
Generatorn, stjärnkopplingen, plinten och transformatorn som 3D-figurer i
presentationerna, delsidorna och bildspelen. Ny sida generatorn/ där eleven
vrider rotorn och ser de tre spänningarna ritas i takt.

Co-Authored-By: Claude Opus 5.5 <noreply@anthropic.com>
Claude-Session: https://claude.ai/code/session_011V9KjBb53XrDm23Dw58SH3
</commit_message>
<xml_diff>
--- a/sjoskolan/vecka-41/aktuell/v41_01_Trefassystemets_grunder_elev.pptx
+++ b/sjoskolan/vecka-41/aktuell/v41_01_Trefassystemets_grunder_elev.pptx
@@ -15862,7 +15862,7 @@
         <p:spPr>
           <a:xfrm xmlns:a="http://schemas.openxmlformats.org/drawingml/2006/main">
             <a:off x="762000" y="1666875"/>
-            <a:ext cx="7620000" cy="942975"/>
+            <a:ext cx="3977639" cy="942975"/>
           </a:xfrm>
           <a:prstGeom xmlns:a="http://schemas.openxmlformats.org/drawingml/2006/main" prst="rect">
             <a:avLst/>
@@ -15889,7 +15889,7 @@
               </a:defRPr>
             </a:pPr>
             <a:r>
-              <a:rPr sz="2250" b="0">
+              <a:rPr sz="2050" b="0">
                 <a:solidFill>
                   <a:srgbClr val="111111"/>
                 </a:solidFill>
@@ -15900,7 +15900,7 @@
               <a:t>U</a:t>
             </a:r>
             <a:r>
-              <a:rPr sz="2250" b="0" baseline="-25000">
+              <a:rPr sz="2050" b="0" baseline="-25000">
                 <a:solidFill>
                   <a:srgbClr val="111111"/>
                 </a:solidFill>
@@ -15911,7 +15911,7 @@
               <a:t>L</a:t>
             </a:r>
             <a:r>
-              <a:rPr sz="2250" b="0">
+              <a:rPr sz="2050" b="0">
                 <a:solidFill>
                   <a:srgbClr val="111111"/>
                 </a:solidFill>
@@ -15941,7 +15941,7 @@
         <p:spPr>
           <a:xfrm xmlns:a="http://schemas.openxmlformats.org/drawingml/2006/main">
             <a:off x="762000" y="2714625"/>
-            <a:ext cx="7620000" cy="942975"/>
+            <a:ext cx="3977639" cy="942975"/>
           </a:xfrm>
           <a:prstGeom xmlns:a="http://schemas.openxmlformats.org/drawingml/2006/main" prst="rect">
             <a:avLst/>
@@ -16020,7 +16020,7 @@
         <p:spPr>
           <a:xfrm xmlns:a="http://schemas.openxmlformats.org/drawingml/2006/main">
             <a:off x="762000" y="3762375"/>
-            <a:ext cx="7620000" cy="942975"/>
+            <a:ext cx="3977639" cy="942975"/>
           </a:xfrm>
           <a:prstGeom xmlns:a="http://schemas.openxmlformats.org/drawingml/2006/main" prst="rect">
             <a:avLst/>
@@ -16077,7 +16077,7 @@
         <p:spPr>
           <a:xfrm xmlns:a="http://schemas.openxmlformats.org/drawingml/2006/main">
             <a:off x="762000" y="4810125"/>
-            <a:ext cx="7620000" cy="942975"/>
+            <a:ext cx="3977639" cy="942975"/>
           </a:xfrm>
           <a:prstGeom xmlns:a="http://schemas.openxmlformats.org/drawingml/2006/main" prst="rect">
             <a:avLst/>
@@ -16104,7 +16104,7 @@
               </a:defRPr>
             </a:pPr>
             <a:r>
-              <a:rPr sz="2250" b="0">
+              <a:rPr sz="2000" b="0">
                 <a:solidFill>
                   <a:srgbClr val="111111"/>
                 </a:solidFill>
@@ -16174,6 +16174,30 @@
           </a:p>
         </p:txBody>
       </p:sp>
+      <p:pic xmlns:a="http://schemas.openxmlformats.org/drawingml/2006/main" xmlns:r="http://schemas.openxmlformats.org/officeDocument/2006/relationships">
+        <p:nvPicPr>
+          <p:cNvPr id="16" name="Figur: Generatorn kopplad i Y med kabeln L1, L2" descr="Generatorn kopplad i Y med kabeln L1, L2, L3 och N: linjespänningen UL mäts mellan två fasledare, fasspänningen UF mellan en fasledare och N; stjärnpunkten blir N"/>
+          <p:cNvPicPr>
+            <a:picLocks noChangeAspect="1"/>
+          </p:cNvPicPr>
+          <p:nvPr/>
+        </p:nvPicPr>
+        <p:blipFill>
+          <a:blip r:embed="rId4"/>
+          <a:stretch>
+            <a:fillRect/>
+          </a:stretch>
+        </p:blipFill>
+        <p:spPr>
+          <a:xfrm>
+            <a:off x="4892040" y="1645920"/>
+            <a:ext cx="3886200" cy="2173417"/>
+          </a:xfrm>
+          <a:prstGeom prst="rect">
+            <a:avLst/>
+          </a:prstGeom>
+        </p:spPr>
+      </p:pic>
     </p:spTree>
     <p:extLst>
       <p:ext uri="{BB962C8B-B14F-4D97-AF65-F5344CB8AC3E}">
@@ -17107,22 +17131,22 @@
       </p:sp>
       <p:pic xmlns:a="http://schemas.openxmlformats.org/drawingml/2006/main" xmlns:r="http://schemas.openxmlformats.org/officeDocument/2006/relationships">
         <p:nvPicPr>
-          <p:cNvPr id="11" name="schema-sinus" descr="L1, L2 och L3 över 20 ms (50 Hz) med toppvärdet 1, 120° isär. Streckad: linjespänningen U12 = L1 − L2 med toppvärdet √3 ≈ 1,73."/>
+          <p:cNvPr id="11" name="Figur: Generatorn i 3D: tre spolar 120° isär oc" descr="Generatorn i 3D: tre spolar 120° isär och en roterande magnet; bredvid kurvorna L1, L2 och L3 över 20 ms (50 Hz), 120° isär, med linjespänningen U12 = L1 − L2 streckad med toppvärdet √3 gånger fasens"/>
           <p:cNvPicPr>
             <a:picLocks noChangeAspect="1"/>
           </p:cNvPicPr>
           <p:nvPr/>
         </p:nvPicPr>
         <p:blipFill>
-          <a:blip r:embed="rId5"/>
+          <a:blip r:embed="rId6"/>
           <a:stretch>
             <a:fillRect/>
           </a:stretch>
         </p:blipFill>
         <p:spPr>
           <a:xfrm>
-            <a:off x="1710944" y="2395728"/>
-            <a:ext cx="5722112" cy="2340864"/>
+            <a:off x="914400" y="2395728"/>
+            <a:ext cx="7315200" cy="2333549"/>
           </a:xfrm>
           <a:prstGeom prst="rect">
             <a:avLst/>

</xml_diff>

<commit_message>
Sjöskolan: 3D-figurer i vecka 42 och granskning av vecka 41:s figurer
Vecka 42: beröringsspänning, ljusbåge, riskområde och närområde, frånskilj,
lås, märk och prova samt jordning och kortslutning i 3D, granskade för
fysisk riktighet. Vecka 41: övning 1.4 visade fel spänning, bild 6 markerar
tidpunkten, texten i övning 1.10 flyttad. Ny kontroll av figurernas tal.

Co-Authored-By: Claude Opus 5.5 <noreply@anthropic.com>
Claude-Session: https://claude.ai/code/session_011V9KjBb53XrDm23Dw58SH3
</commit_message>
<xml_diff>
--- a/sjoskolan/vecka-41/aktuell/v41_01_Trefassystemets_grunder_elev.pptx
+++ b/sjoskolan/vecka-41/aktuell/v41_01_Trefassystemets_grunder_elev.pptx
@@ -6914,14 +6914,14 @@
       </p:sp>
       <p:pic xmlns:a="http://schemas.openxmlformats.org/drawingml/2006/main" xmlns:r="http://schemas.openxmlformats.org/officeDocument/2006/relationships">
         <p:nvPicPr>
-          <p:cNvPr id="9" name="Figur: Ledarna L1, L2, L3 och N; fasspänningen " descr="Ledarna L1, L2, L3 och N; fasspänningen 120 V mellan L1 och N, linjespänningen okänd"/>
+          <p:cNvPr id="9" name="Figur: Ledarna L1, L2, L3 och N; fasspänningen " descr="Ledarna L1, L2, L3 och N; fasspänningen 230 V mellan L1 och N, linjespänningen okänd"/>
           <p:cNvPicPr>
             <a:picLocks noChangeAspect="1"/>
           </p:cNvPicPr>
           <p:nvPr/>
         </p:nvPicPr>
         <p:blipFill>
-          <a:blip r:embed="rId3"/>
+          <a:blip r:embed="rId4"/>
           <a:stretch>
             <a:fillRect/>
           </a:stretch>
@@ -15043,7 +15043,7 @@
           <p:nvPr/>
         </p:nvPicPr>
         <p:blipFill>
-          <a:blip r:embed="rId3"/>
+          <a:blip r:embed="rId5"/>
           <a:stretch>
             <a:fillRect/>
           </a:stretch>
@@ -17131,14 +17131,14 @@
       </p:sp>
       <p:pic xmlns:a="http://schemas.openxmlformats.org/drawingml/2006/main" xmlns:r="http://schemas.openxmlformats.org/officeDocument/2006/relationships">
         <p:nvPicPr>
-          <p:cNvPr id="11" name="Figur: Generatorn i 3D: tre spolar 120° isär oc" descr="Generatorn i 3D: tre spolar 120° isär och en roterande magnet; bredvid kurvorna L1, L2 och L3 över 20 ms (50 Hz), 120° isär, med linjespänningen U12 = L1 − L2 streckad med toppvärdet √3 gånger fasens"/>
+          <p:cNvPr id="11" name="Figur: Generatorn i 3D: tre spolar 120° isär oc" descr="Generatorn i 3D: tre spolar 120° isär och en roterande magnet som vrids medurs; bredvid kurvorna L1, L2 och L3 över 20 ms (50 Hz), 120° isär, med linjespänningen U12 = L1 − L2 streckad (toppvärde √3). Rotorns läge i bilden motsvarar 5 ms, då L1 har sitt toppvärde"/>
           <p:cNvPicPr>
             <a:picLocks noChangeAspect="1"/>
           </p:cNvPicPr>
           <p:nvPr/>
         </p:nvPicPr>
         <p:blipFill>
-          <a:blip r:embed="rId6"/>
+          <a:blip r:embed="rId7"/>
           <a:stretch>
             <a:fillRect/>
           </a:stretch>
@@ -17146,7 +17146,7 @@
         <p:spPr>
           <a:xfrm>
             <a:off x="914400" y="2395728"/>
-            <a:ext cx="7315200" cy="2333549"/>
+            <a:ext cx="7315200" cy="2332653"/>
           </a:xfrm>
           <a:prstGeom prst="rect">
             <a:avLst/>

</xml_diff>